<commit_message>
Use project name for presentation themes
</commit_message>
<xml_diff>
--- a/reports/presentation/phase1.pptx
+++ b/reports/presentation/phase1.pptx
@@ -172,9 +172,9 @@
 </file>
 
 <file path=ppt/notesMasters/theme/theme3.xml><?xml version="1.0" encoding="utf-8"?>
-<a:theme xmlns:a="http://schemas.openxmlformats.org/drawingml/2006/main" name="ChatGPT">
+<a:theme xmlns:a="http://schemas.openxmlformats.org/drawingml/2006/main" name="Inventory Image Tagging">
   <a:themeElements>
-    <a:clrScheme name="ChatGPT">
+    <a:clrScheme name="Inventory Image Tagging">
       <a:dk1>
         <a:srgbClr val="000000"/>
       </a:dk1>
@@ -224,7 +224,7 @@
         <a:cs typeface=""/>
       </a:minorFont>
     </a:fontScheme>
-    <a:fmtScheme name="ChatGPT">
+    <a:fmtScheme name="Inventory Image Tagging">
       <a:fillStyleLst>
         <a:solidFill>
           <a:schemeClr val="phClr"/>
@@ -4167,9 +4167,9 @@
 </file>
 
 <file path=ppt/slideMasters/theme/theme2.xml><?xml version="1.0" encoding="utf-8"?>
-<a:theme xmlns:a="http://schemas.openxmlformats.org/drawingml/2006/main" name="ChatGPT">
+<a:theme xmlns:a="http://schemas.openxmlformats.org/drawingml/2006/main" name="Inventory Image Tagging">
   <a:themeElements>
-    <a:clrScheme name="ChatGPT">
+    <a:clrScheme name="Inventory Image Tagging">
       <a:dk1>
         <a:srgbClr val="000000"/>
       </a:dk1>
@@ -4219,7 +4219,7 @@
         <a:cs typeface=""/>
       </a:minorFont>
     </a:fontScheme>
-    <a:fmtScheme name="ChatGPT">
+    <a:fmtScheme name="Inventory Image Tagging">
       <a:fillStyleLst>
         <a:solidFill>
           <a:schemeClr val="phClr"/>
@@ -19657,9 +19657,9 @@
 </file>
 
 <file path=ppt/theme/theme1.xml><?xml version="1.0" encoding="utf-8"?>
-<a:theme xmlns:a="http://schemas.openxmlformats.org/drawingml/2006/main" name="ChatGPT">
+<a:theme xmlns:a="http://schemas.openxmlformats.org/drawingml/2006/main" name="Inventory Image Tagging">
   <a:themeElements>
-    <a:clrScheme name="ChatGPT">
+    <a:clrScheme name="Inventory Image Tagging">
       <a:dk1>
         <a:srgbClr val="000000"/>
       </a:dk1>
@@ -19709,7 +19709,7 @@
         <a:cs typeface=""/>
       </a:minorFont>
     </a:fontScheme>
-    <a:fmtScheme name="ChatGPT">
+    <a:fmtScheme name="Inventory Image Tagging">
       <a:fillStyleLst>
         <a:solidFill>
           <a:schemeClr val="phClr"/>

</xml_diff>

<commit_message>
Limit Phase 1 to the eight required comparisons and update report and slides
</commit_message>
<xml_diff>
--- a/reports/presentation/phase1.pptx
+++ b/reports/presentation/phase1.pptx
@@ -2,27 +2,25 @@
 <file path=ppt/presentation.xml><?xml version="1.0" encoding="utf-8"?>
 <p:presentation xmlns:p="http://schemas.openxmlformats.org/presentationml/2006/main">
   <p:sldMasterIdLst>
-    <p:sldMasterId xmlns:r="http://schemas.openxmlformats.org/officeDocument/2006/relationships" id="2147483648" r:id="R99ed7896d52449bb"/>
+    <p:sldMasterId xmlns:r="http://schemas.openxmlformats.org/officeDocument/2006/relationships" id="2147483648" r:id="R437bae086ffd4702"/>
   </p:sldMasterIdLst>
   <p:notesMasterIdLst>
-    <p:notesMasterId xmlns:r="http://schemas.openxmlformats.org/officeDocument/2006/relationships" r:id="R83488fb3aed94898"/>
+    <p:notesMasterId xmlns:r="http://schemas.openxmlformats.org/officeDocument/2006/relationships" r:id="Re6ab03835349410e"/>
   </p:notesMasterIdLst>
   <p:sldIdLst>
-    <p:sldId xmlns:r="http://schemas.openxmlformats.org/officeDocument/2006/relationships" id="256" r:id="Rcd06130e3a0d49d5"/>
-    <p:sldId xmlns:r="http://schemas.openxmlformats.org/officeDocument/2006/relationships" id="257" r:id="R8a5df8bf25384c31"/>
-    <p:sldId xmlns:r="http://schemas.openxmlformats.org/officeDocument/2006/relationships" id="258" r:id="R2ec8482d28df410e"/>
-    <p:sldId xmlns:r="http://schemas.openxmlformats.org/officeDocument/2006/relationships" id="259" r:id="Rb6edd99d65ac4d14"/>
-    <p:sldId xmlns:r="http://schemas.openxmlformats.org/officeDocument/2006/relationships" id="260" r:id="R9abed787a4b0409a"/>
-    <p:sldId xmlns:r="http://schemas.openxmlformats.org/officeDocument/2006/relationships" id="261" r:id="R1228fe2f7c004934"/>
-    <p:sldId xmlns:r="http://schemas.openxmlformats.org/officeDocument/2006/relationships" id="262" r:id="R5726b6546a614edf"/>
-    <p:sldId xmlns:r="http://schemas.openxmlformats.org/officeDocument/2006/relationships" id="263" r:id="R97aa7685a4f94902"/>
-    <p:sldId xmlns:r="http://schemas.openxmlformats.org/officeDocument/2006/relationships" id="264" r:id="R7f2f3e886bc448da"/>
-    <p:sldId xmlns:r="http://schemas.openxmlformats.org/officeDocument/2006/relationships" id="265" r:id="Rbde069db71164cbb"/>
-    <p:sldId xmlns:r="http://schemas.openxmlformats.org/officeDocument/2006/relationships" id="266" r:id="R598d71d5d89c4975"/>
-    <p:sldId xmlns:r="http://schemas.openxmlformats.org/officeDocument/2006/relationships" id="267" r:id="R69b14fc000534df7"/>
-    <p:sldId xmlns:r="http://schemas.openxmlformats.org/officeDocument/2006/relationships" id="268" r:id="R461cb2105d1f4588"/>
-    <p:sldId xmlns:r="http://schemas.openxmlformats.org/officeDocument/2006/relationships" id="269" r:id="Rbd03e700a85a469e"/>
-    <p:sldId xmlns:r="http://schemas.openxmlformats.org/officeDocument/2006/relationships" id="270" r:id="R352405af55d54ffe"/>
+    <p:sldId xmlns:r="http://schemas.openxmlformats.org/officeDocument/2006/relationships" id="256" r:id="Reff35045baa548f2"/>
+    <p:sldId xmlns:r="http://schemas.openxmlformats.org/officeDocument/2006/relationships" id="257" r:id="R41a3f0e9b099450c"/>
+    <p:sldId xmlns:r="http://schemas.openxmlformats.org/officeDocument/2006/relationships" id="258" r:id="Reafb79ee17fe4163"/>
+    <p:sldId xmlns:r="http://schemas.openxmlformats.org/officeDocument/2006/relationships" id="259" r:id="R6e0341ddb9234a2a"/>
+    <p:sldId xmlns:r="http://schemas.openxmlformats.org/officeDocument/2006/relationships" id="260" r:id="Ra498995667484a2b"/>
+    <p:sldId xmlns:r="http://schemas.openxmlformats.org/officeDocument/2006/relationships" id="261" r:id="Rac7c50a64894432a"/>
+    <p:sldId xmlns:r="http://schemas.openxmlformats.org/officeDocument/2006/relationships" id="262" r:id="Rf4718f4e0cbd4ce8"/>
+    <p:sldId xmlns:r="http://schemas.openxmlformats.org/officeDocument/2006/relationships" id="263" r:id="R6f44caa97154421e"/>
+    <p:sldId xmlns:r="http://schemas.openxmlformats.org/officeDocument/2006/relationships" id="264" r:id="Re8fe01cf3a1c486d"/>
+    <p:sldId xmlns:r="http://schemas.openxmlformats.org/officeDocument/2006/relationships" id="265" r:id="Rb02d2ff119da4a73"/>
+    <p:sldId xmlns:r="http://schemas.openxmlformats.org/officeDocument/2006/relationships" id="266" r:id="R63c52a3696c34145"/>
+    <p:sldId xmlns:r="http://schemas.openxmlformats.org/officeDocument/2006/relationships" id="267" r:id="R685869b53e804b07"/>
+    <p:sldId xmlns:r="http://schemas.openxmlformats.org/officeDocument/2006/relationships" id="268" r:id="R7b9cebd451d64b8d"/>
   </p:sldIdLst>
   <p:sldSz cx="12192000" cy="6858000"/>
   <p:notesSz cx="6858000" cy="9144000"/>
@@ -526,7 +524,7 @@
           <a:lstStyle xmlns:a="http://schemas.openxmlformats.org/drawingml/2006/main"/>
           <a:p xmlns:a="http://schemas.openxmlformats.org/drawingml/2006/main">
             <a:r>
-              <a:t>Recall is the proportion of a true category that the model identifies correctly. Shirt recall is 71.4%, the lowest category recall. Bag recall is 98.6%. Each test category has 1,000 images, so these percentages have equal denominators. Source: reports/test/per_class.csv.</a:t>
+              <a:t>Recall is the proportion of a true category that the selected model identifies correctly. Each test category has 1,000 images. Values shown are read from the selected model rows in reports/test/per_class.csv.</a:t>
             </a:r>
           </a:p>
         </p:txBody>
@@ -666,7 +664,7 @@
           <a:lstStyle xmlns:a="http://schemas.openxmlformats.org/drawingml/2006/main"/>
           <a:p xmlns:a="http://schemas.openxmlformats.org/drawingml/2006/main">
             <a:r>
-              <a:t>We use the same CPU with two threads and warm each model before timing. There are 20 single-image repetitions, plus five repetitions over 1,024 images in batches of 128. Timing includes HOG, scaling and prediction, while excluding file decoding and model loading. Single-image p95 is 15.732 ms. Batch throughput is a separate measure. Sources: reports/test/results.csv and timing_repeats.csv.</a:t>
+              <a:t>We use the same CPU with two threads and warm each model before timing. There are 20 single-image repetitions, plus five repetitions over 1,024 images in batches of 128. Timing includes HOG, scaling and prediction, while excluding file decoding and model loading. Batch throughput is a separate measure. Sources: reports/test/results.csv and timing_repeats.csv.</a:t>
             </a:r>
           </a:p>
         </p:txBody>
@@ -737,146 +735,6 @@
           <a:p xmlns:a="http://schemas.openxmlformats.org/drawingml/2006/main">
             <a:r>
               <a:t>We use one split and a limited search. The public test benchmark also appeared in the supplied reference. We have not tested phone photos, new categories, near-duplicates, splits by product identity or calibration. Phase 2 should reuse the saved split for a CNN with two or three blocks, pooling and dropout. Validation should control early stopping. We will test architecture and regularization choices separately before comparing errors. Sources: report limitations and course Project 11 description.</a:t>
-            </a:r>
-          </a:p>
-        </p:txBody>
-      </p:sp>
-      <p:sp>
-        <p:nvSpPr>
-          <p:cNvPr id="4" name="Slide Number Placeholder 3"/>
-          <p:cNvSpPr>
-            <a:spLocks xmlns:a="http://schemas.openxmlformats.org/drawingml/2006/main" noGrp="1"/>
-          </p:cNvSpPr>
-          <p:nvPr>
-            <p:ph type="sldNum" idx="5"/>
-          </p:nvPr>
-        </p:nvSpPr>
-        <p:spPr/>
-        <p:txBody>
-          <a:bodyPr xmlns:a="http://schemas.openxmlformats.org/drawingml/2006/main"/>
-          <a:lstStyle xmlns:a="http://schemas.openxmlformats.org/drawingml/2006/main"/>
-          <a:p xmlns:a="http://schemas.openxmlformats.org/drawingml/2006/main"/>
-        </p:txBody>
-      </p:sp>
-    </p:spTree>
-  </p:cSld>
-  <p:clrMapOvr>
-    <a:masterClrMapping xmlns:a="http://schemas.openxmlformats.org/drawingml/2006/main"/>
-  </p:clrMapOvr>
-</p:notes>
-</file>
-
-<file path=ppt/notesSlides/notesSlide14.xml><?xml version="1.0" encoding="utf-8"?>
-<p:notes xmlns:p="http://schemas.openxmlformats.org/presentationml/2006/main">
-  <p:cSld>
-    <p:spTree>
-      <p:nvGrpSpPr>
-        <p:cNvPr id="1" name=""/>
-        <p:cNvGrpSpPr/>
-        <p:nvPr/>
-      </p:nvGrpSpPr>
-      <p:grpSpPr>
-        <a:xfrm xmlns:a="http://schemas.openxmlformats.org/drawingml/2006/main"/>
-      </p:grpSpPr>
-      <p:sp>
-        <p:nvSpPr>
-          <p:cNvPr id="2" name="Slide Image Placeholder 1"/>
-          <p:cNvSpPr>
-            <a:spLocks xmlns:a="http://schemas.openxmlformats.org/drawingml/2006/main" noGrp="1"/>
-          </p:cNvSpPr>
-          <p:nvPr>
-            <p:ph type="sldImg" idx="0"/>
-          </p:nvPr>
-        </p:nvSpPr>
-        <p:spPr/>
-      </p:sp>
-      <p:sp>
-        <p:nvSpPr>
-          <p:cNvPr id="3" name="Notes Placeholder 2"/>
-          <p:cNvSpPr>
-            <a:spLocks xmlns:a="http://schemas.openxmlformats.org/drawingml/2006/main" noGrp="1"/>
-          </p:cNvSpPr>
-          <p:nvPr>
-            <p:ph type="body" idx="1"/>
-          </p:nvPr>
-        </p:nvSpPr>
-        <p:spPr/>
-        <p:txBody>
-          <a:bodyPr xmlns:a="http://schemas.openxmlformats.org/drawingml/2006/main"/>
-          <a:lstStyle xmlns:a="http://schemas.openxmlformats.org/drawingml/2006/main"/>
-          <a:p xmlns:a="http://schemas.openxmlformats.org/drawingml/2006/main">
-            <a:r>
-              <a:t>The reproduction script runs the full experiment in a separate directory, preserving the reported outputs. A fresh clone needs local data and fitted models. The uv wrapper handles the colon in our current folder path. Use the notebook to follow the results and the viva guide to practise explaining each stage. Sources: README.md and docs/viva_guide.md.</a:t>
-            </a:r>
-          </a:p>
-        </p:txBody>
-      </p:sp>
-      <p:sp>
-        <p:nvSpPr>
-          <p:cNvPr id="4" name="Slide Number Placeholder 3"/>
-          <p:cNvSpPr>
-            <a:spLocks xmlns:a="http://schemas.openxmlformats.org/drawingml/2006/main" noGrp="1"/>
-          </p:cNvSpPr>
-          <p:nvPr>
-            <p:ph type="sldNum" idx="5"/>
-          </p:nvPr>
-        </p:nvSpPr>
-        <p:spPr/>
-        <p:txBody>
-          <a:bodyPr xmlns:a="http://schemas.openxmlformats.org/drawingml/2006/main"/>
-          <a:lstStyle xmlns:a="http://schemas.openxmlformats.org/drawingml/2006/main"/>
-          <a:p xmlns:a="http://schemas.openxmlformats.org/drawingml/2006/main"/>
-        </p:txBody>
-      </p:sp>
-    </p:spTree>
-  </p:cSld>
-  <p:clrMapOvr>
-    <a:masterClrMapping xmlns:a="http://schemas.openxmlformats.org/drawingml/2006/main"/>
-  </p:clrMapOvr>
-</p:notes>
-</file>
-
-<file path=ppt/notesSlides/notesSlide15.xml><?xml version="1.0" encoding="utf-8"?>
-<p:notes xmlns:p="http://schemas.openxmlformats.org/presentationml/2006/main">
-  <p:cSld>
-    <p:spTree>
-      <p:nvGrpSpPr>
-        <p:cNvPr id="1" name=""/>
-        <p:cNvGrpSpPr/>
-        <p:nvPr/>
-      </p:nvGrpSpPr>
-      <p:grpSpPr>
-        <a:xfrm xmlns:a="http://schemas.openxmlformats.org/drawingml/2006/main"/>
-      </p:grpSpPr>
-      <p:sp>
-        <p:nvSpPr>
-          <p:cNvPr id="2" name="Slide Image Placeholder 1"/>
-          <p:cNvSpPr>
-            <a:spLocks xmlns:a="http://schemas.openxmlformats.org/drawingml/2006/main" noGrp="1"/>
-          </p:cNvSpPr>
-          <p:nvPr>
-            <p:ph type="sldImg" idx="0"/>
-          </p:nvPr>
-        </p:nvSpPr>
-        <p:spPr/>
-      </p:sp>
-      <p:sp>
-        <p:nvSpPr>
-          <p:cNvPr id="3" name="Notes Placeholder 2"/>
-          <p:cNvSpPr>
-            <a:spLocks xmlns:a="http://schemas.openxmlformats.org/drawingml/2006/main" noGrp="1"/>
-          </p:cNvSpPr>
-          <p:nvPr>
-            <p:ph type="body" idx="1"/>
-          </p:nvPr>
-        </p:nvSpPr>
-        <p:spPr/>
-        <p:txBody>
-          <a:bodyPr xmlns:a="http://schemas.openxmlformats.org/drawingml/2006/main"/>
-          <a:lstStyle xmlns:a="http://schemas.openxmlformats.org/drawingml/2006/main"/>
-          <a:p xmlns:a="http://schemas.openxmlformats.org/drawingml/2006/main">
-            <a:r>
-              <a:t>The five names and enrolment numbers come from the roster supplied on 23 October 2026. Add the course section and formal affiliation before submission. Record each member's actual contribution, and make sure everyone can explain the complete workflow. Source: docs/team.md.</a:t>
             </a:r>
           </a:p>
         </p:txBody>
@@ -1156,7 +1014,7 @@
           <a:lstStyle xmlns:a="http://schemas.openxmlformats.org/drawingml/2006/main"/>
           <a:p xmlns:a="http://schemas.openxmlformats.org/drawingml/2006/main">
             <a:r>
-              <a:t>Flattening keeps every pixel value, so reshaping recovers the image. HOG summarizes edge directions within cells, then normalizes nearby cells in blocks. Its rules are fixed and use no category labels. Both versions use nine direction bins and 2x2-cell blocks. Sources: features.py and https://scikit-image.org/docs/stable/auto_examples/features_detection/plot_hog.html .</a:t>
+              <a:t>Flattening keeps every pixel value, so reshaping recovers the image. HOG summarizes edge directions within cells, then normalizes nearby cells in blocks. Its rules are fixed and use no category labels. HOG uses nine direction bins and 2x2-cell blocks. Sources: features.py and https://scikit-image.org/docs/stable/auto_examples/features_detection/plot_hog.html .</a:t>
             </a:r>
           </a:p>
         </p:txBody>
@@ -1226,7 +1084,7 @@
           <a:lstStyle xmlns:a="http://schemas.openxmlformats.org/drawingml/2006/main"/>
           <a:p xmlns:a="http://schemas.openxmlformats.org/drawingml/2006/main">
             <a:r>
-              <a:t>We train each of four classifier families on pixels and coarse HOG. Logistic Regression uses StandardScaler fitted only on training features. Linear SVM uses normalized features directly, with tolerance 1e-3 and max_iter 2,000. The forest settings pair 200 trees with depth 25, and 400 trees with unrestricted depth. Sources: models.py and train.py.</a:t>
+              <a:t>We train each of four classifier families on pixels and HOG. Logistic Regression uses StandardScaler fitted only on training features. Linear SVM uses normalized features directly, with tolerance 1e-3 and max_iter 2,000. The forest settings pair 200 trees with depth 25, and 400 trees with unrestricted depth. Sources: models.py and train.py.</a:t>
             </a:r>
           </a:p>
         </p:txBody>
@@ -1296,7 +1154,7 @@
           <a:lstStyle xmlns:a="http://schemas.openxmlformats.org/drawingml/2006/main"/>
           <a:p xmlns:a="http://schemas.openxmlformats.org/drawingml/2006/main">
             <a:r>
-              <a:t>We try two settings for each combination and reject candidates with convergence warnings. Validation macro F1 selects the retained candidate, with accuracy breaking ties. Additional RBF runs test C values 3 and 10 on pixels, coarse HOG and fine HOG. Changing both the classifier and descriptor prevents us from attributing a gain to just one factor. We save model hashes before test evaluation. Sources: reports/training/*_trials.json and reports/frozen.json.</a:t>
+              <a:t>Each of the eight combinations tries two settings. We reject candidates with convergence warnings. Validation macro F1 selects the retained candidate, with accuracy breaking ties. We select the overall model using the same validation rule, then freeze choices and file hashes before opening the test set. Sources: reports/training/*_trials.json and reports/frozen.json.</a:t>
             </a:r>
           </a:p>
         </p:txBody>
@@ -1436,7 +1294,7 @@
           <a:lstStyle xmlns:a="http://schemas.openxmlformats.org/drawingml/2006/main"/>
           <a:p xmlns:a="http://schemas.openxmlformats.org/drawingml/2006/main">
             <a:r>
-              <a:t>Validation selected fine HOG with RBF SVM using C=3 and gamma=scale. Its validation accuracy is 91.36%. On the official test set, accuracy is 90.87% and macro F1 is 0.9084. These results apply to Fashion-MNIST. The reference used 12,000 training images and reported 85.27% for its best classical model. We changed training size and settings, so the difference cannot isolate either effect. Sources: reports/frozen.json, reports/test/results.csv and the supplied reference.</a:t>
+              <a:t>Validation selects pixel Random Forest from the eight combinations. It uses 400 trees with unrestricted depth. All result values shown come from reports/test/results.csv. Confusion rows are true categories and columns are model predictions. The model choice was saved before final test evaluation.</a:t>
             </a:r>
           </a:p>
         </p:txBody>
@@ -1483,7 +1341,7 @@
           <p:cNvPr id="3" name="Title">
             <a:extLst xmlns:a="http://schemas.openxmlformats.org/drawingml/2006/main">
               <a:ext uri="{FF2B5EF4-FFF2-40B4-BE49-F238E27FC236}">
-                <a16:creationId xmlns:a16="http://schemas.microsoft.com/office/drawing/2014/main" id="{0081B69D-3DFD-463A-827F-34B8EE084868}"/>
+                <a16:creationId xmlns:a16="http://schemas.microsoft.com/office/drawing/2014/main" id="{A222985D-AECB-4484-8204-98A50B6146FA}"/>
               </a:ext>
             </a:extLst>
           </p:cNvPr>
@@ -1712,7 +1570,7 @@
           <p:cNvPr id="2" name="Subtitle">
             <a:extLst xmlns:a="http://schemas.openxmlformats.org/drawingml/2006/main">
               <a:ext uri="{FF2B5EF4-FFF2-40B4-BE49-F238E27FC236}">
-                <a16:creationId xmlns:a16="http://schemas.microsoft.com/office/drawing/2014/main" id="{319175A1-088E-4F6E-A54A-6B324D5BE15E}"/>
+                <a16:creationId xmlns:a16="http://schemas.microsoft.com/office/drawing/2014/main" id="{DD9BC63A-3391-45A3-A12D-F742BB30131C}"/>
               </a:ext>
             </a:extLst>
           </p:cNvPr>
@@ -1958,7 +1816,7 @@
           <p:cNvPr id="2" name="Section title">
             <a:extLst xmlns:a="http://schemas.openxmlformats.org/drawingml/2006/main">
               <a:ext uri="{FF2B5EF4-FFF2-40B4-BE49-F238E27FC236}">
-                <a16:creationId xmlns:a16="http://schemas.microsoft.com/office/drawing/2014/main" id="{1B0EE243-B0F7-4CFE-A945-06EB97805ABF}"/>
+                <a16:creationId xmlns:a16="http://schemas.microsoft.com/office/drawing/2014/main" id="{8F0234AA-60CF-4F6A-A6EF-E99302D3AE38}"/>
               </a:ext>
             </a:extLst>
           </p:cNvPr>
@@ -2204,7 +2062,7 @@
           <p:cNvPr id="3" name="Title">
             <a:extLst xmlns:a="http://schemas.openxmlformats.org/drawingml/2006/main">
               <a:ext uri="{FF2B5EF4-FFF2-40B4-BE49-F238E27FC236}">
-                <a16:creationId xmlns:a16="http://schemas.microsoft.com/office/drawing/2014/main" id="{9ADB6550-4F70-4826-99B1-01D39C796B29}"/>
+                <a16:creationId xmlns:a16="http://schemas.microsoft.com/office/drawing/2014/main" id="{EE2DE53A-4A6A-4989-AB4B-813DE982DB5A}"/>
               </a:ext>
             </a:extLst>
           </p:cNvPr>
@@ -2433,7 +2291,7 @@
           <p:cNvPr id="2" name="Body">
             <a:extLst xmlns:a="http://schemas.openxmlformats.org/drawingml/2006/main">
               <a:ext uri="{FF2B5EF4-FFF2-40B4-BE49-F238E27FC236}">
-                <a16:creationId xmlns:a16="http://schemas.microsoft.com/office/drawing/2014/main" id="{E7DA28C8-1EBF-4501-A18F-31B30114F05F}"/>
+                <a16:creationId xmlns:a16="http://schemas.microsoft.com/office/drawing/2014/main" id="{66D54662-980D-483B-BFD0-96456BBABC1E}"/>
               </a:ext>
             </a:extLst>
           </p:cNvPr>
@@ -2679,7 +2537,7 @@
           <p:cNvPr id="4" name="Title">
             <a:extLst xmlns:a="http://schemas.openxmlformats.org/drawingml/2006/main">
               <a:ext uri="{FF2B5EF4-FFF2-40B4-BE49-F238E27FC236}">
-                <a16:creationId xmlns:a16="http://schemas.microsoft.com/office/drawing/2014/main" id="{8892C8A6-194B-419E-BC11-9A1FBF9529CE}"/>
+                <a16:creationId xmlns:a16="http://schemas.microsoft.com/office/drawing/2014/main" id="{0139B9F9-95F3-4752-9F40-AEAB9090893D}"/>
               </a:ext>
             </a:extLst>
           </p:cNvPr>
@@ -2908,7 +2766,7 @@
           <p:cNvPr id="2" name="Left column">
             <a:extLst xmlns:a="http://schemas.openxmlformats.org/drawingml/2006/main">
               <a:ext uri="{FF2B5EF4-FFF2-40B4-BE49-F238E27FC236}">
-                <a16:creationId xmlns:a16="http://schemas.microsoft.com/office/drawing/2014/main" id="{E0DE3E45-A490-4E94-8408-CC415A4E883F}"/>
+                <a16:creationId xmlns:a16="http://schemas.microsoft.com/office/drawing/2014/main" id="{AF79E453-B089-4A2A-80AF-D2A15E8B1B4E}"/>
               </a:ext>
             </a:extLst>
           </p:cNvPr>
@@ -3137,7 +2995,7 @@
           <p:cNvPr id="3" name="Right column">
             <a:extLst xmlns:a="http://schemas.openxmlformats.org/drawingml/2006/main">
               <a:ext uri="{FF2B5EF4-FFF2-40B4-BE49-F238E27FC236}">
-                <a16:creationId xmlns:a16="http://schemas.microsoft.com/office/drawing/2014/main" id="{47E4D8E2-0939-4EEE-AB4B-A50BDE19F234}"/>
+                <a16:creationId xmlns:a16="http://schemas.microsoft.com/office/drawing/2014/main" id="{AE46A08A-4F23-4B53-B8C5-601E754EE029}"/>
               </a:ext>
             </a:extLst>
           </p:cNvPr>
@@ -3383,7 +3241,7 @@
           <p:cNvPr id="3" name="Title">
             <a:extLst xmlns:a="http://schemas.openxmlformats.org/drawingml/2006/main">
               <a:ext uri="{FF2B5EF4-FFF2-40B4-BE49-F238E27FC236}">
-                <a16:creationId xmlns:a16="http://schemas.microsoft.com/office/drawing/2014/main" id="{6A71C93A-F6CB-43FA-ACDC-DCFBE9F0436C}"/>
+                <a16:creationId xmlns:a16="http://schemas.microsoft.com/office/drawing/2014/main" id="{87DD8350-3B8E-4D00-A94A-D11AAACD2D83}"/>
               </a:ext>
             </a:extLst>
           </p:cNvPr>
@@ -3612,7 +3470,7 @@
           <p:cNvPr id="2" name="Left column">
             <a:extLst xmlns:a="http://schemas.openxmlformats.org/drawingml/2006/main">
               <a:ext uri="{FF2B5EF4-FFF2-40B4-BE49-F238E27FC236}">
-                <a16:creationId xmlns:a16="http://schemas.microsoft.com/office/drawing/2014/main" id="{58050C2D-CEB8-4FC1-88B1-3CB27D545202}"/>
+                <a16:creationId xmlns:a16="http://schemas.microsoft.com/office/drawing/2014/main" id="{7BE6B30C-9075-4BA7-8161-7955519DE58E}"/>
               </a:ext>
             </a:extLst>
           </p:cNvPr>
@@ -3879,12 +3737,12 @@
   </p:cSld>
   <p:clrMap bg1="lt1" tx1="dk1" bg2="lt2" tx2="dk2" accent1="accent1" accent2="accent2" accent3="accent3" accent4="accent4" accent5="accent5" accent6="accent6" hlink="hlink" folHlink="folHlink"/>
   <p:sldLayoutIdLst>
-    <p:sldLayoutId xmlns:r="http://schemas.openxmlformats.org/officeDocument/2006/relationships" id="2147483649" r:id="R3f5704c491494820"/>
-    <p:sldLayoutId xmlns:r="http://schemas.openxmlformats.org/officeDocument/2006/relationships" id="2147483650" r:id="R8469aa98cec44752"/>
-    <p:sldLayoutId xmlns:r="http://schemas.openxmlformats.org/officeDocument/2006/relationships" id="2147483651" r:id="Refb961802d5842e0"/>
-    <p:sldLayoutId xmlns:r="http://schemas.openxmlformats.org/officeDocument/2006/relationships" id="2147483652" r:id="Rb837a11aa2c34b5d"/>
-    <p:sldLayoutId xmlns:r="http://schemas.openxmlformats.org/officeDocument/2006/relationships" id="2147483653" r:id="R2030ed6978424364"/>
-    <p:sldLayoutId xmlns:r="http://schemas.openxmlformats.org/officeDocument/2006/relationships" id="2147483654" r:id="Read7d27759f54faf"/>
+    <p:sldLayoutId xmlns:r="http://schemas.openxmlformats.org/officeDocument/2006/relationships" id="2147483649" r:id="R02d06c4c88c840ca"/>
+    <p:sldLayoutId xmlns:r="http://schemas.openxmlformats.org/officeDocument/2006/relationships" id="2147483650" r:id="Rcc6b7e6a56ca4865"/>
+    <p:sldLayoutId xmlns:r="http://schemas.openxmlformats.org/officeDocument/2006/relationships" id="2147483651" r:id="Rf7cef8956ac84d44"/>
+    <p:sldLayoutId xmlns:r="http://schemas.openxmlformats.org/officeDocument/2006/relationships" id="2147483652" r:id="R6d14ba20aba44f3b"/>
+    <p:sldLayoutId xmlns:r="http://schemas.openxmlformats.org/officeDocument/2006/relationships" id="2147483653" r:id="R7d8b8f4abc5040e2"/>
+    <p:sldLayoutId xmlns:r="http://schemas.openxmlformats.org/officeDocument/2006/relationships" id="2147483654" r:id="Rcddfdc2b16fd4c34"/>
   </p:sldLayoutIdLst>
   <p:txStyles>
     <p:titleStyle>
@@ -4477,34 +4335,34 @@
                 <c:formatCode>General</c:formatCode>
                 <c:ptCount val="10"/>
                 <c:pt idx="0">
-                  <c:v>85.9</c:v>
+                  <c:v>85.2</c:v>
                 </c:pt>
                 <c:pt idx="1">
-                  <c:v>97.8</c:v>
+                  <c:v>95.9</c:v>
                 </c:pt>
                 <c:pt idx="2">
-                  <c:v>86.2</c:v>
+                  <c:v>80.2</c:v>
                 </c:pt>
                 <c:pt idx="3">
-                  <c:v>91.9</c:v>
+                  <c:v>91</c:v>
                 </c:pt>
                 <c:pt idx="4">
-                  <c:v>87.1</c:v>
+                  <c:v>82.2</c:v>
                 </c:pt>
                 <c:pt idx="5">
-                  <c:v>96.7</c:v>
+                  <c:v>95.4</c:v>
                 </c:pt>
                 <c:pt idx="6">
-                  <c:v>71.4</c:v>
+                  <c:v>59.2</c:v>
                 </c:pt>
                 <c:pt idx="7">
-                  <c:v>96.9</c:v>
+                  <c:v>94.7</c:v>
                 </c:pt>
                 <c:pt idx="8">
-                  <c:v>98.6</c:v>
+                  <c:v>97.5</c:v>
                 </c:pt>
                 <c:pt idx="9">
-                  <c:v>96.2</c:v>
+                  <c:v>94.8</c:v>
                 </c:pt>
               </c:numCache>
             </c:numRef>
@@ -4675,7 +4533,7 @@
           <p:cNvPr id="7" name="">
             <a:extLst xmlns:a="http://schemas.openxmlformats.org/drawingml/2006/main">
               <a:ext uri="{FF2B5EF4-FFF2-40B4-BE49-F238E27FC236}">
-                <a16:creationId xmlns:a16="http://schemas.microsoft.com/office/drawing/2014/main" id="{78831972-7D11-4CF3-ADFA-94880A8D0323}"/>
+                <a16:creationId xmlns:a16="http://schemas.microsoft.com/office/drawing/2014/main" id="{30574747-AABD-4D91-8BD3-32512D76C0F0}"/>
               </a:ext>
             </a:extLst>
           </p:cNvPr>
@@ -4831,7 +4689,7 @@
           <p:cNvPr id="2" name="">
             <a:extLst xmlns:a="http://schemas.openxmlformats.org/drawingml/2006/main">
               <a:ext uri="{FF2B5EF4-FFF2-40B4-BE49-F238E27FC236}">
-                <a16:creationId xmlns:a16="http://schemas.microsoft.com/office/drawing/2014/main" id="{54350EBD-A752-4A84-85BB-0A809C036EFE}"/>
+                <a16:creationId xmlns:a16="http://schemas.microsoft.com/office/drawing/2014/main" id="{76000A23-3CE8-4F1B-9173-4BCF0F115229}"/>
               </a:ext>
             </a:extLst>
           </p:cNvPr>
@@ -4987,7 +4845,7 @@
           <p:cNvPr id="3" name="">
             <a:extLst xmlns:a="http://schemas.openxmlformats.org/drawingml/2006/main">
               <a:ext uri="{FF2B5EF4-FFF2-40B4-BE49-F238E27FC236}">
-                <a16:creationId xmlns:a16="http://schemas.microsoft.com/office/drawing/2014/main" id="{0D7577AA-7477-4565-8D41-933B95CADC3D}"/>
+                <a16:creationId xmlns:a16="http://schemas.microsoft.com/office/drawing/2014/main" id="{B0017F95-71CA-4F2A-8923-57D58C7770C8}"/>
               </a:ext>
             </a:extLst>
           </p:cNvPr>
@@ -5143,7 +5001,7 @@
           <p:cNvPr id="4" name="">
             <a:extLst xmlns:a="http://schemas.openxmlformats.org/drawingml/2006/main">
               <a:ext uri="{FF2B5EF4-FFF2-40B4-BE49-F238E27FC236}">
-                <a16:creationId xmlns:a16="http://schemas.microsoft.com/office/drawing/2014/main" id="{333E8F30-064D-4DDE-9639-59AC38582D36}"/>
+                <a16:creationId xmlns:a16="http://schemas.microsoft.com/office/drawing/2014/main" id="{E580A82F-C5C0-44AD-A78D-1055356553B1}"/>
               </a:ext>
             </a:extLst>
           </p:cNvPr>
@@ -5322,7 +5180,7 @@
           <p:cNvPr id="5" name="">
             <a:extLst xmlns:a="http://schemas.openxmlformats.org/drawingml/2006/main">
               <a:ext uri="{FF2B5EF4-FFF2-40B4-BE49-F238E27FC236}">
-                <a16:creationId xmlns:a16="http://schemas.microsoft.com/office/drawing/2014/main" id="{6FE01476-E949-467B-856B-F8A3E2B49AC6}"/>
+                <a16:creationId xmlns:a16="http://schemas.microsoft.com/office/drawing/2014/main" id="{56537D15-7FA6-4367-9460-E4B9B0B9015D}"/>
               </a:ext>
             </a:extLst>
           </p:cNvPr>
@@ -5478,7 +5336,7 @@
           <p:cNvPr id="6" name="">
             <a:extLst xmlns:a="http://schemas.openxmlformats.org/drawingml/2006/main">
               <a:ext uri="{FF2B5EF4-FFF2-40B4-BE49-F238E27FC236}">
-                <a16:creationId xmlns:a16="http://schemas.microsoft.com/office/drawing/2014/main" id="{1F65CE5A-9758-489A-B54E-9E377C55584B}"/>
+                <a16:creationId xmlns:a16="http://schemas.microsoft.com/office/drawing/2014/main" id="{2D647A47-B3EC-47DF-9CDD-AD0B6F86B88A}"/>
               </a:ext>
             </a:extLst>
           </p:cNvPr>
@@ -5655,7 +5513,7 @@
     </p:spTree>
     <p:extLst>
       <p:ext uri="{BB962C8B-B14F-4D97-AF65-F5344CB8AC3E}">
-        <p14:creationId xmlns:p14="http://schemas.microsoft.com/office/powerpoint/2010/main" val="1656233421"/>
+        <p14:creationId xmlns:p14="http://schemas.microsoft.com/office/powerpoint/2010/main" val="944690110"/>
       </p:ext>
     </p:extLst>
   </p:cSld>
@@ -5686,7 +5544,7 @@
           <p:cNvPr id="5" name="">
             <a:extLst xmlns:a="http://schemas.openxmlformats.org/drawingml/2006/main">
               <a:ext uri="{FF2B5EF4-FFF2-40B4-BE49-F238E27FC236}">
-                <a16:creationId xmlns:a16="http://schemas.microsoft.com/office/drawing/2014/main" id="{6846C365-1DFF-4A0C-B6CF-58C40A514081}"/>
+                <a16:creationId xmlns:a16="http://schemas.microsoft.com/office/drawing/2014/main" id="{B0E2DC0F-A556-42ED-9F5E-3C6DB3D652CB}"/>
               </a:ext>
             </a:extLst>
           </p:cNvPr>
@@ -5842,7 +5700,7 @@
           <p:cNvPr id="2" name="">
             <a:extLst xmlns:a="http://schemas.openxmlformats.org/drawingml/2006/main">
               <a:ext uri="{FF2B5EF4-FFF2-40B4-BE49-F238E27FC236}">
-                <a16:creationId xmlns:a16="http://schemas.microsoft.com/office/drawing/2014/main" id="{5730D960-DCC4-4A39-BDB8-1C5F177E6787}"/>
+                <a16:creationId xmlns:a16="http://schemas.microsoft.com/office/drawing/2014/main" id="{73625DA4-D90C-4E73-B402-B4625D8E7114}"/>
               </a:ext>
             </a:extLst>
           </p:cNvPr>
@@ -5998,7 +5856,7 @@
           <p:cNvPr id="3" name="">
             <a:extLst xmlns:a="http://schemas.openxmlformats.org/drawingml/2006/main">
               <a:ext uri="{FF2B5EF4-FFF2-40B4-BE49-F238E27FC236}">
-                <a16:creationId xmlns:a16="http://schemas.microsoft.com/office/drawing/2014/main" id="{6561C342-13BA-4C6D-A1AA-052CC24D22CE}"/>
+                <a16:creationId xmlns:a16="http://schemas.microsoft.com/office/drawing/2014/main" id="{E80BB18E-C491-414B-AAED-8799D9E5D641}"/>
               </a:ext>
             </a:extLst>
           </p:cNvPr>
@@ -6154,7 +6012,7 @@
           <p:cNvPr id="4" name="Chart">
             <a:extLst xmlns:a="http://schemas.openxmlformats.org/drawingml/2006/main">
               <a:ext uri="{FF2B5EF4-FFF2-40B4-BE49-F238E27FC236}">
-                <a16:creationId xmlns:a16="http://schemas.microsoft.com/office/drawing/2014/main" id="{5E65C6F2-3591-4A74-A115-179D254E5AEC}"/>
+                <a16:creationId xmlns:a16="http://schemas.microsoft.com/office/drawing/2014/main" id="{FBB381BD-6F20-496E-8645-70262DBE20A0}"/>
               </a:ext>
             </a:extLst>
           </p:cNvPr>
@@ -6167,14 +6025,14 @@
         </p:xfrm>
         <a:graphic xmlns:a="http://schemas.openxmlformats.org/drawingml/2006/main">
           <a:graphicData uri="http://schemas.openxmlformats.org/drawingml/2006/chart">
-            <c:chart xmlns:r="http://schemas.openxmlformats.org/officeDocument/2006/relationships" xmlns:c="http://schemas.openxmlformats.org/drawingml/2006/chart" r:id="Rd474d94c73664703"/>
+            <c:chart xmlns:r="http://schemas.openxmlformats.org/officeDocument/2006/relationships" xmlns:c="http://schemas.openxmlformats.org/drawingml/2006/chart" r:id="Ree6cdb4e28cf428f"/>
           </a:graphicData>
         </a:graphic>
       </p:graphicFrame>
     </p:spTree>
     <p:extLst>
       <p:ext uri="{BB962C8B-B14F-4D97-AF65-F5344CB8AC3E}">
-        <p14:creationId xmlns:p14="http://schemas.microsoft.com/office/powerpoint/2010/main" val="2147345673"/>
+        <p14:creationId xmlns:p14="http://schemas.microsoft.com/office/powerpoint/2010/main" val="46770147"/>
       </p:ext>
     </p:extLst>
   </p:cSld>
@@ -6205,7 +6063,7 @@
           <p:cNvPr id="8" name="">
             <a:extLst xmlns:a="http://schemas.openxmlformats.org/drawingml/2006/main">
               <a:ext uri="{FF2B5EF4-FFF2-40B4-BE49-F238E27FC236}">
-                <a16:creationId xmlns:a16="http://schemas.microsoft.com/office/drawing/2014/main" id="{4932590E-AAD0-4AC9-8E6F-6EE0DC848E5B}"/>
+                <a16:creationId xmlns:a16="http://schemas.microsoft.com/office/drawing/2014/main" id="{37CD76D7-D4B1-45FB-9AC7-72480D94DB33}"/>
               </a:ext>
             </a:extLst>
           </p:cNvPr>
@@ -6361,7 +6219,7 @@
           <p:cNvPr id="2" name="">
             <a:extLst xmlns:a="http://schemas.openxmlformats.org/drawingml/2006/main">
               <a:ext uri="{FF2B5EF4-FFF2-40B4-BE49-F238E27FC236}">
-                <a16:creationId xmlns:a16="http://schemas.microsoft.com/office/drawing/2014/main" id="{74AF57C9-8842-4FC8-9BD8-AB58B1CD86CF}"/>
+                <a16:creationId xmlns:a16="http://schemas.microsoft.com/office/drawing/2014/main" id="{9A6AB95B-2EB2-4B8D-9C55-C61729E83139}"/>
               </a:ext>
             </a:extLst>
           </p:cNvPr>
@@ -6517,7 +6375,7 @@
           <p:cNvPr id="3" name="">
             <a:extLst xmlns:a="http://schemas.openxmlformats.org/drawingml/2006/main">
               <a:ext uri="{FF2B5EF4-FFF2-40B4-BE49-F238E27FC236}">
-                <a16:creationId xmlns:a16="http://schemas.microsoft.com/office/drawing/2014/main" id="{8CA8F8A5-DB6A-45FE-8F8C-D37785097E11}"/>
+                <a16:creationId xmlns:a16="http://schemas.microsoft.com/office/drawing/2014/main" id="{67AA6A68-1095-4A4E-804F-3DFCA2D2871B}"/>
               </a:ext>
             </a:extLst>
           </p:cNvPr>
@@ -6673,7 +6531,7 @@
           <p:cNvPr id="4" name="">
             <a:extLst xmlns:a="http://schemas.openxmlformats.org/drawingml/2006/main">
               <a:ext uri="{FF2B5EF4-FFF2-40B4-BE49-F238E27FC236}">
-                <a16:creationId xmlns:a16="http://schemas.microsoft.com/office/drawing/2014/main" id="{0C437C70-BEBB-4363-86BB-C1AC612C30E8}"/>
+                <a16:creationId xmlns:a16="http://schemas.microsoft.com/office/drawing/2014/main" id="{57563DC1-D392-43B0-93D3-941B735BC4D3}"/>
               </a:ext>
             </a:extLst>
           </p:cNvPr>
@@ -6683,7 +6541,7 @@
           <p:nvPr/>
         </p:nvPicPr>
         <p:blipFill>
-          <a:blip xmlns:r="http://schemas.openxmlformats.org/officeDocument/2006/relationships" xmlns:a="http://schemas.openxmlformats.org/drawingml/2006/main" r:embed="Rdfa93f6f7c4f44b6"/>
+          <a:blip xmlns:r="http://schemas.openxmlformats.org/officeDocument/2006/relationships" xmlns:a="http://schemas.openxmlformats.org/drawingml/2006/main" r:embed="R6490ce2091f04db0"/>
           <a:stretch xmlns:a="http://schemas.openxmlformats.org/drawingml/2006/main"/>
         </p:blipFill>
         <p:spPr>
@@ -6701,7 +6559,7 @@
           <p:cNvPr id="5" name="">
             <a:extLst xmlns:a="http://schemas.openxmlformats.org/drawingml/2006/main">
               <a:ext uri="{FF2B5EF4-FFF2-40B4-BE49-F238E27FC236}">
-                <a16:creationId xmlns:a16="http://schemas.microsoft.com/office/drawing/2014/main" id="{1893E765-5DB4-4ADA-B929-F9156DE5DA8B}"/>
+                <a16:creationId xmlns:a16="http://schemas.microsoft.com/office/drawing/2014/main" id="{FD4837A5-9E9E-45DF-9DF4-3D3A8D794A40}"/>
               </a:ext>
             </a:extLst>
           </p:cNvPr>
@@ -6870,7 +6728,7 @@
                 <a:ea typeface="Helvetica Neue"/>
                 <a:cs typeface="Helvetica Neue"/>
               </a:rPr>
-              <a:t>116 errors</a:t>
+              <a:t>149 errors</a:t>
             </a:r>
           </a:p>
         </p:txBody>
@@ -6880,7 +6738,7 @@
           <p:cNvPr id="6" name="">
             <a:extLst xmlns:a="http://schemas.openxmlformats.org/drawingml/2006/main">
               <a:ext uri="{FF2B5EF4-FFF2-40B4-BE49-F238E27FC236}">
-                <a16:creationId xmlns:a16="http://schemas.microsoft.com/office/drawing/2014/main" id="{9B72DDB3-F8E4-4A1E-8997-F4AFBA83A910}"/>
+                <a16:creationId xmlns:a16="http://schemas.microsoft.com/office/drawing/2014/main" id="{6642100A-49E6-4647-96AF-47A3A3B42A50}"/>
               </a:ext>
             </a:extLst>
           </p:cNvPr>
@@ -7026,7 +6884,7 @@
                 <a:ea typeface="Helvetica Neue"/>
                 <a:cs typeface="Helvetica Neue"/>
               </a:rPr>
-              <a:t>T-shirt/top as Shirt</a:t>
+              <a:t>Shirt as Pullover</a:t>
             </a:r>
           </a:p>
           <a:p xmlns:a="http://schemas.openxmlformats.org/drawingml/2006/main">
@@ -7049,7 +6907,7 @@
                 <a:ea typeface="Helvetica Neue"/>
                 <a:cs typeface="Helvetica Neue"/>
               </a:rPr>
-              <a:t>102 errors</a:t>
+              <a:t>124 errors</a:t>
             </a:r>
           </a:p>
         </p:txBody>
@@ -7059,7 +6917,7 @@
           <p:cNvPr id="7" name="">
             <a:extLst xmlns:a="http://schemas.openxmlformats.org/drawingml/2006/main">
               <a:ext uri="{FF2B5EF4-FFF2-40B4-BE49-F238E27FC236}">
-                <a16:creationId xmlns:a16="http://schemas.microsoft.com/office/drawing/2014/main" id="{91120F8B-61A2-494A-A6F3-47DE9D9C97B3}"/>
+                <a16:creationId xmlns:a16="http://schemas.microsoft.com/office/drawing/2014/main" id="{CB898F58-8939-4295-812F-0AA6263C1B48}"/>
               </a:ext>
             </a:extLst>
           </p:cNvPr>
@@ -7205,7 +7063,7 @@
                 <a:ea typeface="Helvetica Neue"/>
                 <a:cs typeface="Helvetica Neue"/>
               </a:rPr>
-              <a:t>Shirt as Coat</a:t>
+              <a:t>Pullover as Coat</a:t>
             </a:r>
           </a:p>
           <a:p xmlns:a="http://schemas.openxmlformats.org/drawingml/2006/main">
@@ -7228,7 +7086,7 @@
                 <a:ea typeface="Helvetica Neue"/>
                 <a:cs typeface="Helvetica Neue"/>
               </a:rPr>
-              <a:t>66 errors</a:t>
+              <a:t>116 errors</a:t>
             </a:r>
           </a:p>
         </p:txBody>
@@ -7236,7 +7094,7 @@
     </p:spTree>
     <p:extLst>
       <p:ext uri="{BB962C8B-B14F-4D97-AF65-F5344CB8AC3E}">
-        <p14:creationId xmlns:p14="http://schemas.microsoft.com/office/powerpoint/2010/main" val="1824579662"/>
+        <p14:creationId xmlns:p14="http://schemas.microsoft.com/office/powerpoint/2010/main" val="171262258"/>
       </p:ext>
     </p:extLst>
   </p:cSld>
@@ -7267,7 +7125,7 @@
           <p:cNvPr id="6" name="">
             <a:extLst xmlns:a="http://schemas.openxmlformats.org/drawingml/2006/main">
               <a:ext uri="{FF2B5EF4-FFF2-40B4-BE49-F238E27FC236}">
-                <a16:creationId xmlns:a16="http://schemas.microsoft.com/office/drawing/2014/main" id="{F05B6637-6FFD-4039-B703-F9B5B5D7784C}"/>
+                <a16:creationId xmlns:a16="http://schemas.microsoft.com/office/drawing/2014/main" id="{4F988E82-9CD0-451D-AAA0-B0E9AA63BA85}"/>
               </a:ext>
             </a:extLst>
           </p:cNvPr>
@@ -7423,7 +7281,7 @@
           <p:cNvPr id="2" name="">
             <a:extLst xmlns:a="http://schemas.openxmlformats.org/drawingml/2006/main">
               <a:ext uri="{FF2B5EF4-FFF2-40B4-BE49-F238E27FC236}">
-                <a16:creationId xmlns:a16="http://schemas.microsoft.com/office/drawing/2014/main" id="{CA13CA1E-0A80-4658-BABC-C6C7063B7740}"/>
+                <a16:creationId xmlns:a16="http://schemas.microsoft.com/office/drawing/2014/main" id="{E165FC9E-21BA-46FD-A618-DBCC40E925E3}"/>
               </a:ext>
             </a:extLst>
           </p:cNvPr>
@@ -7579,7 +7437,7 @@
           <p:cNvPr id="3" name="">
             <a:extLst xmlns:a="http://schemas.openxmlformats.org/drawingml/2006/main">
               <a:ext uri="{FF2B5EF4-FFF2-40B4-BE49-F238E27FC236}">
-                <a16:creationId xmlns:a16="http://schemas.microsoft.com/office/drawing/2014/main" id="{C5D3F016-F492-4E45-8EEC-E1418B456244}"/>
+                <a16:creationId xmlns:a16="http://schemas.microsoft.com/office/drawing/2014/main" id="{BD54857E-0F45-49B3-B7BC-7F0604C56867}"/>
               </a:ext>
             </a:extLst>
           </p:cNvPr>
@@ -7735,7 +7593,7 @@
           <p:cNvPr id="4" name="">
             <a:extLst xmlns:a="http://schemas.openxmlformats.org/drawingml/2006/main">
               <a:ext uri="{FF2B5EF4-FFF2-40B4-BE49-F238E27FC236}">
-                <a16:creationId xmlns:a16="http://schemas.microsoft.com/office/drawing/2014/main" id="{9B4FD049-B816-49C5-B192-0F4883B90E0B}"/>
+                <a16:creationId xmlns:a16="http://schemas.microsoft.com/office/drawing/2014/main" id="{38ACBC6A-6F3E-4B14-90B1-C477F1F76D8C}"/>
               </a:ext>
             </a:extLst>
           </p:cNvPr>
@@ -7843,7 +7701,7 @@
                           <a:ea typeface="Helvetica Neue"/>
                           <a:cs typeface="Helvetica Neue"/>
                         </a:rPr>
-                        <a:t>10.17 ms</a:t>
+                        <a:t>24.98 ms</a:t>
                       </a:r>
                     </a:p>
                   </a:txBody>
@@ -7893,7 +7751,7 @@
                           <a:ea typeface="Helvetica Neue"/>
                           <a:cs typeface="Helvetica Neue"/>
                         </a:rPr>
-                        <a:t>59 images/s</a:t>
+                        <a:t>5120 images/s</a:t>
                       </a:r>
                     </a:p>
                   </a:txBody>
@@ -7943,7 +7801,7 @@
                           <a:ea typeface="Helvetica Neue"/>
                           <a:cs typeface="Helvetica Neue"/>
                         </a:rPr>
-                        <a:t>52.74 MiB</a:t>
+                        <a:t>69.96 MiB</a:t>
                       </a:r>
                     </a:p>
                   </a:txBody>
@@ -7969,7 +7827,7 @@
                           <a:ea typeface="Helvetica Neue"/>
                           <a:cs typeface="Helvetica Neue"/>
                         </a:rPr>
-                        <a:t>support vectors</a:t>
+                        <a:t>tree nodes</a:t>
                       </a:r>
                     </a:p>
                   </a:txBody>
@@ -7993,7 +7851,7 @@
                           <a:ea typeface="Helvetica Neue"/>
                           <a:cs typeface="Helvetica Neue"/>
                         </a:rPr>
-                        <a:t>17835</a:t>
+                        <a:t>3264176</a:t>
                       </a:r>
                     </a:p>
                   </a:txBody>
@@ -8013,7 +7871,7 @@
           <p:cNvPr id="5" name="">
             <a:extLst xmlns:a="http://schemas.openxmlformats.org/drawingml/2006/main">
               <a:ext uri="{FF2B5EF4-FFF2-40B4-BE49-F238E27FC236}">
-                <a16:creationId xmlns:a16="http://schemas.microsoft.com/office/drawing/2014/main" id="{8A795016-F628-4C32-BB31-A041FDAB4939}"/>
+                <a16:creationId xmlns:a16="http://schemas.microsoft.com/office/drawing/2014/main" id="{5205962C-CF5E-4F8E-B50A-67C8997DF823}"/>
               </a:ext>
             </a:extLst>
           </p:cNvPr>
@@ -8167,7 +8025,7 @@
     </p:spTree>
     <p:extLst>
       <p:ext uri="{BB962C8B-B14F-4D97-AF65-F5344CB8AC3E}">
-        <p14:creationId xmlns:p14="http://schemas.microsoft.com/office/powerpoint/2010/main" val="455632143"/>
+        <p14:creationId xmlns:p14="http://schemas.microsoft.com/office/powerpoint/2010/main" val="2109123305"/>
       </p:ext>
     </p:extLst>
   </p:cSld>
@@ -8198,7 +8056,7 @@
           <p:cNvPr id="8" name="">
             <a:extLst xmlns:a="http://schemas.openxmlformats.org/drawingml/2006/main">
               <a:ext uri="{FF2B5EF4-FFF2-40B4-BE49-F238E27FC236}">
-                <a16:creationId xmlns:a16="http://schemas.microsoft.com/office/drawing/2014/main" id="{BF534813-1620-4675-8573-39861A0E61FB}"/>
+                <a16:creationId xmlns:a16="http://schemas.microsoft.com/office/drawing/2014/main" id="{97C33276-C75A-435E-9CF4-5234EC7897D9}"/>
               </a:ext>
             </a:extLst>
           </p:cNvPr>
@@ -8354,7 +8212,7 @@
           <p:cNvPr id="2" name="">
             <a:extLst xmlns:a="http://schemas.openxmlformats.org/drawingml/2006/main">
               <a:ext uri="{FF2B5EF4-FFF2-40B4-BE49-F238E27FC236}">
-                <a16:creationId xmlns:a16="http://schemas.microsoft.com/office/drawing/2014/main" id="{9328B739-0A2D-410B-82B9-4EBBDB16DA4E}"/>
+                <a16:creationId xmlns:a16="http://schemas.microsoft.com/office/drawing/2014/main" id="{350393B3-D249-4CF3-891F-4566D3349568}"/>
               </a:ext>
             </a:extLst>
           </p:cNvPr>
@@ -8510,7 +8368,7 @@
           <p:cNvPr id="3" name="">
             <a:extLst xmlns:a="http://schemas.openxmlformats.org/drawingml/2006/main">
               <a:ext uri="{FF2B5EF4-FFF2-40B4-BE49-F238E27FC236}">
-                <a16:creationId xmlns:a16="http://schemas.microsoft.com/office/drawing/2014/main" id="{3B9FC1F0-A0F7-41BC-B167-9957BBBF3126}"/>
+                <a16:creationId xmlns:a16="http://schemas.microsoft.com/office/drawing/2014/main" id="{EC6DA9FB-8650-4F20-8789-26ED8C186F36}"/>
               </a:ext>
             </a:extLst>
           </p:cNvPr>
@@ -8666,7 +8524,7 @@
           <p:cNvPr id="4" name="">
             <a:extLst xmlns:a="http://schemas.openxmlformats.org/drawingml/2006/main">
               <a:ext uri="{FF2B5EF4-FFF2-40B4-BE49-F238E27FC236}">
-                <a16:creationId xmlns:a16="http://schemas.microsoft.com/office/drawing/2014/main" id="{76D873D9-C490-4102-ACCE-34A876101944}"/>
+                <a16:creationId xmlns:a16="http://schemas.microsoft.com/office/drawing/2014/main" id="{21D163D5-1F73-4A22-8906-CB0BE0DDEB10}"/>
               </a:ext>
             </a:extLst>
           </p:cNvPr>
@@ -8822,7 +8680,7 @@
           <p:cNvPr id="5" name="">
             <a:extLst xmlns:a="http://schemas.openxmlformats.org/drawingml/2006/main">
               <a:ext uri="{FF2B5EF4-FFF2-40B4-BE49-F238E27FC236}">
-                <a16:creationId xmlns:a16="http://schemas.microsoft.com/office/drawing/2014/main" id="{8E9BAB89-DE71-42D0-AFBD-EDE51D36E749}"/>
+                <a16:creationId xmlns:a16="http://schemas.microsoft.com/office/drawing/2014/main" id="{105CC4BE-1D03-4FC8-BD5E-6A1FC3E74453}"/>
               </a:ext>
             </a:extLst>
           </p:cNvPr>
@@ -8978,7 +8836,7 @@
           <p:cNvPr id="6" name="">
             <a:extLst xmlns:a="http://schemas.openxmlformats.org/drawingml/2006/main">
               <a:ext uri="{FF2B5EF4-FFF2-40B4-BE49-F238E27FC236}">
-                <a16:creationId xmlns:a16="http://schemas.microsoft.com/office/drawing/2014/main" id="{068201DB-B5B0-415A-BD57-81B337E3FD8F}"/>
+                <a16:creationId xmlns:a16="http://schemas.microsoft.com/office/drawing/2014/main" id="{0D0F3E30-3F39-442C-9E0D-F58E7AF0DDC2}"/>
               </a:ext>
             </a:extLst>
           </p:cNvPr>
@@ -9134,7 +8992,7 @@
           <p:cNvPr id="7" name="">
             <a:extLst xmlns:a="http://schemas.openxmlformats.org/drawingml/2006/main">
               <a:ext uri="{FF2B5EF4-FFF2-40B4-BE49-F238E27FC236}">
-                <a16:creationId xmlns:a16="http://schemas.microsoft.com/office/drawing/2014/main" id="{3F865B8F-6BCC-4AAD-B47F-3A6F1FEE2EE1}"/>
+                <a16:creationId xmlns:a16="http://schemas.microsoft.com/office/drawing/2014/main" id="{B33E0D33-848D-4294-8FA7-3FF5F20C409F}"/>
               </a:ext>
             </a:extLst>
           </p:cNvPr>
@@ -9288,1953 +9146,7 @@
     </p:spTree>
     <p:extLst>
       <p:ext uri="{BB962C8B-B14F-4D97-AF65-F5344CB8AC3E}">
-        <p14:creationId xmlns:p14="http://schemas.microsoft.com/office/powerpoint/2010/main" val="2053335834"/>
-      </p:ext>
-    </p:extLst>
-  </p:cSld>
-</p:sld>
-</file>
-
-<file path=ppt/slides/slide14.xml><?xml version="1.0" encoding="utf-8"?>
-<p:sld xmlns:p="http://schemas.openxmlformats.org/presentationml/2006/main">
-  <p:cSld>
-    <p:bg>
-      <p:bgPr>
-        <a:solidFill xmlns:a="http://schemas.openxmlformats.org/drawingml/2006/main">
-          <a:srgbClr val="F8FAFB"/>
-        </a:solidFill>
-      </p:bgPr>
-    </p:bg>
-    <p:spTree>
-      <p:nvGrpSpPr>
-        <p:cNvPr id="1" name=""/>
-        <p:cNvGrpSpPr/>
-        <p:nvPr/>
-      </p:nvGrpSpPr>
-      <p:grpSpPr>
-        <a:xfrm xmlns:a="http://schemas.openxmlformats.org/drawingml/2006/main"/>
-      </p:grpSpPr>
-      <p:sp>
-        <p:nvSpPr>
-          <p:cNvPr id="8" name="">
-            <a:extLst xmlns:a="http://schemas.openxmlformats.org/drawingml/2006/main">
-              <a:ext uri="{FF2B5EF4-FFF2-40B4-BE49-F238E27FC236}">
-                <a16:creationId xmlns:a16="http://schemas.microsoft.com/office/drawing/2014/main" id="{E3A167F8-1F31-4464-8CFC-8D5C4D41D8DC}"/>
-              </a:ext>
-            </a:extLst>
-          </p:cNvPr>
-          <p:cNvSpPr>
-            <a:spLocks xmlns:a="http://schemas.openxmlformats.org/drawingml/2006/main" noGrp="1"/>
-          </p:cNvSpPr>
-          <p:nvPr/>
-        </p:nvSpPr>
-        <p:spPr>
-          <a:xfrm xmlns:a="http://schemas.openxmlformats.org/drawingml/2006/main">
-            <a:off x="619125" y="419100"/>
-            <a:ext cx="10953750" cy="895350"/>
-          </a:xfrm>
-          <a:prstGeom xmlns:a="http://schemas.openxmlformats.org/drawingml/2006/main" prst="rect">
-            <a:avLst/>
-          </a:prstGeom>
-          <a:noFill xmlns:a="http://schemas.openxmlformats.org/drawingml/2006/main"/>
-          <a:ln xmlns:a="http://schemas.openxmlformats.org/drawingml/2006/main" w="0">
-            <a:noFill/>
-          </a:ln>
-        </p:spPr>
-        <p:txBody>
-          <a:bodyPr xmlns:a="http://schemas.openxmlformats.org/drawingml/2006/main"/>
-          <a:lstStyle xmlns:a="http://schemas.openxmlformats.org/drawingml/2006/main">
-            <a:defPPr>
-              <a:defRPr sz="3225" b="1">
-                <a:solidFill>
-                  <a:srgbClr val="102B3B"/>
-                </a:solidFill>
-                <a:latin typeface="Helvetica Neue"/>
-                <a:ea typeface="Helvetica Neue"/>
-                <a:cs typeface="Helvetica Neue"/>
-              </a:defRPr>
-            </a:defPPr>
-            <a:lvl1pPr>
-              <a:defRPr sz="3225" b="1">
-                <a:solidFill>
-                  <a:srgbClr val="102B3B"/>
-                </a:solidFill>
-                <a:latin typeface="Helvetica Neue"/>
-                <a:ea typeface="Helvetica Neue"/>
-                <a:cs typeface="Helvetica Neue"/>
-              </a:defRPr>
-            </a:lvl1pPr>
-            <a:lvl2pPr>
-              <a:defRPr sz="3225" b="1">
-                <a:solidFill>
-                  <a:srgbClr val="102B3B"/>
-                </a:solidFill>
-                <a:latin typeface="Helvetica Neue"/>
-                <a:ea typeface="Helvetica Neue"/>
-                <a:cs typeface="Helvetica Neue"/>
-              </a:defRPr>
-            </a:lvl2pPr>
-            <a:lvl3pPr>
-              <a:defRPr sz="3225" b="1">
-                <a:solidFill>
-                  <a:srgbClr val="102B3B"/>
-                </a:solidFill>
-                <a:latin typeface="Helvetica Neue"/>
-                <a:ea typeface="Helvetica Neue"/>
-                <a:cs typeface="Helvetica Neue"/>
-              </a:defRPr>
-            </a:lvl3pPr>
-            <a:lvl4pPr>
-              <a:defRPr sz="3225" b="1">
-                <a:solidFill>
-                  <a:srgbClr val="102B3B"/>
-                </a:solidFill>
-                <a:latin typeface="Helvetica Neue"/>
-                <a:ea typeface="Helvetica Neue"/>
-                <a:cs typeface="Helvetica Neue"/>
-              </a:defRPr>
-            </a:lvl4pPr>
-            <a:lvl5pPr>
-              <a:defRPr sz="3225" b="1">
-                <a:solidFill>
-                  <a:srgbClr val="102B3B"/>
-                </a:solidFill>
-                <a:latin typeface="Helvetica Neue"/>
-                <a:ea typeface="Helvetica Neue"/>
-                <a:cs typeface="Helvetica Neue"/>
-              </a:defRPr>
-            </a:lvl5pPr>
-            <a:lvl6pPr>
-              <a:defRPr sz="3225" b="1">
-                <a:solidFill>
-                  <a:srgbClr val="102B3B"/>
-                </a:solidFill>
-                <a:latin typeface="Helvetica Neue"/>
-                <a:ea typeface="Helvetica Neue"/>
-                <a:cs typeface="Helvetica Neue"/>
-              </a:defRPr>
-            </a:lvl6pPr>
-            <a:lvl7pPr>
-              <a:defRPr sz="3225" b="1">
-                <a:solidFill>
-                  <a:srgbClr val="102B3B"/>
-                </a:solidFill>
-                <a:latin typeface="Helvetica Neue"/>
-                <a:ea typeface="Helvetica Neue"/>
-                <a:cs typeface="Helvetica Neue"/>
-              </a:defRPr>
-            </a:lvl7pPr>
-            <a:lvl8pPr>
-              <a:defRPr sz="3225" b="1">
-                <a:solidFill>
-                  <a:srgbClr val="102B3B"/>
-                </a:solidFill>
-                <a:latin typeface="Helvetica Neue"/>
-                <a:ea typeface="Helvetica Neue"/>
-                <a:cs typeface="Helvetica Neue"/>
-              </a:defRPr>
-            </a:lvl8pPr>
-            <a:lvl9pPr>
-              <a:defRPr sz="3225" b="1">
-                <a:solidFill>
-                  <a:srgbClr val="102B3B"/>
-                </a:solidFill>
-                <a:latin typeface="Helvetica Neue"/>
-                <a:ea typeface="Helvetica Neue"/>
-                <a:cs typeface="Helvetica Neue"/>
-              </a:defRPr>
-            </a:lvl9pPr>
-          </a:lstStyle>
-          <a:p xmlns:a="http://schemas.openxmlformats.org/drawingml/2006/main">
-            <a:pPr>
-              <a:defRPr sz="3225" b="1">
-                <a:solidFill>
-                  <a:srgbClr val="102B3B"/>
-                </a:solidFill>
-                <a:latin typeface="Helvetica Neue"/>
-                <a:ea typeface="Helvetica Neue"/>
-                <a:cs typeface="Helvetica Neue"/>
-              </a:defRPr>
-            </a:pPr>
-            <a:r>
-              <a:rPr sz="3225" b="1">
-                <a:solidFill>
-                  <a:srgbClr val="102B3B"/>
-                </a:solidFill>
-                <a:latin typeface="Helvetica Neue"/>
-                <a:ea typeface="Helvetica Neue"/>
-                <a:cs typeface="Helvetica Neue"/>
-              </a:rPr>
-              <a:t>Running the experiment</a:t>
-            </a:r>
-          </a:p>
-        </p:txBody>
-      </p:sp>
-      <p:sp>
-        <p:nvSpPr>
-          <p:cNvPr id="2" name="">
-            <a:extLst xmlns:a="http://schemas.openxmlformats.org/drawingml/2006/main">
-              <a:ext uri="{FF2B5EF4-FFF2-40B4-BE49-F238E27FC236}">
-                <a16:creationId xmlns:a16="http://schemas.microsoft.com/office/drawing/2014/main" id="{0F83A17D-F8A3-4F69-BB7F-9E038DD467A2}"/>
-              </a:ext>
-            </a:extLst>
-          </p:cNvPr>
-          <p:cNvSpPr>
-            <a:spLocks xmlns:a="http://schemas.openxmlformats.org/drawingml/2006/main" noGrp="1"/>
-          </p:cNvSpPr>
-          <p:nvPr/>
-        </p:nvSpPr>
-        <p:spPr>
-          <a:xfrm xmlns:a="http://schemas.openxmlformats.org/drawingml/2006/main">
-            <a:off x="619125" y="6343650"/>
-            <a:ext cx="7620000" cy="228600"/>
-          </a:xfrm>
-          <a:prstGeom xmlns:a="http://schemas.openxmlformats.org/drawingml/2006/main" prst="rect">
-            <a:avLst/>
-          </a:prstGeom>
-          <a:noFill xmlns:a="http://schemas.openxmlformats.org/drawingml/2006/main"/>
-          <a:ln xmlns:a="http://schemas.openxmlformats.org/drawingml/2006/main" w="0">
-            <a:noFill/>
-          </a:ln>
-        </p:spPr>
-        <p:txBody>
-          <a:bodyPr xmlns:a="http://schemas.openxmlformats.org/drawingml/2006/main"/>
-          <a:lstStyle xmlns:a="http://schemas.openxmlformats.org/drawingml/2006/main">
-            <a:defPPr>
-              <a:defRPr sz="1200" b="0">
-                <a:solidFill>
-                  <a:srgbClr val="607582"/>
-                </a:solidFill>
-                <a:latin typeface="Helvetica Neue"/>
-                <a:ea typeface="Helvetica Neue"/>
-                <a:cs typeface="Helvetica Neue"/>
-              </a:defRPr>
-            </a:defPPr>
-            <a:lvl1pPr>
-              <a:defRPr sz="1200" b="0">
-                <a:solidFill>
-                  <a:srgbClr val="607582"/>
-                </a:solidFill>
-                <a:latin typeface="Helvetica Neue"/>
-                <a:ea typeface="Helvetica Neue"/>
-                <a:cs typeface="Helvetica Neue"/>
-              </a:defRPr>
-            </a:lvl1pPr>
-            <a:lvl2pPr>
-              <a:defRPr sz="1200" b="0">
-                <a:solidFill>
-                  <a:srgbClr val="607582"/>
-                </a:solidFill>
-                <a:latin typeface="Helvetica Neue"/>
-                <a:ea typeface="Helvetica Neue"/>
-                <a:cs typeface="Helvetica Neue"/>
-              </a:defRPr>
-            </a:lvl2pPr>
-            <a:lvl3pPr>
-              <a:defRPr sz="1200" b="0">
-                <a:solidFill>
-                  <a:srgbClr val="607582"/>
-                </a:solidFill>
-                <a:latin typeface="Helvetica Neue"/>
-                <a:ea typeface="Helvetica Neue"/>
-                <a:cs typeface="Helvetica Neue"/>
-              </a:defRPr>
-            </a:lvl3pPr>
-            <a:lvl4pPr>
-              <a:defRPr sz="1200" b="0">
-                <a:solidFill>
-                  <a:srgbClr val="607582"/>
-                </a:solidFill>
-                <a:latin typeface="Helvetica Neue"/>
-                <a:ea typeface="Helvetica Neue"/>
-                <a:cs typeface="Helvetica Neue"/>
-              </a:defRPr>
-            </a:lvl4pPr>
-            <a:lvl5pPr>
-              <a:defRPr sz="1200" b="0">
-                <a:solidFill>
-                  <a:srgbClr val="607582"/>
-                </a:solidFill>
-                <a:latin typeface="Helvetica Neue"/>
-                <a:ea typeface="Helvetica Neue"/>
-                <a:cs typeface="Helvetica Neue"/>
-              </a:defRPr>
-            </a:lvl5pPr>
-            <a:lvl6pPr>
-              <a:defRPr sz="1200" b="0">
-                <a:solidFill>
-                  <a:srgbClr val="607582"/>
-                </a:solidFill>
-                <a:latin typeface="Helvetica Neue"/>
-                <a:ea typeface="Helvetica Neue"/>
-                <a:cs typeface="Helvetica Neue"/>
-              </a:defRPr>
-            </a:lvl6pPr>
-            <a:lvl7pPr>
-              <a:defRPr sz="1200" b="0">
-                <a:solidFill>
-                  <a:srgbClr val="607582"/>
-                </a:solidFill>
-                <a:latin typeface="Helvetica Neue"/>
-                <a:ea typeface="Helvetica Neue"/>
-                <a:cs typeface="Helvetica Neue"/>
-              </a:defRPr>
-            </a:lvl7pPr>
-            <a:lvl8pPr>
-              <a:defRPr sz="1200" b="0">
-                <a:solidFill>
-                  <a:srgbClr val="607582"/>
-                </a:solidFill>
-                <a:latin typeface="Helvetica Neue"/>
-                <a:ea typeface="Helvetica Neue"/>
-                <a:cs typeface="Helvetica Neue"/>
-              </a:defRPr>
-            </a:lvl8pPr>
-            <a:lvl9pPr>
-              <a:defRPr sz="1200" b="0">
-                <a:solidFill>
-                  <a:srgbClr val="607582"/>
-                </a:solidFill>
-                <a:latin typeface="Helvetica Neue"/>
-                <a:ea typeface="Helvetica Neue"/>
-                <a:cs typeface="Helvetica Neue"/>
-              </a:defRPr>
-            </a:lvl9pPr>
-          </a:lstStyle>
-          <a:p xmlns:a="http://schemas.openxmlformats.org/drawingml/2006/main">
-            <a:pPr>
-              <a:defRPr sz="1200" b="0">
-                <a:solidFill>
-                  <a:srgbClr val="607582"/>
-                </a:solidFill>
-                <a:latin typeface="Helvetica Neue"/>
-                <a:ea typeface="Helvetica Neue"/>
-                <a:cs typeface="Helvetica Neue"/>
-              </a:defRPr>
-            </a:pPr>
-            <a:r>
-              <a:rPr sz="1200" b="0">
-                <a:solidFill>
-                  <a:srgbClr val="607582"/>
-                </a:solidFill>
-                <a:latin typeface="Helvetica Neue"/>
-                <a:ea typeface="Helvetica Neue"/>
-                <a:cs typeface="Helvetica Neue"/>
-              </a:rPr>
-              <a:t>PROJECT 11  /  PHASE 1</a:t>
-            </a:r>
-          </a:p>
-        </p:txBody>
-      </p:sp>
-      <p:sp>
-        <p:nvSpPr>
-          <p:cNvPr id="3" name="">
-            <a:extLst xmlns:a="http://schemas.openxmlformats.org/drawingml/2006/main">
-              <a:ext uri="{FF2B5EF4-FFF2-40B4-BE49-F238E27FC236}">
-                <a16:creationId xmlns:a16="http://schemas.microsoft.com/office/drawing/2014/main" id="{CD8063E1-F6E2-4D5A-BE78-CC314C5CADB5}"/>
-              </a:ext>
-            </a:extLst>
-          </p:cNvPr>
-          <p:cNvSpPr>
-            <a:spLocks xmlns:a="http://schemas.openxmlformats.org/drawingml/2006/main" noGrp="1"/>
-          </p:cNvSpPr>
-          <p:nvPr/>
-        </p:nvSpPr>
-        <p:spPr>
-          <a:xfrm xmlns:a="http://schemas.openxmlformats.org/drawingml/2006/main">
-            <a:off x="11049000" y="6343650"/>
-            <a:ext cx="666750" cy="228600"/>
-          </a:xfrm>
-          <a:prstGeom xmlns:a="http://schemas.openxmlformats.org/drawingml/2006/main" prst="rect">
-            <a:avLst/>
-          </a:prstGeom>
-          <a:noFill xmlns:a="http://schemas.openxmlformats.org/drawingml/2006/main"/>
-          <a:ln xmlns:a="http://schemas.openxmlformats.org/drawingml/2006/main" w="0">
-            <a:noFill/>
-          </a:ln>
-        </p:spPr>
-        <p:txBody>
-          <a:bodyPr xmlns:a="http://schemas.openxmlformats.org/drawingml/2006/main"/>
-          <a:lstStyle xmlns:a="http://schemas.openxmlformats.org/drawingml/2006/main">
-            <a:defPPr>
-              <a:defRPr sz="1200" b="0">
-                <a:solidFill>
-                  <a:srgbClr val="607582"/>
-                </a:solidFill>
-                <a:latin typeface="Helvetica Neue"/>
-                <a:ea typeface="Helvetica Neue"/>
-                <a:cs typeface="Helvetica Neue"/>
-              </a:defRPr>
-            </a:defPPr>
-            <a:lvl1pPr>
-              <a:defRPr sz="1200" b="0">
-                <a:solidFill>
-                  <a:srgbClr val="607582"/>
-                </a:solidFill>
-                <a:latin typeface="Helvetica Neue"/>
-                <a:ea typeface="Helvetica Neue"/>
-                <a:cs typeface="Helvetica Neue"/>
-              </a:defRPr>
-            </a:lvl1pPr>
-            <a:lvl2pPr>
-              <a:defRPr sz="1200" b="0">
-                <a:solidFill>
-                  <a:srgbClr val="607582"/>
-                </a:solidFill>
-                <a:latin typeface="Helvetica Neue"/>
-                <a:ea typeface="Helvetica Neue"/>
-                <a:cs typeface="Helvetica Neue"/>
-              </a:defRPr>
-            </a:lvl2pPr>
-            <a:lvl3pPr>
-              <a:defRPr sz="1200" b="0">
-                <a:solidFill>
-                  <a:srgbClr val="607582"/>
-                </a:solidFill>
-                <a:latin typeface="Helvetica Neue"/>
-                <a:ea typeface="Helvetica Neue"/>
-                <a:cs typeface="Helvetica Neue"/>
-              </a:defRPr>
-            </a:lvl3pPr>
-            <a:lvl4pPr>
-              <a:defRPr sz="1200" b="0">
-                <a:solidFill>
-                  <a:srgbClr val="607582"/>
-                </a:solidFill>
-                <a:latin typeface="Helvetica Neue"/>
-                <a:ea typeface="Helvetica Neue"/>
-                <a:cs typeface="Helvetica Neue"/>
-              </a:defRPr>
-            </a:lvl4pPr>
-            <a:lvl5pPr>
-              <a:defRPr sz="1200" b="0">
-                <a:solidFill>
-                  <a:srgbClr val="607582"/>
-                </a:solidFill>
-                <a:latin typeface="Helvetica Neue"/>
-                <a:ea typeface="Helvetica Neue"/>
-                <a:cs typeface="Helvetica Neue"/>
-              </a:defRPr>
-            </a:lvl5pPr>
-            <a:lvl6pPr>
-              <a:defRPr sz="1200" b="0">
-                <a:solidFill>
-                  <a:srgbClr val="607582"/>
-                </a:solidFill>
-                <a:latin typeface="Helvetica Neue"/>
-                <a:ea typeface="Helvetica Neue"/>
-                <a:cs typeface="Helvetica Neue"/>
-              </a:defRPr>
-            </a:lvl6pPr>
-            <a:lvl7pPr>
-              <a:defRPr sz="1200" b="0">
-                <a:solidFill>
-                  <a:srgbClr val="607582"/>
-                </a:solidFill>
-                <a:latin typeface="Helvetica Neue"/>
-                <a:ea typeface="Helvetica Neue"/>
-                <a:cs typeface="Helvetica Neue"/>
-              </a:defRPr>
-            </a:lvl7pPr>
-            <a:lvl8pPr>
-              <a:defRPr sz="1200" b="0">
-                <a:solidFill>
-                  <a:srgbClr val="607582"/>
-                </a:solidFill>
-                <a:latin typeface="Helvetica Neue"/>
-                <a:ea typeface="Helvetica Neue"/>
-                <a:cs typeface="Helvetica Neue"/>
-              </a:defRPr>
-            </a:lvl8pPr>
-            <a:lvl9pPr>
-              <a:defRPr sz="1200" b="0">
-                <a:solidFill>
-                  <a:srgbClr val="607582"/>
-                </a:solidFill>
-                <a:latin typeface="Helvetica Neue"/>
-                <a:ea typeface="Helvetica Neue"/>
-                <a:cs typeface="Helvetica Neue"/>
-              </a:defRPr>
-            </a:lvl9pPr>
-          </a:lstStyle>
-          <a:p xmlns:a="http://schemas.openxmlformats.org/drawingml/2006/main">
-            <a:pPr>
-              <a:defRPr sz="1200" b="0">
-                <a:solidFill>
-                  <a:srgbClr val="607582"/>
-                </a:solidFill>
-                <a:latin typeface="Helvetica Neue"/>
-                <a:ea typeface="Helvetica Neue"/>
-                <a:cs typeface="Helvetica Neue"/>
-              </a:defRPr>
-            </a:pPr>
-            <a:r>
-              <a:rPr sz="1200" b="0">
-                <a:solidFill>
-                  <a:srgbClr val="607582"/>
-                </a:solidFill>
-                <a:latin typeface="Helvetica Neue"/>
-                <a:ea typeface="Helvetica Neue"/>
-                <a:cs typeface="Helvetica Neue"/>
-              </a:rPr>
-              <a:t>14</a:t>
-            </a:r>
-          </a:p>
-        </p:txBody>
-      </p:sp>
-      <p:sp>
-        <p:nvSpPr>
-          <p:cNvPr id="4" name="">
-            <a:extLst xmlns:a="http://schemas.openxmlformats.org/drawingml/2006/main">
-              <a:ext uri="{FF2B5EF4-FFF2-40B4-BE49-F238E27FC236}">
-                <a16:creationId xmlns:a16="http://schemas.microsoft.com/office/drawing/2014/main" id="{D793A9F5-F533-4095-A498-B991ADF6309C}"/>
-              </a:ext>
-            </a:extLst>
-          </p:cNvPr>
-          <p:cNvSpPr>
-            <a:spLocks xmlns:a="http://schemas.openxmlformats.org/drawingml/2006/main" noGrp="1"/>
-          </p:cNvSpPr>
-          <p:nvPr/>
-        </p:nvSpPr>
-        <p:spPr>
-          <a:xfrm xmlns:a="http://schemas.openxmlformats.org/drawingml/2006/main">
-            <a:off x="714375" y="1476375"/>
-            <a:ext cx="10668000" cy="923925"/>
-          </a:xfrm>
-          <a:prstGeom xmlns:a="http://schemas.openxmlformats.org/drawingml/2006/main" prst="rect">
-            <a:avLst/>
-          </a:prstGeom>
-          <a:noFill xmlns:a="http://schemas.openxmlformats.org/drawingml/2006/main"/>
-          <a:ln xmlns:a="http://schemas.openxmlformats.org/drawingml/2006/main" w="0">
-            <a:noFill/>
-          </a:ln>
-        </p:spPr>
-        <p:txBody>
-          <a:bodyPr xmlns:a="http://schemas.openxmlformats.org/drawingml/2006/main"/>
-          <a:lstStyle xmlns:a="http://schemas.openxmlformats.org/drawingml/2006/main">
-            <a:defPPr>
-              <a:defRPr sz="2250" b="0">
-                <a:solidFill>
-                  <a:srgbClr val="20333F"/>
-                </a:solidFill>
-                <a:latin typeface="Helvetica Neue"/>
-                <a:ea typeface="Helvetica Neue"/>
-                <a:cs typeface="Helvetica Neue"/>
-              </a:defRPr>
-            </a:defPPr>
-            <a:lvl1pPr>
-              <a:defRPr sz="2250" b="0">
-                <a:solidFill>
-                  <a:srgbClr val="20333F"/>
-                </a:solidFill>
-                <a:latin typeface="Helvetica Neue"/>
-                <a:ea typeface="Helvetica Neue"/>
-                <a:cs typeface="Helvetica Neue"/>
-              </a:defRPr>
-            </a:lvl1pPr>
-            <a:lvl2pPr>
-              <a:defRPr sz="2250" b="0">
-                <a:solidFill>
-                  <a:srgbClr val="20333F"/>
-                </a:solidFill>
-                <a:latin typeface="Helvetica Neue"/>
-                <a:ea typeface="Helvetica Neue"/>
-                <a:cs typeface="Helvetica Neue"/>
-              </a:defRPr>
-            </a:lvl2pPr>
-            <a:lvl3pPr>
-              <a:defRPr sz="2250" b="0">
-                <a:solidFill>
-                  <a:srgbClr val="20333F"/>
-                </a:solidFill>
-                <a:latin typeface="Helvetica Neue"/>
-                <a:ea typeface="Helvetica Neue"/>
-                <a:cs typeface="Helvetica Neue"/>
-              </a:defRPr>
-            </a:lvl3pPr>
-            <a:lvl4pPr>
-              <a:defRPr sz="2250" b="0">
-                <a:solidFill>
-                  <a:srgbClr val="20333F"/>
-                </a:solidFill>
-                <a:latin typeface="Helvetica Neue"/>
-                <a:ea typeface="Helvetica Neue"/>
-                <a:cs typeface="Helvetica Neue"/>
-              </a:defRPr>
-            </a:lvl4pPr>
-            <a:lvl5pPr>
-              <a:defRPr sz="2250" b="0">
-                <a:solidFill>
-                  <a:srgbClr val="20333F"/>
-                </a:solidFill>
-                <a:latin typeface="Helvetica Neue"/>
-                <a:ea typeface="Helvetica Neue"/>
-                <a:cs typeface="Helvetica Neue"/>
-              </a:defRPr>
-            </a:lvl5pPr>
-            <a:lvl6pPr>
-              <a:defRPr sz="2250" b="0">
-                <a:solidFill>
-                  <a:srgbClr val="20333F"/>
-                </a:solidFill>
-                <a:latin typeface="Helvetica Neue"/>
-                <a:ea typeface="Helvetica Neue"/>
-                <a:cs typeface="Helvetica Neue"/>
-              </a:defRPr>
-            </a:lvl6pPr>
-            <a:lvl7pPr>
-              <a:defRPr sz="2250" b="0">
-                <a:solidFill>
-                  <a:srgbClr val="20333F"/>
-                </a:solidFill>
-                <a:latin typeface="Helvetica Neue"/>
-                <a:ea typeface="Helvetica Neue"/>
-                <a:cs typeface="Helvetica Neue"/>
-              </a:defRPr>
-            </a:lvl7pPr>
-            <a:lvl8pPr>
-              <a:defRPr sz="2250" b="0">
-                <a:solidFill>
-                  <a:srgbClr val="20333F"/>
-                </a:solidFill>
-                <a:latin typeface="Helvetica Neue"/>
-                <a:ea typeface="Helvetica Neue"/>
-                <a:cs typeface="Helvetica Neue"/>
-              </a:defRPr>
-            </a:lvl8pPr>
-            <a:lvl9pPr>
-              <a:defRPr sz="2250" b="0">
-                <a:solidFill>
-                  <a:srgbClr val="20333F"/>
-                </a:solidFill>
-                <a:latin typeface="Helvetica Neue"/>
-                <a:ea typeface="Helvetica Neue"/>
-                <a:cs typeface="Helvetica Neue"/>
-              </a:defRPr>
-            </a:lvl9pPr>
-          </a:lstStyle>
-          <a:p xmlns:a="http://schemas.openxmlformats.org/drawingml/2006/main">
-            <a:pPr>
-              <a:defRPr sz="2250" b="0">
-                <a:solidFill>
-                  <a:srgbClr val="20333F"/>
-                </a:solidFill>
-                <a:latin typeface="Helvetica Neue"/>
-                <a:ea typeface="Helvetica Neue"/>
-                <a:cs typeface="Helvetica Neue"/>
-              </a:defRPr>
-            </a:pPr>
-            <a:r>
-              <a:rPr sz="2250" b="0">
-                <a:solidFill>
-                  <a:srgbClr val="20333F"/>
-                </a:solidFill>
-                <a:latin typeface="Helvetica Neue"/>
-                <a:ea typeface="Helvetica Neue"/>
-                <a:cs typeface="Helvetica Neue"/>
-              </a:rPr>
-              <a:t>uv sync --locked</a:t>
-            </a:r>
-          </a:p>
-        </p:txBody>
-      </p:sp>
-      <p:sp>
-        <p:nvSpPr>
-          <p:cNvPr id="5" name="">
-            <a:extLst xmlns:a="http://schemas.openxmlformats.org/drawingml/2006/main">
-              <a:ext uri="{FF2B5EF4-FFF2-40B4-BE49-F238E27FC236}">
-                <a16:creationId xmlns:a16="http://schemas.microsoft.com/office/drawing/2014/main" id="{6573DA14-F1BC-47DB-BE5C-EAF29B089DE4}"/>
-              </a:ext>
-            </a:extLst>
-          </p:cNvPr>
-          <p:cNvSpPr>
-            <a:spLocks xmlns:a="http://schemas.openxmlformats.org/drawingml/2006/main" noGrp="1"/>
-          </p:cNvSpPr>
-          <p:nvPr/>
-        </p:nvSpPr>
-        <p:spPr>
-          <a:xfrm xmlns:a="http://schemas.openxmlformats.org/drawingml/2006/main">
-            <a:off x="714375" y="2476500"/>
-            <a:ext cx="10668000" cy="923925"/>
-          </a:xfrm>
-          <a:prstGeom xmlns:a="http://schemas.openxmlformats.org/drawingml/2006/main" prst="rect">
-            <a:avLst/>
-          </a:prstGeom>
-          <a:noFill xmlns:a="http://schemas.openxmlformats.org/drawingml/2006/main"/>
-          <a:ln xmlns:a="http://schemas.openxmlformats.org/drawingml/2006/main" w="0">
-            <a:noFill/>
-          </a:ln>
-        </p:spPr>
-        <p:txBody>
-          <a:bodyPr xmlns:a="http://schemas.openxmlformats.org/drawingml/2006/main"/>
-          <a:lstStyle xmlns:a="http://schemas.openxmlformats.org/drawingml/2006/main">
-            <a:defPPr>
-              <a:defRPr sz="2250" b="0">
-                <a:solidFill>
-                  <a:srgbClr val="20333F"/>
-                </a:solidFill>
-                <a:latin typeface="Helvetica Neue"/>
-                <a:ea typeface="Helvetica Neue"/>
-                <a:cs typeface="Helvetica Neue"/>
-              </a:defRPr>
-            </a:defPPr>
-            <a:lvl1pPr>
-              <a:defRPr sz="2250" b="0">
-                <a:solidFill>
-                  <a:srgbClr val="20333F"/>
-                </a:solidFill>
-                <a:latin typeface="Helvetica Neue"/>
-                <a:ea typeface="Helvetica Neue"/>
-                <a:cs typeface="Helvetica Neue"/>
-              </a:defRPr>
-            </a:lvl1pPr>
-            <a:lvl2pPr>
-              <a:defRPr sz="2250" b="0">
-                <a:solidFill>
-                  <a:srgbClr val="20333F"/>
-                </a:solidFill>
-                <a:latin typeface="Helvetica Neue"/>
-                <a:ea typeface="Helvetica Neue"/>
-                <a:cs typeface="Helvetica Neue"/>
-              </a:defRPr>
-            </a:lvl2pPr>
-            <a:lvl3pPr>
-              <a:defRPr sz="2250" b="0">
-                <a:solidFill>
-                  <a:srgbClr val="20333F"/>
-                </a:solidFill>
-                <a:latin typeface="Helvetica Neue"/>
-                <a:ea typeface="Helvetica Neue"/>
-                <a:cs typeface="Helvetica Neue"/>
-              </a:defRPr>
-            </a:lvl3pPr>
-            <a:lvl4pPr>
-              <a:defRPr sz="2250" b="0">
-                <a:solidFill>
-                  <a:srgbClr val="20333F"/>
-                </a:solidFill>
-                <a:latin typeface="Helvetica Neue"/>
-                <a:ea typeface="Helvetica Neue"/>
-                <a:cs typeface="Helvetica Neue"/>
-              </a:defRPr>
-            </a:lvl4pPr>
-            <a:lvl5pPr>
-              <a:defRPr sz="2250" b="0">
-                <a:solidFill>
-                  <a:srgbClr val="20333F"/>
-                </a:solidFill>
-                <a:latin typeface="Helvetica Neue"/>
-                <a:ea typeface="Helvetica Neue"/>
-                <a:cs typeface="Helvetica Neue"/>
-              </a:defRPr>
-            </a:lvl5pPr>
-            <a:lvl6pPr>
-              <a:defRPr sz="2250" b="0">
-                <a:solidFill>
-                  <a:srgbClr val="20333F"/>
-                </a:solidFill>
-                <a:latin typeface="Helvetica Neue"/>
-                <a:ea typeface="Helvetica Neue"/>
-                <a:cs typeface="Helvetica Neue"/>
-              </a:defRPr>
-            </a:lvl6pPr>
-            <a:lvl7pPr>
-              <a:defRPr sz="2250" b="0">
-                <a:solidFill>
-                  <a:srgbClr val="20333F"/>
-                </a:solidFill>
-                <a:latin typeface="Helvetica Neue"/>
-                <a:ea typeface="Helvetica Neue"/>
-                <a:cs typeface="Helvetica Neue"/>
-              </a:defRPr>
-            </a:lvl7pPr>
-            <a:lvl8pPr>
-              <a:defRPr sz="2250" b="0">
-                <a:solidFill>
-                  <a:srgbClr val="20333F"/>
-                </a:solidFill>
-                <a:latin typeface="Helvetica Neue"/>
-                <a:ea typeface="Helvetica Neue"/>
-                <a:cs typeface="Helvetica Neue"/>
-              </a:defRPr>
-            </a:lvl8pPr>
-            <a:lvl9pPr>
-              <a:defRPr sz="2250" b="0">
-                <a:solidFill>
-                  <a:srgbClr val="20333F"/>
-                </a:solidFill>
-                <a:latin typeface="Helvetica Neue"/>
-                <a:ea typeface="Helvetica Neue"/>
-                <a:cs typeface="Helvetica Neue"/>
-              </a:defRPr>
-            </a:lvl9pPr>
-          </a:lstStyle>
-          <a:p xmlns:a="http://schemas.openxmlformats.org/drawingml/2006/main">
-            <a:pPr>
-              <a:defRPr sz="2250" b="0">
-                <a:solidFill>
-                  <a:srgbClr val="20333F"/>
-                </a:solidFill>
-                <a:latin typeface="Helvetica Neue"/>
-                <a:ea typeface="Helvetica Neue"/>
-                <a:cs typeface="Helvetica Neue"/>
-              </a:defRPr>
-            </a:pPr>
-            <a:r>
-              <a:rPr sz="2250" b="0">
-                <a:solidFill>
-                  <a:srgbClr val="20333F"/>
-                </a:solidFill>
-                <a:latin typeface="Helvetica Neue"/>
-                <a:ea typeface="Helvetica Neue"/>
-                <a:cs typeface="Helvetica Neue"/>
-              </a:rPr>
-              <a:t>bash scripts/uv.sh run python scripts/reproduce.py</a:t>
-            </a:r>
-          </a:p>
-        </p:txBody>
-      </p:sp>
-      <p:sp>
-        <p:nvSpPr>
-          <p:cNvPr id="6" name="">
-            <a:extLst xmlns:a="http://schemas.openxmlformats.org/drawingml/2006/main">
-              <a:ext uri="{FF2B5EF4-FFF2-40B4-BE49-F238E27FC236}">
-                <a16:creationId xmlns:a16="http://schemas.microsoft.com/office/drawing/2014/main" id="{296E22F1-A3E6-4161-9363-9D3C107C396C}"/>
-              </a:ext>
-            </a:extLst>
-          </p:cNvPr>
-          <p:cNvSpPr>
-            <a:spLocks xmlns:a="http://schemas.openxmlformats.org/drawingml/2006/main" noGrp="1"/>
-          </p:cNvSpPr>
-          <p:nvPr/>
-        </p:nvSpPr>
-        <p:spPr>
-          <a:xfrm xmlns:a="http://schemas.openxmlformats.org/drawingml/2006/main">
-            <a:off x="714375" y="3476625"/>
-            <a:ext cx="10668000" cy="923925"/>
-          </a:xfrm>
-          <a:prstGeom xmlns:a="http://schemas.openxmlformats.org/drawingml/2006/main" prst="rect">
-            <a:avLst/>
-          </a:prstGeom>
-          <a:noFill xmlns:a="http://schemas.openxmlformats.org/drawingml/2006/main"/>
-          <a:ln xmlns:a="http://schemas.openxmlformats.org/drawingml/2006/main" w="0">
-            <a:noFill/>
-          </a:ln>
-        </p:spPr>
-        <p:txBody>
-          <a:bodyPr xmlns:a="http://schemas.openxmlformats.org/drawingml/2006/main"/>
-          <a:lstStyle xmlns:a="http://schemas.openxmlformats.org/drawingml/2006/main">
-            <a:defPPr>
-              <a:defRPr sz="2250" b="0">
-                <a:solidFill>
-                  <a:srgbClr val="20333F"/>
-                </a:solidFill>
-                <a:latin typeface="Helvetica Neue"/>
-                <a:ea typeface="Helvetica Neue"/>
-                <a:cs typeface="Helvetica Neue"/>
-              </a:defRPr>
-            </a:defPPr>
-            <a:lvl1pPr>
-              <a:defRPr sz="2250" b="0">
-                <a:solidFill>
-                  <a:srgbClr val="20333F"/>
-                </a:solidFill>
-                <a:latin typeface="Helvetica Neue"/>
-                <a:ea typeface="Helvetica Neue"/>
-                <a:cs typeface="Helvetica Neue"/>
-              </a:defRPr>
-            </a:lvl1pPr>
-            <a:lvl2pPr>
-              <a:defRPr sz="2250" b="0">
-                <a:solidFill>
-                  <a:srgbClr val="20333F"/>
-                </a:solidFill>
-                <a:latin typeface="Helvetica Neue"/>
-                <a:ea typeface="Helvetica Neue"/>
-                <a:cs typeface="Helvetica Neue"/>
-              </a:defRPr>
-            </a:lvl2pPr>
-            <a:lvl3pPr>
-              <a:defRPr sz="2250" b="0">
-                <a:solidFill>
-                  <a:srgbClr val="20333F"/>
-                </a:solidFill>
-                <a:latin typeface="Helvetica Neue"/>
-                <a:ea typeface="Helvetica Neue"/>
-                <a:cs typeface="Helvetica Neue"/>
-              </a:defRPr>
-            </a:lvl3pPr>
-            <a:lvl4pPr>
-              <a:defRPr sz="2250" b="0">
-                <a:solidFill>
-                  <a:srgbClr val="20333F"/>
-                </a:solidFill>
-                <a:latin typeface="Helvetica Neue"/>
-                <a:ea typeface="Helvetica Neue"/>
-                <a:cs typeface="Helvetica Neue"/>
-              </a:defRPr>
-            </a:lvl4pPr>
-            <a:lvl5pPr>
-              <a:defRPr sz="2250" b="0">
-                <a:solidFill>
-                  <a:srgbClr val="20333F"/>
-                </a:solidFill>
-                <a:latin typeface="Helvetica Neue"/>
-                <a:ea typeface="Helvetica Neue"/>
-                <a:cs typeface="Helvetica Neue"/>
-              </a:defRPr>
-            </a:lvl5pPr>
-            <a:lvl6pPr>
-              <a:defRPr sz="2250" b="0">
-                <a:solidFill>
-                  <a:srgbClr val="20333F"/>
-                </a:solidFill>
-                <a:latin typeface="Helvetica Neue"/>
-                <a:ea typeface="Helvetica Neue"/>
-                <a:cs typeface="Helvetica Neue"/>
-              </a:defRPr>
-            </a:lvl6pPr>
-            <a:lvl7pPr>
-              <a:defRPr sz="2250" b="0">
-                <a:solidFill>
-                  <a:srgbClr val="20333F"/>
-                </a:solidFill>
-                <a:latin typeface="Helvetica Neue"/>
-                <a:ea typeface="Helvetica Neue"/>
-                <a:cs typeface="Helvetica Neue"/>
-              </a:defRPr>
-            </a:lvl7pPr>
-            <a:lvl8pPr>
-              <a:defRPr sz="2250" b="0">
-                <a:solidFill>
-                  <a:srgbClr val="20333F"/>
-                </a:solidFill>
-                <a:latin typeface="Helvetica Neue"/>
-                <a:ea typeface="Helvetica Neue"/>
-                <a:cs typeface="Helvetica Neue"/>
-              </a:defRPr>
-            </a:lvl8pPr>
-            <a:lvl9pPr>
-              <a:defRPr sz="2250" b="0">
-                <a:solidFill>
-                  <a:srgbClr val="20333F"/>
-                </a:solidFill>
-                <a:latin typeface="Helvetica Neue"/>
-                <a:ea typeface="Helvetica Neue"/>
-                <a:cs typeface="Helvetica Neue"/>
-              </a:defRPr>
-            </a:lvl9pPr>
-          </a:lstStyle>
-          <a:p xmlns:a="http://schemas.openxmlformats.org/drawingml/2006/main">
-            <a:pPr>
-              <a:defRPr sz="2250" b="0">
-                <a:solidFill>
-                  <a:srgbClr val="20333F"/>
-                </a:solidFill>
-                <a:latin typeface="Helvetica Neue"/>
-                <a:ea typeface="Helvetica Neue"/>
-                <a:cs typeface="Helvetica Neue"/>
-              </a:defRPr>
-            </a:pPr>
-            <a:r>
-              <a:rPr sz="2250" b="0">
-                <a:solidFill>
-                  <a:srgbClr val="20333F"/>
-                </a:solidFill>
-                <a:latin typeface="Helvetica Neue"/>
-                <a:ea typeface="Helvetica Neue"/>
-                <a:cs typeface="Helvetica Neue"/>
-              </a:rPr>
-              <a:t>Notebook: notebooks/phase1.ipynb</a:t>
-            </a:r>
-          </a:p>
-        </p:txBody>
-      </p:sp>
-      <p:sp>
-        <p:nvSpPr>
-          <p:cNvPr id="7" name="">
-            <a:extLst xmlns:a="http://schemas.openxmlformats.org/drawingml/2006/main">
-              <a:ext uri="{FF2B5EF4-FFF2-40B4-BE49-F238E27FC236}">
-                <a16:creationId xmlns:a16="http://schemas.microsoft.com/office/drawing/2014/main" id="{3069A015-7C19-49CA-BA65-204817DF93A9}"/>
-              </a:ext>
-            </a:extLst>
-          </p:cNvPr>
-          <p:cNvSpPr>
-            <a:spLocks xmlns:a="http://schemas.openxmlformats.org/drawingml/2006/main" noGrp="1"/>
-          </p:cNvSpPr>
-          <p:nvPr/>
-        </p:nvSpPr>
-        <p:spPr>
-          <a:xfrm xmlns:a="http://schemas.openxmlformats.org/drawingml/2006/main">
-            <a:off x="714375" y="4476750"/>
-            <a:ext cx="10668000" cy="923925"/>
-          </a:xfrm>
-          <a:prstGeom xmlns:a="http://schemas.openxmlformats.org/drawingml/2006/main" prst="rect">
-            <a:avLst/>
-          </a:prstGeom>
-          <a:noFill xmlns:a="http://schemas.openxmlformats.org/drawingml/2006/main"/>
-          <a:ln xmlns:a="http://schemas.openxmlformats.org/drawingml/2006/main" w="0">
-            <a:noFill/>
-          </a:ln>
-        </p:spPr>
-        <p:txBody>
-          <a:bodyPr xmlns:a="http://schemas.openxmlformats.org/drawingml/2006/main"/>
-          <a:lstStyle xmlns:a="http://schemas.openxmlformats.org/drawingml/2006/main">
-            <a:defPPr>
-              <a:defRPr sz="2250" b="0">
-                <a:solidFill>
-                  <a:srgbClr val="20333F"/>
-                </a:solidFill>
-                <a:latin typeface="Helvetica Neue"/>
-                <a:ea typeface="Helvetica Neue"/>
-                <a:cs typeface="Helvetica Neue"/>
-              </a:defRPr>
-            </a:defPPr>
-            <a:lvl1pPr>
-              <a:defRPr sz="2250" b="0">
-                <a:solidFill>
-                  <a:srgbClr val="20333F"/>
-                </a:solidFill>
-                <a:latin typeface="Helvetica Neue"/>
-                <a:ea typeface="Helvetica Neue"/>
-                <a:cs typeface="Helvetica Neue"/>
-              </a:defRPr>
-            </a:lvl1pPr>
-            <a:lvl2pPr>
-              <a:defRPr sz="2250" b="0">
-                <a:solidFill>
-                  <a:srgbClr val="20333F"/>
-                </a:solidFill>
-                <a:latin typeface="Helvetica Neue"/>
-                <a:ea typeface="Helvetica Neue"/>
-                <a:cs typeface="Helvetica Neue"/>
-              </a:defRPr>
-            </a:lvl2pPr>
-            <a:lvl3pPr>
-              <a:defRPr sz="2250" b="0">
-                <a:solidFill>
-                  <a:srgbClr val="20333F"/>
-                </a:solidFill>
-                <a:latin typeface="Helvetica Neue"/>
-                <a:ea typeface="Helvetica Neue"/>
-                <a:cs typeface="Helvetica Neue"/>
-              </a:defRPr>
-            </a:lvl3pPr>
-            <a:lvl4pPr>
-              <a:defRPr sz="2250" b="0">
-                <a:solidFill>
-                  <a:srgbClr val="20333F"/>
-                </a:solidFill>
-                <a:latin typeface="Helvetica Neue"/>
-                <a:ea typeface="Helvetica Neue"/>
-                <a:cs typeface="Helvetica Neue"/>
-              </a:defRPr>
-            </a:lvl4pPr>
-            <a:lvl5pPr>
-              <a:defRPr sz="2250" b="0">
-                <a:solidFill>
-                  <a:srgbClr val="20333F"/>
-                </a:solidFill>
-                <a:latin typeface="Helvetica Neue"/>
-                <a:ea typeface="Helvetica Neue"/>
-                <a:cs typeface="Helvetica Neue"/>
-              </a:defRPr>
-            </a:lvl5pPr>
-            <a:lvl6pPr>
-              <a:defRPr sz="2250" b="0">
-                <a:solidFill>
-                  <a:srgbClr val="20333F"/>
-                </a:solidFill>
-                <a:latin typeface="Helvetica Neue"/>
-                <a:ea typeface="Helvetica Neue"/>
-                <a:cs typeface="Helvetica Neue"/>
-              </a:defRPr>
-            </a:lvl6pPr>
-            <a:lvl7pPr>
-              <a:defRPr sz="2250" b="0">
-                <a:solidFill>
-                  <a:srgbClr val="20333F"/>
-                </a:solidFill>
-                <a:latin typeface="Helvetica Neue"/>
-                <a:ea typeface="Helvetica Neue"/>
-                <a:cs typeface="Helvetica Neue"/>
-              </a:defRPr>
-            </a:lvl7pPr>
-            <a:lvl8pPr>
-              <a:defRPr sz="2250" b="0">
-                <a:solidFill>
-                  <a:srgbClr val="20333F"/>
-                </a:solidFill>
-                <a:latin typeface="Helvetica Neue"/>
-                <a:ea typeface="Helvetica Neue"/>
-                <a:cs typeface="Helvetica Neue"/>
-              </a:defRPr>
-            </a:lvl8pPr>
-            <a:lvl9pPr>
-              <a:defRPr sz="2250" b="0">
-                <a:solidFill>
-                  <a:srgbClr val="20333F"/>
-                </a:solidFill>
-                <a:latin typeface="Helvetica Neue"/>
-                <a:ea typeface="Helvetica Neue"/>
-                <a:cs typeface="Helvetica Neue"/>
-              </a:defRPr>
-            </a:lvl9pPr>
-          </a:lstStyle>
-          <a:p xmlns:a="http://schemas.openxmlformats.org/drawingml/2006/main">
-            <a:pPr>
-              <a:defRPr sz="2250" b="0">
-                <a:solidFill>
-                  <a:srgbClr val="20333F"/>
-                </a:solidFill>
-                <a:latin typeface="Helvetica Neue"/>
-                <a:ea typeface="Helvetica Neue"/>
-                <a:cs typeface="Helvetica Neue"/>
-              </a:defRPr>
-            </a:pPr>
-            <a:r>
-              <a:rPr sz="2250" b="0">
-                <a:solidFill>
-                  <a:srgbClr val="20333F"/>
-                </a:solidFill>
-                <a:latin typeface="Helvetica Neue"/>
-                <a:ea typeface="Helvetica Neue"/>
-                <a:cs typeface="Helvetica Neue"/>
-              </a:rPr>
-              <a:t>Workflow: prepare data, extract features, train, validate, evaluate</a:t>
-            </a:r>
-          </a:p>
-        </p:txBody>
-      </p:sp>
-    </p:spTree>
-    <p:extLst>
-      <p:ext uri="{BB962C8B-B14F-4D97-AF65-F5344CB8AC3E}">
-        <p14:creationId xmlns:p14="http://schemas.microsoft.com/office/powerpoint/2010/main" val="1022174138"/>
-      </p:ext>
-    </p:extLst>
-  </p:cSld>
-</p:sld>
-</file>
-
-<file path=ppt/slides/slide15.xml><?xml version="1.0" encoding="utf-8"?>
-<p:sld xmlns:p="http://schemas.openxmlformats.org/presentationml/2006/main">
-  <p:cSld>
-    <p:bg>
-      <p:bgPr>
-        <a:solidFill xmlns:a="http://schemas.openxmlformats.org/drawingml/2006/main">
-          <a:srgbClr val="F8FAFB"/>
-        </a:solidFill>
-      </p:bgPr>
-    </p:bg>
-    <p:spTree>
-      <p:nvGrpSpPr>
-        <p:cNvPr id="1" name=""/>
-        <p:cNvGrpSpPr/>
-        <p:nvPr/>
-      </p:nvGrpSpPr>
-      <p:grpSpPr>
-        <a:xfrm xmlns:a="http://schemas.openxmlformats.org/drawingml/2006/main"/>
-      </p:grpSpPr>
-      <p:sp>
-        <p:nvSpPr>
-          <p:cNvPr id="5" name="">
-            <a:extLst xmlns:a="http://schemas.openxmlformats.org/drawingml/2006/main">
-              <a:ext uri="{FF2B5EF4-FFF2-40B4-BE49-F238E27FC236}">
-                <a16:creationId xmlns:a16="http://schemas.microsoft.com/office/drawing/2014/main" id="{D05AEB43-300C-4CA2-A34F-640C6E2521E3}"/>
-              </a:ext>
-            </a:extLst>
-          </p:cNvPr>
-          <p:cNvSpPr>
-            <a:spLocks xmlns:a="http://schemas.openxmlformats.org/drawingml/2006/main" noGrp="1"/>
-          </p:cNvSpPr>
-          <p:nvPr/>
-        </p:nvSpPr>
-        <p:spPr>
-          <a:xfrm xmlns:a="http://schemas.openxmlformats.org/drawingml/2006/main">
-            <a:off x="619125" y="419100"/>
-            <a:ext cx="10953750" cy="895350"/>
-          </a:xfrm>
-          <a:prstGeom xmlns:a="http://schemas.openxmlformats.org/drawingml/2006/main" prst="rect">
-            <a:avLst/>
-          </a:prstGeom>
-          <a:noFill xmlns:a="http://schemas.openxmlformats.org/drawingml/2006/main"/>
-          <a:ln xmlns:a="http://schemas.openxmlformats.org/drawingml/2006/main" w="0">
-            <a:noFill/>
-          </a:ln>
-        </p:spPr>
-        <p:txBody>
-          <a:bodyPr xmlns:a="http://schemas.openxmlformats.org/drawingml/2006/main"/>
-          <a:lstStyle xmlns:a="http://schemas.openxmlformats.org/drawingml/2006/main">
-            <a:defPPr>
-              <a:defRPr sz="3225" b="1">
-                <a:solidFill>
-                  <a:srgbClr val="102B3B"/>
-                </a:solidFill>
-                <a:latin typeface="Helvetica Neue"/>
-                <a:ea typeface="Helvetica Neue"/>
-                <a:cs typeface="Helvetica Neue"/>
-              </a:defRPr>
-            </a:defPPr>
-            <a:lvl1pPr>
-              <a:defRPr sz="3225" b="1">
-                <a:solidFill>
-                  <a:srgbClr val="102B3B"/>
-                </a:solidFill>
-                <a:latin typeface="Helvetica Neue"/>
-                <a:ea typeface="Helvetica Neue"/>
-                <a:cs typeface="Helvetica Neue"/>
-              </a:defRPr>
-            </a:lvl1pPr>
-            <a:lvl2pPr>
-              <a:defRPr sz="3225" b="1">
-                <a:solidFill>
-                  <a:srgbClr val="102B3B"/>
-                </a:solidFill>
-                <a:latin typeface="Helvetica Neue"/>
-                <a:ea typeface="Helvetica Neue"/>
-                <a:cs typeface="Helvetica Neue"/>
-              </a:defRPr>
-            </a:lvl2pPr>
-            <a:lvl3pPr>
-              <a:defRPr sz="3225" b="1">
-                <a:solidFill>
-                  <a:srgbClr val="102B3B"/>
-                </a:solidFill>
-                <a:latin typeface="Helvetica Neue"/>
-                <a:ea typeface="Helvetica Neue"/>
-                <a:cs typeface="Helvetica Neue"/>
-              </a:defRPr>
-            </a:lvl3pPr>
-            <a:lvl4pPr>
-              <a:defRPr sz="3225" b="1">
-                <a:solidFill>
-                  <a:srgbClr val="102B3B"/>
-                </a:solidFill>
-                <a:latin typeface="Helvetica Neue"/>
-                <a:ea typeface="Helvetica Neue"/>
-                <a:cs typeface="Helvetica Neue"/>
-              </a:defRPr>
-            </a:lvl4pPr>
-            <a:lvl5pPr>
-              <a:defRPr sz="3225" b="1">
-                <a:solidFill>
-                  <a:srgbClr val="102B3B"/>
-                </a:solidFill>
-                <a:latin typeface="Helvetica Neue"/>
-                <a:ea typeface="Helvetica Neue"/>
-                <a:cs typeface="Helvetica Neue"/>
-              </a:defRPr>
-            </a:lvl5pPr>
-            <a:lvl6pPr>
-              <a:defRPr sz="3225" b="1">
-                <a:solidFill>
-                  <a:srgbClr val="102B3B"/>
-                </a:solidFill>
-                <a:latin typeface="Helvetica Neue"/>
-                <a:ea typeface="Helvetica Neue"/>
-                <a:cs typeface="Helvetica Neue"/>
-              </a:defRPr>
-            </a:lvl6pPr>
-            <a:lvl7pPr>
-              <a:defRPr sz="3225" b="1">
-                <a:solidFill>
-                  <a:srgbClr val="102B3B"/>
-                </a:solidFill>
-                <a:latin typeface="Helvetica Neue"/>
-                <a:ea typeface="Helvetica Neue"/>
-                <a:cs typeface="Helvetica Neue"/>
-              </a:defRPr>
-            </a:lvl7pPr>
-            <a:lvl8pPr>
-              <a:defRPr sz="3225" b="1">
-                <a:solidFill>
-                  <a:srgbClr val="102B3B"/>
-                </a:solidFill>
-                <a:latin typeface="Helvetica Neue"/>
-                <a:ea typeface="Helvetica Neue"/>
-                <a:cs typeface="Helvetica Neue"/>
-              </a:defRPr>
-            </a:lvl8pPr>
-            <a:lvl9pPr>
-              <a:defRPr sz="3225" b="1">
-                <a:solidFill>
-                  <a:srgbClr val="102B3B"/>
-                </a:solidFill>
-                <a:latin typeface="Helvetica Neue"/>
-                <a:ea typeface="Helvetica Neue"/>
-                <a:cs typeface="Helvetica Neue"/>
-              </a:defRPr>
-            </a:lvl9pPr>
-          </a:lstStyle>
-          <a:p xmlns:a="http://schemas.openxmlformats.org/drawingml/2006/main">
-            <a:pPr>
-              <a:defRPr sz="3225" b="1">
-                <a:solidFill>
-                  <a:srgbClr val="102B3B"/>
-                </a:solidFill>
-                <a:latin typeface="Helvetica Neue"/>
-                <a:ea typeface="Helvetica Neue"/>
-                <a:cs typeface="Helvetica Neue"/>
-              </a:defRPr>
-            </a:pPr>
-            <a:r>
-              <a:rPr sz="3225" b="1">
-                <a:solidFill>
-                  <a:srgbClr val="102B3B"/>
-                </a:solidFill>
-                <a:latin typeface="Helvetica Neue"/>
-                <a:ea typeface="Helvetica Neue"/>
-                <a:cs typeface="Helvetica Neue"/>
-              </a:rPr>
-              <a:t>Project team</a:t>
-            </a:r>
-          </a:p>
-        </p:txBody>
-      </p:sp>
-      <p:sp>
-        <p:nvSpPr>
-          <p:cNvPr id="2" name="">
-            <a:extLst xmlns:a="http://schemas.openxmlformats.org/drawingml/2006/main">
-              <a:ext uri="{FF2B5EF4-FFF2-40B4-BE49-F238E27FC236}">
-                <a16:creationId xmlns:a16="http://schemas.microsoft.com/office/drawing/2014/main" id="{335CD2A9-D547-4EB0-BE3A-8449E0D8A417}"/>
-              </a:ext>
-            </a:extLst>
-          </p:cNvPr>
-          <p:cNvSpPr>
-            <a:spLocks xmlns:a="http://schemas.openxmlformats.org/drawingml/2006/main" noGrp="1"/>
-          </p:cNvSpPr>
-          <p:nvPr/>
-        </p:nvSpPr>
-        <p:spPr>
-          <a:xfrm xmlns:a="http://schemas.openxmlformats.org/drawingml/2006/main">
-            <a:off x="619125" y="6343650"/>
-            <a:ext cx="7620000" cy="228600"/>
-          </a:xfrm>
-          <a:prstGeom xmlns:a="http://schemas.openxmlformats.org/drawingml/2006/main" prst="rect">
-            <a:avLst/>
-          </a:prstGeom>
-          <a:noFill xmlns:a="http://schemas.openxmlformats.org/drawingml/2006/main"/>
-          <a:ln xmlns:a="http://schemas.openxmlformats.org/drawingml/2006/main" w="0">
-            <a:noFill/>
-          </a:ln>
-        </p:spPr>
-        <p:txBody>
-          <a:bodyPr xmlns:a="http://schemas.openxmlformats.org/drawingml/2006/main"/>
-          <a:lstStyle xmlns:a="http://schemas.openxmlformats.org/drawingml/2006/main">
-            <a:defPPr>
-              <a:defRPr sz="1200" b="0">
-                <a:solidFill>
-                  <a:srgbClr val="607582"/>
-                </a:solidFill>
-                <a:latin typeface="Helvetica Neue"/>
-                <a:ea typeface="Helvetica Neue"/>
-                <a:cs typeface="Helvetica Neue"/>
-              </a:defRPr>
-            </a:defPPr>
-            <a:lvl1pPr>
-              <a:defRPr sz="1200" b="0">
-                <a:solidFill>
-                  <a:srgbClr val="607582"/>
-                </a:solidFill>
-                <a:latin typeface="Helvetica Neue"/>
-                <a:ea typeface="Helvetica Neue"/>
-                <a:cs typeface="Helvetica Neue"/>
-              </a:defRPr>
-            </a:lvl1pPr>
-            <a:lvl2pPr>
-              <a:defRPr sz="1200" b="0">
-                <a:solidFill>
-                  <a:srgbClr val="607582"/>
-                </a:solidFill>
-                <a:latin typeface="Helvetica Neue"/>
-                <a:ea typeface="Helvetica Neue"/>
-                <a:cs typeface="Helvetica Neue"/>
-              </a:defRPr>
-            </a:lvl2pPr>
-            <a:lvl3pPr>
-              <a:defRPr sz="1200" b="0">
-                <a:solidFill>
-                  <a:srgbClr val="607582"/>
-                </a:solidFill>
-                <a:latin typeface="Helvetica Neue"/>
-                <a:ea typeface="Helvetica Neue"/>
-                <a:cs typeface="Helvetica Neue"/>
-              </a:defRPr>
-            </a:lvl3pPr>
-            <a:lvl4pPr>
-              <a:defRPr sz="1200" b="0">
-                <a:solidFill>
-                  <a:srgbClr val="607582"/>
-                </a:solidFill>
-                <a:latin typeface="Helvetica Neue"/>
-                <a:ea typeface="Helvetica Neue"/>
-                <a:cs typeface="Helvetica Neue"/>
-              </a:defRPr>
-            </a:lvl4pPr>
-            <a:lvl5pPr>
-              <a:defRPr sz="1200" b="0">
-                <a:solidFill>
-                  <a:srgbClr val="607582"/>
-                </a:solidFill>
-                <a:latin typeface="Helvetica Neue"/>
-                <a:ea typeface="Helvetica Neue"/>
-                <a:cs typeface="Helvetica Neue"/>
-              </a:defRPr>
-            </a:lvl5pPr>
-            <a:lvl6pPr>
-              <a:defRPr sz="1200" b="0">
-                <a:solidFill>
-                  <a:srgbClr val="607582"/>
-                </a:solidFill>
-                <a:latin typeface="Helvetica Neue"/>
-                <a:ea typeface="Helvetica Neue"/>
-                <a:cs typeface="Helvetica Neue"/>
-              </a:defRPr>
-            </a:lvl6pPr>
-            <a:lvl7pPr>
-              <a:defRPr sz="1200" b="0">
-                <a:solidFill>
-                  <a:srgbClr val="607582"/>
-                </a:solidFill>
-                <a:latin typeface="Helvetica Neue"/>
-                <a:ea typeface="Helvetica Neue"/>
-                <a:cs typeface="Helvetica Neue"/>
-              </a:defRPr>
-            </a:lvl7pPr>
-            <a:lvl8pPr>
-              <a:defRPr sz="1200" b="0">
-                <a:solidFill>
-                  <a:srgbClr val="607582"/>
-                </a:solidFill>
-                <a:latin typeface="Helvetica Neue"/>
-                <a:ea typeface="Helvetica Neue"/>
-                <a:cs typeface="Helvetica Neue"/>
-              </a:defRPr>
-            </a:lvl8pPr>
-            <a:lvl9pPr>
-              <a:defRPr sz="1200" b="0">
-                <a:solidFill>
-                  <a:srgbClr val="607582"/>
-                </a:solidFill>
-                <a:latin typeface="Helvetica Neue"/>
-                <a:ea typeface="Helvetica Neue"/>
-                <a:cs typeface="Helvetica Neue"/>
-              </a:defRPr>
-            </a:lvl9pPr>
-          </a:lstStyle>
-          <a:p xmlns:a="http://schemas.openxmlformats.org/drawingml/2006/main">
-            <a:pPr>
-              <a:defRPr sz="1200" b="0">
-                <a:solidFill>
-                  <a:srgbClr val="607582"/>
-                </a:solidFill>
-                <a:latin typeface="Helvetica Neue"/>
-                <a:ea typeface="Helvetica Neue"/>
-                <a:cs typeface="Helvetica Neue"/>
-              </a:defRPr>
-            </a:pPr>
-            <a:r>
-              <a:rPr sz="1200" b="0">
-                <a:solidFill>
-                  <a:srgbClr val="607582"/>
-                </a:solidFill>
-                <a:latin typeface="Helvetica Neue"/>
-                <a:ea typeface="Helvetica Neue"/>
-                <a:cs typeface="Helvetica Neue"/>
-              </a:rPr>
-              <a:t>PROJECT 11  /  PHASE 1</a:t>
-            </a:r>
-          </a:p>
-        </p:txBody>
-      </p:sp>
-      <p:sp>
-        <p:nvSpPr>
-          <p:cNvPr id="3" name="">
-            <a:extLst xmlns:a="http://schemas.openxmlformats.org/drawingml/2006/main">
-              <a:ext uri="{FF2B5EF4-FFF2-40B4-BE49-F238E27FC236}">
-                <a16:creationId xmlns:a16="http://schemas.microsoft.com/office/drawing/2014/main" id="{F485733D-6304-4A65-8749-46AF3282E526}"/>
-              </a:ext>
-            </a:extLst>
-          </p:cNvPr>
-          <p:cNvSpPr>
-            <a:spLocks xmlns:a="http://schemas.openxmlformats.org/drawingml/2006/main" noGrp="1"/>
-          </p:cNvSpPr>
-          <p:nvPr/>
-        </p:nvSpPr>
-        <p:spPr>
-          <a:xfrm xmlns:a="http://schemas.openxmlformats.org/drawingml/2006/main">
-            <a:off x="11049000" y="6343650"/>
-            <a:ext cx="666750" cy="228600"/>
-          </a:xfrm>
-          <a:prstGeom xmlns:a="http://schemas.openxmlformats.org/drawingml/2006/main" prst="rect">
-            <a:avLst/>
-          </a:prstGeom>
-          <a:noFill xmlns:a="http://schemas.openxmlformats.org/drawingml/2006/main"/>
-          <a:ln xmlns:a="http://schemas.openxmlformats.org/drawingml/2006/main" w="0">
-            <a:noFill/>
-          </a:ln>
-        </p:spPr>
-        <p:txBody>
-          <a:bodyPr xmlns:a="http://schemas.openxmlformats.org/drawingml/2006/main"/>
-          <a:lstStyle xmlns:a="http://schemas.openxmlformats.org/drawingml/2006/main">
-            <a:defPPr>
-              <a:defRPr sz="1200" b="0">
-                <a:solidFill>
-                  <a:srgbClr val="607582"/>
-                </a:solidFill>
-                <a:latin typeface="Helvetica Neue"/>
-                <a:ea typeface="Helvetica Neue"/>
-                <a:cs typeface="Helvetica Neue"/>
-              </a:defRPr>
-            </a:defPPr>
-            <a:lvl1pPr>
-              <a:defRPr sz="1200" b="0">
-                <a:solidFill>
-                  <a:srgbClr val="607582"/>
-                </a:solidFill>
-                <a:latin typeface="Helvetica Neue"/>
-                <a:ea typeface="Helvetica Neue"/>
-                <a:cs typeface="Helvetica Neue"/>
-              </a:defRPr>
-            </a:lvl1pPr>
-            <a:lvl2pPr>
-              <a:defRPr sz="1200" b="0">
-                <a:solidFill>
-                  <a:srgbClr val="607582"/>
-                </a:solidFill>
-                <a:latin typeface="Helvetica Neue"/>
-                <a:ea typeface="Helvetica Neue"/>
-                <a:cs typeface="Helvetica Neue"/>
-              </a:defRPr>
-            </a:lvl2pPr>
-            <a:lvl3pPr>
-              <a:defRPr sz="1200" b="0">
-                <a:solidFill>
-                  <a:srgbClr val="607582"/>
-                </a:solidFill>
-                <a:latin typeface="Helvetica Neue"/>
-                <a:ea typeface="Helvetica Neue"/>
-                <a:cs typeface="Helvetica Neue"/>
-              </a:defRPr>
-            </a:lvl3pPr>
-            <a:lvl4pPr>
-              <a:defRPr sz="1200" b="0">
-                <a:solidFill>
-                  <a:srgbClr val="607582"/>
-                </a:solidFill>
-                <a:latin typeface="Helvetica Neue"/>
-                <a:ea typeface="Helvetica Neue"/>
-                <a:cs typeface="Helvetica Neue"/>
-              </a:defRPr>
-            </a:lvl4pPr>
-            <a:lvl5pPr>
-              <a:defRPr sz="1200" b="0">
-                <a:solidFill>
-                  <a:srgbClr val="607582"/>
-                </a:solidFill>
-                <a:latin typeface="Helvetica Neue"/>
-                <a:ea typeface="Helvetica Neue"/>
-                <a:cs typeface="Helvetica Neue"/>
-              </a:defRPr>
-            </a:lvl5pPr>
-            <a:lvl6pPr>
-              <a:defRPr sz="1200" b="0">
-                <a:solidFill>
-                  <a:srgbClr val="607582"/>
-                </a:solidFill>
-                <a:latin typeface="Helvetica Neue"/>
-                <a:ea typeface="Helvetica Neue"/>
-                <a:cs typeface="Helvetica Neue"/>
-              </a:defRPr>
-            </a:lvl6pPr>
-            <a:lvl7pPr>
-              <a:defRPr sz="1200" b="0">
-                <a:solidFill>
-                  <a:srgbClr val="607582"/>
-                </a:solidFill>
-                <a:latin typeface="Helvetica Neue"/>
-                <a:ea typeface="Helvetica Neue"/>
-                <a:cs typeface="Helvetica Neue"/>
-              </a:defRPr>
-            </a:lvl7pPr>
-            <a:lvl8pPr>
-              <a:defRPr sz="1200" b="0">
-                <a:solidFill>
-                  <a:srgbClr val="607582"/>
-                </a:solidFill>
-                <a:latin typeface="Helvetica Neue"/>
-                <a:ea typeface="Helvetica Neue"/>
-                <a:cs typeface="Helvetica Neue"/>
-              </a:defRPr>
-            </a:lvl8pPr>
-            <a:lvl9pPr>
-              <a:defRPr sz="1200" b="0">
-                <a:solidFill>
-                  <a:srgbClr val="607582"/>
-                </a:solidFill>
-                <a:latin typeface="Helvetica Neue"/>
-                <a:ea typeface="Helvetica Neue"/>
-                <a:cs typeface="Helvetica Neue"/>
-              </a:defRPr>
-            </a:lvl9pPr>
-          </a:lstStyle>
-          <a:p xmlns:a="http://schemas.openxmlformats.org/drawingml/2006/main">
-            <a:pPr>
-              <a:defRPr sz="1200" b="0">
-                <a:solidFill>
-                  <a:srgbClr val="607582"/>
-                </a:solidFill>
-                <a:latin typeface="Helvetica Neue"/>
-                <a:ea typeface="Helvetica Neue"/>
-                <a:cs typeface="Helvetica Neue"/>
-              </a:defRPr>
-            </a:pPr>
-            <a:r>
-              <a:rPr sz="1200" b="0">
-                <a:solidFill>
-                  <a:srgbClr val="607582"/>
-                </a:solidFill>
-                <a:latin typeface="Helvetica Neue"/>
-                <a:ea typeface="Helvetica Neue"/>
-                <a:cs typeface="Helvetica Neue"/>
-              </a:rPr>
-              <a:t>15</a:t>
-            </a:r>
-          </a:p>
-        </p:txBody>
-      </p:sp>
-      <p:graphicFrame>
-        <p:nvGraphicFramePr>
-          <p:cNvPr id="4" name="">
-            <a:extLst xmlns:a="http://schemas.openxmlformats.org/drawingml/2006/main">
-              <a:ext uri="{FF2B5EF4-FFF2-40B4-BE49-F238E27FC236}">
-                <a16:creationId xmlns:a16="http://schemas.microsoft.com/office/drawing/2014/main" id="{36A3A457-0341-4835-AF26-5CE5935DF27B}"/>
-              </a:ext>
-            </a:extLst>
-          </p:cNvPr>
-          <p:cNvGraphicFramePr/>
-          <p:nvPr/>
-        </p:nvGraphicFramePr>
-        <p:xfrm>
-          <a:off xmlns:a="http://schemas.openxmlformats.org/drawingml/2006/main" x="714375" y="1428750"/>
-          <a:ext xmlns:a="http://schemas.openxmlformats.org/drawingml/2006/main" cx="10715625" cy="3905250"/>
-        </p:xfrm>
-        <a:graphic xmlns:a="http://schemas.openxmlformats.org/drawingml/2006/main">
-          <a:graphicData uri="http://schemas.openxmlformats.org/drawingml/2006/table">
-            <a:tbl>
-              <a:tblPr/>
-              <a:tblGrid>
-                <a:gridCol w="7143750"/>
-                <a:gridCol w="3571875"/>
-              </a:tblGrid>
-              <a:tr h="650875">
-                <a:tc>
-                  <a:txBody>
-                    <a:bodyPr/>
-                    <a:lstStyle/>
-                    <a:p>
-                      <a:r>
-                        <a:rPr sz="1800" b="1">
-                          <a:solidFill>
-                            <a:srgbClr val="FFFFFF"/>
-                          </a:solidFill>
-                          <a:latin typeface="Helvetica Neue"/>
-                          <a:ea typeface="Helvetica Neue"/>
-                          <a:cs typeface="Helvetica Neue"/>
-                        </a:rPr>
-                        <a:t>Member</a:t>
-                      </a:r>
-                    </a:p>
-                  </a:txBody>
-                  <a:tcPr marL="91440" marR="91440" marT="45720" marB="45720">
-                    <a:solidFill>
-                      <a:srgbClr val="185B70"/>
-                    </a:solidFill>
-                  </a:tcPr>
-                </a:tc>
-                <a:tc>
-                  <a:txBody>
-                    <a:bodyPr/>
-                    <a:lstStyle/>
-                    <a:p>
-                      <a:r>
-                        <a:rPr sz="1800" b="1">
-                          <a:solidFill>
-                            <a:srgbClr val="FFFFFF"/>
-                          </a:solidFill>
-                          <a:latin typeface="Helvetica Neue"/>
-                          <a:ea typeface="Helvetica Neue"/>
-                          <a:cs typeface="Helvetica Neue"/>
-                        </a:rPr>
-                        <a:t>Enrolment</a:t>
-                      </a:r>
-                    </a:p>
-                  </a:txBody>
-                  <a:tcPr marL="91440" marR="91440" marT="45720" marB="45720">
-                    <a:solidFill>
-                      <a:srgbClr val="185B70"/>
-                    </a:solidFill>
-                  </a:tcPr>
-                </a:tc>
-              </a:tr>
-              <a:tr h="650875">
-                <a:tc>
-                  <a:txBody>
-                    <a:bodyPr/>
-                    <a:lstStyle/>
-                    <a:p>
-                      <a:r>
-                        <a:rPr sz="1800" b="0">
-                          <a:solidFill>
-                            <a:srgbClr val="20333F"/>
-                          </a:solidFill>
-                          <a:latin typeface="Helvetica Neue"/>
-                          <a:ea typeface="Helvetica Neue"/>
-                          <a:cs typeface="Helvetica Neue"/>
-                        </a:rPr>
-                        <a:t>Aryan</a:t>
-                      </a:r>
-                    </a:p>
-                  </a:txBody>
-                  <a:tcPr marL="91440" marR="91440" marT="45720" marB="45720">
-                    <a:solidFill>
-                      <a:srgbClr val="EDF3F5"/>
-                    </a:solidFill>
-                  </a:tcPr>
-                </a:tc>
-                <a:tc>
-                  <a:txBody>
-                    <a:bodyPr/>
-                    <a:lstStyle/>
-                    <a:p>
-                      <a:r>
-                        <a:rPr sz="1800" b="0">
-                          <a:solidFill>
-                            <a:srgbClr val="20333F"/>
-                          </a:solidFill>
-                          <a:latin typeface="Helvetica Neue"/>
-                          <a:ea typeface="Helvetica Neue"/>
-                          <a:cs typeface="Helvetica Neue"/>
-                        </a:rPr>
-                        <a:t>2401020013</a:t>
-                      </a:r>
-                    </a:p>
-                  </a:txBody>
-                  <a:tcPr marL="91440" marR="91440" marT="45720" marB="45720">
-                    <a:solidFill>
-                      <a:srgbClr val="EDF3F5"/>
-                    </a:solidFill>
-                  </a:tcPr>
-                </a:tc>
-              </a:tr>
-              <a:tr h="650875">
-                <a:tc>
-                  <a:txBody>
-                    <a:bodyPr/>
-                    <a:lstStyle/>
-                    <a:p>
-                      <a:r>
-                        <a:rPr sz="1800" b="0">
-                          <a:solidFill>
-                            <a:srgbClr val="20333F"/>
-                          </a:solidFill>
-                          <a:latin typeface="Helvetica Neue"/>
-                          <a:ea typeface="Helvetica Neue"/>
-                          <a:cs typeface="Helvetica Neue"/>
-                        </a:rPr>
-                        <a:t>Divyanshu Singh</a:t>
-                      </a:r>
-                    </a:p>
-                  </a:txBody>
-                  <a:tcPr marL="91440" marR="91440" marT="45720" marB="45720">
-                    <a:solidFill>
-                      <a:srgbClr val="FFFFFF"/>
-                    </a:solidFill>
-                  </a:tcPr>
-                </a:tc>
-                <a:tc>
-                  <a:txBody>
-                    <a:bodyPr/>
-                    <a:lstStyle/>
-                    <a:p>
-                      <a:r>
-                        <a:rPr sz="1800" b="0">
-                          <a:solidFill>
-                            <a:srgbClr val="20333F"/>
-                          </a:solidFill>
-                          <a:latin typeface="Helvetica Neue"/>
-                          <a:ea typeface="Helvetica Neue"/>
-                          <a:cs typeface="Helvetica Neue"/>
-                        </a:rPr>
-                        <a:t>2401010161</a:t>
-                      </a:r>
-                    </a:p>
-                  </a:txBody>
-                  <a:tcPr marL="91440" marR="91440" marT="45720" marB="45720">
-                    <a:solidFill>
-                      <a:srgbClr val="FFFFFF"/>
-                    </a:solidFill>
-                  </a:tcPr>
-                </a:tc>
-              </a:tr>
-              <a:tr h="650875">
-                <a:tc>
-                  <a:txBody>
-                    <a:bodyPr/>
-                    <a:lstStyle/>
-                    <a:p>
-                      <a:r>
-                        <a:rPr sz="1800" b="0">
-                          <a:solidFill>
-                            <a:srgbClr val="20333F"/>
-                          </a:solidFill>
-                          <a:latin typeface="Helvetica Neue"/>
-                          <a:ea typeface="Helvetica Neue"/>
-                          <a:cs typeface="Helvetica Neue"/>
-                        </a:rPr>
-                        <a:t>Jatin Kumar Singh</a:t>
-                      </a:r>
-                    </a:p>
-                  </a:txBody>
-                  <a:tcPr marL="91440" marR="91440" marT="45720" marB="45720">
-                    <a:solidFill>
-                      <a:srgbClr val="EDF3F5"/>
-                    </a:solidFill>
-                  </a:tcPr>
-                </a:tc>
-                <a:tc>
-                  <a:txBody>
-                    <a:bodyPr/>
-                    <a:lstStyle/>
-                    <a:p>
-                      <a:r>
-                        <a:rPr sz="1800" b="0">
-                          <a:solidFill>
-                            <a:srgbClr val="20333F"/>
-                          </a:solidFill>
-                          <a:latin typeface="Helvetica Neue"/>
-                          <a:ea typeface="Helvetica Neue"/>
-                          <a:cs typeface="Helvetica Neue"/>
-                        </a:rPr>
-                        <a:t>2401010199</a:t>
-                      </a:r>
-                    </a:p>
-                  </a:txBody>
-                  <a:tcPr marL="91440" marR="91440" marT="45720" marB="45720">
-                    <a:solidFill>
-                      <a:srgbClr val="EDF3F5"/>
-                    </a:solidFill>
-                  </a:tcPr>
-                </a:tc>
-              </a:tr>
-              <a:tr h="650875">
-                <a:tc>
-                  <a:txBody>
-                    <a:bodyPr/>
-                    <a:lstStyle/>
-                    <a:p>
-                      <a:r>
-                        <a:rPr sz="1800" b="0">
-                          <a:solidFill>
-                            <a:srgbClr val="20333F"/>
-                          </a:solidFill>
-                          <a:latin typeface="Helvetica Neue"/>
-                          <a:ea typeface="Helvetica Neue"/>
-                          <a:cs typeface="Helvetica Neue"/>
-                        </a:rPr>
-                        <a:t>Jatin Verma</a:t>
-                      </a:r>
-                    </a:p>
-                  </a:txBody>
-                  <a:tcPr marL="91440" marR="91440" marT="45720" marB="45720">
-                    <a:solidFill>
-                      <a:srgbClr val="FFFFFF"/>
-                    </a:solidFill>
-                  </a:tcPr>
-                </a:tc>
-                <a:tc>
-                  <a:txBody>
-                    <a:bodyPr/>
-                    <a:lstStyle/>
-                    <a:p>
-                      <a:r>
-                        <a:rPr sz="1800" b="0">
-                          <a:solidFill>
-                            <a:srgbClr val="20333F"/>
-                          </a:solidFill>
-                          <a:latin typeface="Helvetica Neue"/>
-                          <a:ea typeface="Helvetica Neue"/>
-                          <a:cs typeface="Helvetica Neue"/>
-                        </a:rPr>
-                        <a:t>2401010200</a:t>
-                      </a:r>
-                    </a:p>
-                  </a:txBody>
-                  <a:tcPr marL="91440" marR="91440" marT="45720" marB="45720">
-                    <a:solidFill>
-                      <a:srgbClr val="FFFFFF"/>
-                    </a:solidFill>
-                  </a:tcPr>
-                </a:tc>
-              </a:tr>
-              <a:tr h="650875">
-                <a:tc>
-                  <a:txBody>
-                    <a:bodyPr/>
-                    <a:lstStyle/>
-                    <a:p>
-                      <a:r>
-                        <a:rPr sz="1800" b="0">
-                          <a:solidFill>
-                            <a:srgbClr val="20333F"/>
-                          </a:solidFill>
-                          <a:latin typeface="Helvetica Neue"/>
-                          <a:ea typeface="Helvetica Neue"/>
-                          <a:cs typeface="Helvetica Neue"/>
-                        </a:rPr>
-                        <a:t>Kushagra Bhardwaj</a:t>
-                      </a:r>
-                    </a:p>
-                  </a:txBody>
-                  <a:tcPr marL="91440" marR="91440" marT="45720" marB="45720">
-                    <a:solidFill>
-                      <a:srgbClr val="EDF3F5"/>
-                    </a:solidFill>
-                  </a:tcPr>
-                </a:tc>
-                <a:tc>
-                  <a:txBody>
-                    <a:bodyPr/>
-                    <a:lstStyle/>
-                    <a:p>
-                      <a:r>
-                        <a:rPr sz="1800" b="0">
-                          <a:solidFill>
-                            <a:srgbClr val="20333F"/>
-                          </a:solidFill>
-                          <a:latin typeface="Helvetica Neue"/>
-                          <a:ea typeface="Helvetica Neue"/>
-                          <a:cs typeface="Helvetica Neue"/>
-                        </a:rPr>
-                        <a:t>2401010247</a:t>
-                      </a:r>
-                    </a:p>
-                  </a:txBody>
-                  <a:tcPr marL="91440" marR="91440" marT="45720" marB="45720">
-                    <a:solidFill>
-                      <a:srgbClr val="EDF3F5"/>
-                    </a:solidFill>
-                  </a:tcPr>
-                </a:tc>
-              </a:tr>
-            </a:tbl>
-          </a:graphicData>
-        </a:graphic>
-      </p:graphicFrame>
-    </p:spTree>
-    <p:extLst>
-      <p:ext uri="{BB962C8B-B14F-4D97-AF65-F5344CB8AC3E}">
-        <p14:creationId xmlns:p14="http://schemas.microsoft.com/office/powerpoint/2010/main" val="1568292151"/>
+        <p14:creationId xmlns:p14="http://schemas.microsoft.com/office/powerpoint/2010/main" val="1899680780"/>
       </p:ext>
     </p:extLst>
   </p:cSld>
@@ -11265,7 +9177,7 @@
           <p:cNvPr id="8" name="">
             <a:extLst xmlns:a="http://schemas.openxmlformats.org/drawingml/2006/main">
               <a:ext uri="{FF2B5EF4-FFF2-40B4-BE49-F238E27FC236}">
-                <a16:creationId xmlns:a16="http://schemas.microsoft.com/office/drawing/2014/main" id="{08FC1744-592A-4E74-8FA0-2FCB579B69B7}"/>
+                <a16:creationId xmlns:a16="http://schemas.microsoft.com/office/drawing/2014/main" id="{56FCCC4D-E47F-4FB7-BE96-4E4D64E04F70}"/>
               </a:ext>
             </a:extLst>
           </p:cNvPr>
@@ -11421,7 +9333,7 @@
           <p:cNvPr id="2" name="">
             <a:extLst xmlns:a="http://schemas.openxmlformats.org/drawingml/2006/main">
               <a:ext uri="{FF2B5EF4-FFF2-40B4-BE49-F238E27FC236}">
-                <a16:creationId xmlns:a16="http://schemas.microsoft.com/office/drawing/2014/main" id="{FB5F2F3C-86D1-4D90-B3D8-81A2E980604B}"/>
+                <a16:creationId xmlns:a16="http://schemas.microsoft.com/office/drawing/2014/main" id="{5BDE9F9C-F9AF-4ABE-A0F0-0E4FC6C0B52E}"/>
               </a:ext>
             </a:extLst>
           </p:cNvPr>
@@ -11577,7 +9489,7 @@
           <p:cNvPr id="3" name="">
             <a:extLst xmlns:a="http://schemas.openxmlformats.org/drawingml/2006/main">
               <a:ext uri="{FF2B5EF4-FFF2-40B4-BE49-F238E27FC236}">
-                <a16:creationId xmlns:a16="http://schemas.microsoft.com/office/drawing/2014/main" id="{A037DABF-F3BE-4AD7-813E-6337C24F8D94}"/>
+                <a16:creationId xmlns:a16="http://schemas.microsoft.com/office/drawing/2014/main" id="{D4FFA1DC-CDEB-4172-9111-F50B51EAE095}"/>
               </a:ext>
             </a:extLst>
           </p:cNvPr>
@@ -11733,7 +9645,7 @@
           <p:cNvPr id="4" name="">
             <a:extLst xmlns:a="http://schemas.openxmlformats.org/drawingml/2006/main">
               <a:ext uri="{FF2B5EF4-FFF2-40B4-BE49-F238E27FC236}">
-                <a16:creationId xmlns:a16="http://schemas.microsoft.com/office/drawing/2014/main" id="{A69631D8-9FA2-43FF-BECC-AA3C7FB8AE74}"/>
+                <a16:creationId xmlns:a16="http://schemas.microsoft.com/office/drawing/2014/main" id="{1D141734-9955-4BD8-8F03-A16AD423ED2B}"/>
               </a:ext>
             </a:extLst>
           </p:cNvPr>
@@ -11889,7 +9801,7 @@
           <p:cNvPr id="5" name="">
             <a:extLst xmlns:a="http://schemas.openxmlformats.org/drawingml/2006/main">
               <a:ext uri="{FF2B5EF4-FFF2-40B4-BE49-F238E27FC236}">
-                <a16:creationId xmlns:a16="http://schemas.microsoft.com/office/drawing/2014/main" id="{BE090D72-7F77-45B7-9EBD-EF82CBA52DFF}"/>
+                <a16:creationId xmlns:a16="http://schemas.microsoft.com/office/drawing/2014/main" id="{0CAE8EE5-FA2C-41BB-9BC7-395DE953A4BB}"/>
               </a:ext>
             </a:extLst>
           </p:cNvPr>
@@ -12045,7 +9957,7 @@
           <p:cNvPr id="6" name="">
             <a:extLst xmlns:a="http://schemas.openxmlformats.org/drawingml/2006/main">
               <a:ext uri="{FF2B5EF4-FFF2-40B4-BE49-F238E27FC236}">
-                <a16:creationId xmlns:a16="http://schemas.microsoft.com/office/drawing/2014/main" id="{4272E9A8-06FE-4CD8-BDC0-3D0413358958}"/>
+                <a16:creationId xmlns:a16="http://schemas.microsoft.com/office/drawing/2014/main" id="{9F86B1B0-CEE6-46A0-A1A1-A02531EF380A}"/>
               </a:ext>
             </a:extLst>
           </p:cNvPr>
@@ -12201,7 +10113,7 @@
           <p:cNvPr id="7" name="">
             <a:extLst xmlns:a="http://schemas.openxmlformats.org/drawingml/2006/main">
               <a:ext uri="{FF2B5EF4-FFF2-40B4-BE49-F238E27FC236}">
-                <a16:creationId xmlns:a16="http://schemas.microsoft.com/office/drawing/2014/main" id="{CA5CA6BC-8D3E-4BFD-8F2A-8CBE7FB0ED2A}"/>
+                <a16:creationId xmlns:a16="http://schemas.microsoft.com/office/drawing/2014/main" id="{68761241-F3C4-4B0F-ADEC-B4A750A568D5}"/>
               </a:ext>
             </a:extLst>
           </p:cNvPr>
@@ -12355,7 +10267,7 @@
     </p:spTree>
     <p:extLst>
       <p:ext uri="{BB962C8B-B14F-4D97-AF65-F5344CB8AC3E}">
-        <p14:creationId xmlns:p14="http://schemas.microsoft.com/office/powerpoint/2010/main" val="1309732048"/>
+        <p14:creationId xmlns:p14="http://schemas.microsoft.com/office/powerpoint/2010/main" val="1913136787"/>
       </p:ext>
     </p:extLst>
   </p:cSld>
@@ -12386,7 +10298,7 @@
           <p:cNvPr id="7" name="">
             <a:extLst xmlns:a="http://schemas.openxmlformats.org/drawingml/2006/main">
               <a:ext uri="{FF2B5EF4-FFF2-40B4-BE49-F238E27FC236}">
-                <a16:creationId xmlns:a16="http://schemas.microsoft.com/office/drawing/2014/main" id="{FD01F48F-9DAE-433B-8853-10B06BBF9F8B}"/>
+                <a16:creationId xmlns:a16="http://schemas.microsoft.com/office/drawing/2014/main" id="{0FEECF1F-B9B0-4A45-9D7E-1E87D05FA504}"/>
               </a:ext>
             </a:extLst>
           </p:cNvPr>
@@ -12542,7 +10454,7 @@
           <p:cNvPr id="2" name="">
             <a:extLst xmlns:a="http://schemas.openxmlformats.org/drawingml/2006/main">
               <a:ext uri="{FF2B5EF4-FFF2-40B4-BE49-F238E27FC236}">
-                <a16:creationId xmlns:a16="http://schemas.microsoft.com/office/drawing/2014/main" id="{C7393192-4A40-4099-B038-8FEFCAAE5218}"/>
+                <a16:creationId xmlns:a16="http://schemas.microsoft.com/office/drawing/2014/main" id="{C7EBD208-8D49-44FA-98D7-C30D4361478A}"/>
               </a:ext>
             </a:extLst>
           </p:cNvPr>
@@ -12698,7 +10610,7 @@
           <p:cNvPr id="3" name="">
             <a:extLst xmlns:a="http://schemas.openxmlformats.org/drawingml/2006/main">
               <a:ext uri="{FF2B5EF4-FFF2-40B4-BE49-F238E27FC236}">
-                <a16:creationId xmlns:a16="http://schemas.microsoft.com/office/drawing/2014/main" id="{7070639F-C800-4887-B059-47C81E5E421F}"/>
+                <a16:creationId xmlns:a16="http://schemas.microsoft.com/office/drawing/2014/main" id="{CFC49D1D-EAB3-4FFA-8EB6-6C0E2B72943E}"/>
               </a:ext>
             </a:extLst>
           </p:cNvPr>
@@ -12854,7 +10766,7 @@
           <p:cNvPr id="4" name="">
             <a:extLst xmlns:a="http://schemas.openxmlformats.org/drawingml/2006/main">
               <a:ext uri="{FF2B5EF4-FFF2-40B4-BE49-F238E27FC236}">
-                <a16:creationId xmlns:a16="http://schemas.microsoft.com/office/drawing/2014/main" id="{9458454B-10BA-4BDF-9123-40DE7007F69A}"/>
+                <a16:creationId xmlns:a16="http://schemas.microsoft.com/office/drawing/2014/main" id="{6557B232-45CD-4022-96C5-18D8D736D9D8}"/>
               </a:ext>
             </a:extLst>
           </p:cNvPr>
@@ -13179,7 +11091,7 @@
           <p:cNvPr id="5" name="">
             <a:extLst xmlns:a="http://schemas.openxmlformats.org/drawingml/2006/main">
               <a:ext uri="{FF2B5EF4-FFF2-40B4-BE49-F238E27FC236}">
-                <a16:creationId xmlns:a16="http://schemas.microsoft.com/office/drawing/2014/main" id="{6C774D4F-69FF-44A3-AFDB-7BC2D2789D56}"/>
+                <a16:creationId xmlns:a16="http://schemas.microsoft.com/office/drawing/2014/main" id="{B046D777-9C7E-4665-A48E-122E4A97CDE8}"/>
               </a:ext>
             </a:extLst>
           </p:cNvPr>
@@ -13335,7 +11247,7 @@
           <p:cNvPr id="6" name="">
             <a:extLst xmlns:a="http://schemas.openxmlformats.org/drawingml/2006/main">
               <a:ext uri="{FF2B5EF4-FFF2-40B4-BE49-F238E27FC236}">
-                <a16:creationId xmlns:a16="http://schemas.microsoft.com/office/drawing/2014/main" id="{55ECD241-6B8C-42A3-9FC3-89D404E485A6}"/>
+                <a16:creationId xmlns:a16="http://schemas.microsoft.com/office/drawing/2014/main" id="{1A29EECB-9BCF-4794-926C-CD1B60203EE7}"/>
               </a:ext>
             </a:extLst>
           </p:cNvPr>
@@ -13489,7 +11401,7 @@
     </p:spTree>
     <p:extLst>
       <p:ext uri="{BB962C8B-B14F-4D97-AF65-F5344CB8AC3E}">
-        <p14:creationId xmlns:p14="http://schemas.microsoft.com/office/powerpoint/2010/main" val="393759607"/>
+        <p14:creationId xmlns:p14="http://schemas.microsoft.com/office/powerpoint/2010/main" val="788760010"/>
       </p:ext>
     </p:extLst>
   </p:cSld>
@@ -13520,7 +11432,7 @@
           <p:cNvPr id="5" name="">
             <a:extLst xmlns:a="http://schemas.openxmlformats.org/drawingml/2006/main">
               <a:ext uri="{FF2B5EF4-FFF2-40B4-BE49-F238E27FC236}">
-                <a16:creationId xmlns:a16="http://schemas.microsoft.com/office/drawing/2014/main" id="{F1B6A529-AD24-4FC8-B8CF-AB89DAF204B3}"/>
+                <a16:creationId xmlns:a16="http://schemas.microsoft.com/office/drawing/2014/main" id="{A03E9A26-4AD4-41A6-8D0D-25E338D01339}"/>
               </a:ext>
             </a:extLst>
           </p:cNvPr>
@@ -13676,7 +11588,7 @@
           <p:cNvPr id="2" name="">
             <a:extLst xmlns:a="http://schemas.openxmlformats.org/drawingml/2006/main">
               <a:ext uri="{FF2B5EF4-FFF2-40B4-BE49-F238E27FC236}">
-                <a16:creationId xmlns:a16="http://schemas.microsoft.com/office/drawing/2014/main" id="{1D702444-E491-4882-881B-135B8FA4A416}"/>
+                <a16:creationId xmlns:a16="http://schemas.microsoft.com/office/drawing/2014/main" id="{501A2D03-B10D-48E4-9A7A-1B10076E272D}"/>
               </a:ext>
             </a:extLst>
           </p:cNvPr>
@@ -13832,7 +11744,7 @@
           <p:cNvPr id="3" name="">
             <a:extLst xmlns:a="http://schemas.openxmlformats.org/drawingml/2006/main">
               <a:ext uri="{FF2B5EF4-FFF2-40B4-BE49-F238E27FC236}">
-                <a16:creationId xmlns:a16="http://schemas.microsoft.com/office/drawing/2014/main" id="{59E37809-E7BE-4D98-81FF-710A79BC3F08}"/>
+                <a16:creationId xmlns:a16="http://schemas.microsoft.com/office/drawing/2014/main" id="{A0BEA951-E657-4F88-B82E-66386780E89D}"/>
               </a:ext>
             </a:extLst>
           </p:cNvPr>
@@ -13988,7 +11900,7 @@
           <p:cNvPr id="4" name="">
             <a:extLst xmlns:a="http://schemas.openxmlformats.org/drawingml/2006/main">
               <a:ext uri="{FF2B5EF4-FFF2-40B4-BE49-F238E27FC236}">
-                <a16:creationId xmlns:a16="http://schemas.microsoft.com/office/drawing/2014/main" id="{F0B5F1DA-F910-457F-AA7B-BDB6F0A579E7}"/>
+                <a16:creationId xmlns:a16="http://schemas.microsoft.com/office/drawing/2014/main" id="{D58F431D-6DB7-4D68-9593-12977D4A81A6}"/>
               </a:ext>
             </a:extLst>
           </p:cNvPr>
@@ -13998,7 +11910,7 @@
           <p:nvPr/>
         </p:nvPicPr>
         <p:blipFill>
-          <a:blip xmlns:r="http://schemas.openxmlformats.org/officeDocument/2006/relationships" xmlns:a="http://schemas.openxmlformats.org/drawingml/2006/main" r:embed="R4c6109ac88834e96"/>
+          <a:blip xmlns:r="http://schemas.openxmlformats.org/officeDocument/2006/relationships" xmlns:a="http://schemas.openxmlformats.org/drawingml/2006/main" r:embed="R1ded62c9db224209"/>
           <a:stretch xmlns:a="http://schemas.openxmlformats.org/drawingml/2006/main"/>
         </p:blipFill>
         <p:spPr>
@@ -14014,7 +11926,7 @@
     </p:spTree>
     <p:extLst>
       <p:ext uri="{BB962C8B-B14F-4D97-AF65-F5344CB8AC3E}">
-        <p14:creationId xmlns:p14="http://schemas.microsoft.com/office/powerpoint/2010/main" val="1958773850"/>
+        <p14:creationId xmlns:p14="http://schemas.microsoft.com/office/powerpoint/2010/main" val="2089997890"/>
       </p:ext>
     </p:extLst>
   </p:cSld>
@@ -14045,7 +11957,7 @@
           <p:cNvPr id="8" name="">
             <a:extLst xmlns:a="http://schemas.openxmlformats.org/drawingml/2006/main">
               <a:ext uri="{FF2B5EF4-FFF2-40B4-BE49-F238E27FC236}">
-                <a16:creationId xmlns:a16="http://schemas.microsoft.com/office/drawing/2014/main" id="{64EE1991-E518-44A0-A6E3-5C9B1DB6B174}"/>
+                <a16:creationId xmlns:a16="http://schemas.microsoft.com/office/drawing/2014/main" id="{04CCA84B-73FD-4625-9276-F4B685302D0F}"/>
               </a:ext>
             </a:extLst>
           </p:cNvPr>
@@ -14201,7 +12113,7 @@
           <p:cNvPr id="2" name="">
             <a:extLst xmlns:a="http://schemas.openxmlformats.org/drawingml/2006/main">
               <a:ext uri="{FF2B5EF4-FFF2-40B4-BE49-F238E27FC236}">
-                <a16:creationId xmlns:a16="http://schemas.microsoft.com/office/drawing/2014/main" id="{A69411A2-9C70-4A9D-9CC6-CD2820D14E12}"/>
+                <a16:creationId xmlns:a16="http://schemas.microsoft.com/office/drawing/2014/main" id="{0C29F190-331F-40F5-8246-2554673D0FEC}"/>
               </a:ext>
             </a:extLst>
           </p:cNvPr>
@@ -14357,7 +12269,7 @@
           <p:cNvPr id="3" name="">
             <a:extLst xmlns:a="http://schemas.openxmlformats.org/drawingml/2006/main">
               <a:ext uri="{FF2B5EF4-FFF2-40B4-BE49-F238E27FC236}">
-                <a16:creationId xmlns:a16="http://schemas.microsoft.com/office/drawing/2014/main" id="{6F6C27E9-EA15-4799-9781-1774D6609D19}"/>
+                <a16:creationId xmlns:a16="http://schemas.microsoft.com/office/drawing/2014/main" id="{7272E91A-945F-424C-99BC-9071E63D1B3A}"/>
               </a:ext>
             </a:extLst>
           </p:cNvPr>
@@ -14513,7 +12425,7 @@
           <p:cNvPr id="4" name="">
             <a:extLst xmlns:a="http://schemas.openxmlformats.org/drawingml/2006/main">
               <a:ext uri="{FF2B5EF4-FFF2-40B4-BE49-F238E27FC236}">
-                <a16:creationId xmlns:a16="http://schemas.microsoft.com/office/drawing/2014/main" id="{A32BC814-4350-48F4-810A-699ABB5A9DF0}"/>
+                <a16:creationId xmlns:a16="http://schemas.microsoft.com/office/drawing/2014/main" id="{CEF06E76-5AE5-4258-85AE-07AC0A9A1FA2}"/>
               </a:ext>
             </a:extLst>
           </p:cNvPr>
@@ -14669,7 +12581,7 @@
           <p:cNvPr id="5" name="">
             <a:extLst xmlns:a="http://schemas.openxmlformats.org/drawingml/2006/main">
               <a:ext uri="{FF2B5EF4-FFF2-40B4-BE49-F238E27FC236}">
-                <a16:creationId xmlns:a16="http://schemas.microsoft.com/office/drawing/2014/main" id="{CF62F694-1118-4956-BE74-BF417E28F67E}"/>
+                <a16:creationId xmlns:a16="http://schemas.microsoft.com/office/drawing/2014/main" id="{E29DAD78-70B6-4B65-8F61-F1E6AE41CE4E}"/>
               </a:ext>
             </a:extLst>
           </p:cNvPr>
@@ -14825,7 +12737,7 @@
           <p:cNvPr id="6" name="">
             <a:extLst xmlns:a="http://schemas.openxmlformats.org/drawingml/2006/main">
               <a:ext uri="{FF2B5EF4-FFF2-40B4-BE49-F238E27FC236}">
-                <a16:creationId xmlns:a16="http://schemas.microsoft.com/office/drawing/2014/main" id="{D678285B-E490-497B-B335-F8B90D843D1F}"/>
+                <a16:creationId xmlns:a16="http://schemas.microsoft.com/office/drawing/2014/main" id="{B520757F-D094-4E71-B3BA-4DAEC0A120C6}"/>
               </a:ext>
             </a:extLst>
           </p:cNvPr>
@@ -14835,7 +12747,7 @@
           <p:nvPr/>
         </p:nvPicPr>
         <p:blipFill>
-          <a:blip xmlns:r="http://schemas.openxmlformats.org/officeDocument/2006/relationships" xmlns:a="http://schemas.openxmlformats.org/drawingml/2006/main" r:embed="Ra0a7fc661c514954"/>
+          <a:blip xmlns:r="http://schemas.openxmlformats.org/officeDocument/2006/relationships" xmlns:a="http://schemas.openxmlformats.org/drawingml/2006/main" r:embed="R914ba2b806fd4b44"/>
           <a:stretch xmlns:a="http://schemas.openxmlformats.org/drawingml/2006/main"/>
         </p:blipFill>
         <p:spPr>
@@ -14853,7 +12765,7 @@
           <p:cNvPr id="7" name="">
             <a:extLst xmlns:a="http://schemas.openxmlformats.org/drawingml/2006/main">
               <a:ext uri="{FF2B5EF4-FFF2-40B4-BE49-F238E27FC236}">
-                <a16:creationId xmlns:a16="http://schemas.microsoft.com/office/drawing/2014/main" id="{5D632D07-DF22-4CC5-B086-9F85FFA41F41}"/>
+                <a16:creationId xmlns:a16="http://schemas.microsoft.com/office/drawing/2014/main" id="{3847D3EE-BB5A-4A0C-B5C9-A0FF77AE673C}"/>
               </a:ext>
             </a:extLst>
           </p:cNvPr>
@@ -14999,7 +12911,7 @@
                 <a:ea typeface="Helvetica Neue"/>
                 <a:cs typeface="Helvetica Neue"/>
               </a:rPr>
-              <a:t>7-pixel cells give 324 values. 4-pixel cells give 1,296</a:t>
+              <a:t>7-pixel cells and 2 × 2-cell blocks give 324 values</a:t>
             </a:r>
           </a:p>
         </p:txBody>
@@ -15007,7 +12919,7 @@
     </p:spTree>
     <p:extLst>
       <p:ext uri="{BB962C8B-B14F-4D97-AF65-F5344CB8AC3E}">
-        <p14:creationId xmlns:p14="http://schemas.microsoft.com/office/powerpoint/2010/main" val="1456076394"/>
+        <p14:creationId xmlns:p14="http://schemas.microsoft.com/office/powerpoint/2010/main" val="2052028754"/>
       </p:ext>
     </p:extLst>
   </p:cSld>
@@ -15038,7 +12950,7 @@
           <p:cNvPr id="6" name="">
             <a:extLst xmlns:a="http://schemas.openxmlformats.org/drawingml/2006/main">
               <a:ext uri="{FF2B5EF4-FFF2-40B4-BE49-F238E27FC236}">
-                <a16:creationId xmlns:a16="http://schemas.microsoft.com/office/drawing/2014/main" id="{D512F2D8-D3CC-4B5A-9D68-F234DE84D8FF}"/>
+                <a16:creationId xmlns:a16="http://schemas.microsoft.com/office/drawing/2014/main" id="{70E9C373-939C-4075-B28D-3139978C26F7}"/>
               </a:ext>
             </a:extLst>
           </p:cNvPr>
@@ -15194,7 +13106,7 @@
           <p:cNvPr id="2" name="">
             <a:extLst xmlns:a="http://schemas.openxmlformats.org/drawingml/2006/main">
               <a:ext uri="{FF2B5EF4-FFF2-40B4-BE49-F238E27FC236}">
-                <a16:creationId xmlns:a16="http://schemas.microsoft.com/office/drawing/2014/main" id="{E623AB23-A74F-4BC2-9E20-EDFA8D01DA70}"/>
+                <a16:creationId xmlns:a16="http://schemas.microsoft.com/office/drawing/2014/main" id="{0F46B52E-7760-408F-8403-DAA11CAEC962}"/>
               </a:ext>
             </a:extLst>
           </p:cNvPr>
@@ -15350,7 +13262,7 @@
           <p:cNvPr id="3" name="">
             <a:extLst xmlns:a="http://schemas.openxmlformats.org/drawingml/2006/main">
               <a:ext uri="{FF2B5EF4-FFF2-40B4-BE49-F238E27FC236}">
-                <a16:creationId xmlns:a16="http://schemas.microsoft.com/office/drawing/2014/main" id="{A518BD55-A773-4608-8F5D-21A3DC3524CE}"/>
+                <a16:creationId xmlns:a16="http://schemas.microsoft.com/office/drawing/2014/main" id="{136BCB61-B3B0-4458-8DB1-D3FBB9E14439}"/>
               </a:ext>
             </a:extLst>
           </p:cNvPr>
@@ -15506,7 +13418,7 @@
           <p:cNvPr id="4" name="">
             <a:extLst xmlns:a="http://schemas.openxmlformats.org/drawingml/2006/main">
               <a:ext uri="{FF2B5EF4-FFF2-40B4-BE49-F238E27FC236}">
-                <a16:creationId xmlns:a16="http://schemas.microsoft.com/office/drawing/2014/main" id="{AB2E2DD3-413D-4D5F-89D9-9260FEEDA320}"/>
+                <a16:creationId xmlns:a16="http://schemas.microsoft.com/office/drawing/2014/main" id="{9D5B65B8-6169-4652-9911-BB99C2EC51D8}"/>
               </a:ext>
             </a:extLst>
           </p:cNvPr>
@@ -15905,7 +13817,7 @@
           <p:cNvPr id="5" name="">
             <a:extLst xmlns:a="http://schemas.openxmlformats.org/drawingml/2006/main">
               <a:ext uri="{FF2B5EF4-FFF2-40B4-BE49-F238E27FC236}">
-                <a16:creationId xmlns:a16="http://schemas.microsoft.com/office/drawing/2014/main" id="{036BFDC5-55C7-421C-BBCA-3C0F373CAE2B}"/>
+                <a16:creationId xmlns:a16="http://schemas.microsoft.com/office/drawing/2014/main" id="{069567F3-44A5-4BF0-89F3-24388E843246}"/>
               </a:ext>
             </a:extLst>
           </p:cNvPr>
@@ -16051,7 +13963,7 @@
                 <a:ea typeface="Helvetica Neue"/>
                 <a:cs typeface="Helvetica Neue"/>
               </a:rPr>
-              <a:t>Each classifier is fitted on pixels and coarse HOG</a:t>
+              <a:t>Each classifier is fitted on pixels and HOG</a:t>
             </a:r>
           </a:p>
         </p:txBody>
@@ -16059,7 +13971,7 @@
     </p:spTree>
     <p:extLst>
       <p:ext uri="{BB962C8B-B14F-4D97-AF65-F5344CB8AC3E}">
-        <p14:creationId xmlns:p14="http://schemas.microsoft.com/office/powerpoint/2010/main" val="662884874"/>
+        <p14:creationId xmlns:p14="http://schemas.microsoft.com/office/powerpoint/2010/main" val="1972585445"/>
       </p:ext>
     </p:extLst>
   </p:cSld>
@@ -16090,7 +14002,7 @@
           <p:cNvPr id="8" name="">
             <a:extLst xmlns:a="http://schemas.openxmlformats.org/drawingml/2006/main">
               <a:ext uri="{FF2B5EF4-FFF2-40B4-BE49-F238E27FC236}">
-                <a16:creationId xmlns:a16="http://schemas.microsoft.com/office/drawing/2014/main" id="{6B7F5A61-3BD1-491F-A0AA-C5C4FDF96F47}"/>
+                <a16:creationId xmlns:a16="http://schemas.microsoft.com/office/drawing/2014/main" id="{CC057B24-C308-4553-A9B2-A99F13EAEAE1}"/>
               </a:ext>
             </a:extLst>
           </p:cNvPr>
@@ -16236,7 +14148,7 @@
                 <a:ea typeface="Helvetica Neue"/>
                 <a:cs typeface="Helvetica Neue"/>
               </a:rPr>
-              <a:t>Model selection and RBF experiments</a:t>
+              <a:t>Choose settings before testing</a:t>
             </a:r>
           </a:p>
         </p:txBody>
@@ -16246,7 +14158,7 @@
           <p:cNvPr id="2" name="">
             <a:extLst xmlns:a="http://schemas.openxmlformats.org/drawingml/2006/main">
               <a:ext uri="{FF2B5EF4-FFF2-40B4-BE49-F238E27FC236}">
-                <a16:creationId xmlns:a16="http://schemas.microsoft.com/office/drawing/2014/main" id="{65E0F7CE-1F18-40F1-80C3-5B343F66549A}"/>
+                <a16:creationId xmlns:a16="http://schemas.microsoft.com/office/drawing/2014/main" id="{C67960E9-5985-4BE4-89E5-770A5718F5F6}"/>
               </a:ext>
             </a:extLst>
           </p:cNvPr>
@@ -16402,7 +14314,7 @@
           <p:cNvPr id="3" name="">
             <a:extLst xmlns:a="http://schemas.openxmlformats.org/drawingml/2006/main">
               <a:ext uri="{FF2B5EF4-FFF2-40B4-BE49-F238E27FC236}">
-                <a16:creationId xmlns:a16="http://schemas.microsoft.com/office/drawing/2014/main" id="{F634533F-F266-471C-9AE1-66D9ED8B5150}"/>
+                <a16:creationId xmlns:a16="http://schemas.microsoft.com/office/drawing/2014/main" id="{BC1FF250-ADE7-43A5-94A1-8BB1AE4270D1}"/>
               </a:ext>
             </a:extLst>
           </p:cNvPr>
@@ -16558,7 +14470,7 @@
           <p:cNvPr id="4" name="">
             <a:extLst xmlns:a="http://schemas.openxmlformats.org/drawingml/2006/main">
               <a:ext uri="{FF2B5EF4-FFF2-40B4-BE49-F238E27FC236}">
-                <a16:creationId xmlns:a16="http://schemas.microsoft.com/office/drawing/2014/main" id="{C55DDD08-97D8-437F-BEA6-C9EE44779925}"/>
+                <a16:creationId xmlns:a16="http://schemas.microsoft.com/office/drawing/2014/main" id="{2001AD1E-B0A4-41F8-92F6-E7FB9D30FEFD}"/>
               </a:ext>
             </a:extLst>
           </p:cNvPr>
@@ -16704,7 +14616,7 @@
                 <a:ea typeface="Helvetica Neue"/>
                 <a:cs typeface="Helvetica Neue"/>
               </a:rPr>
-              <a:t>Reject candidates with convergence warnings</a:t>
+              <a:t>Train each combination on the same 48,000 images</a:t>
             </a:r>
           </a:p>
         </p:txBody>
@@ -16714,7 +14626,7 @@
           <p:cNvPr id="5" name="">
             <a:extLst xmlns:a="http://schemas.openxmlformats.org/drawingml/2006/main">
               <a:ext uri="{FF2B5EF4-FFF2-40B4-BE49-F238E27FC236}">
-                <a16:creationId xmlns:a16="http://schemas.microsoft.com/office/drawing/2014/main" id="{9904517A-206A-4C87-86D5-CB8AB8014818}"/>
+                <a16:creationId xmlns:a16="http://schemas.microsoft.com/office/drawing/2014/main" id="{408D069B-FE83-4B43-93BD-FD850CA9848B}"/>
               </a:ext>
             </a:extLst>
           </p:cNvPr>
@@ -16860,7 +14772,7 @@
                 <a:ea typeface="Helvetica Neue"/>
                 <a:cs typeface="Helvetica Neue"/>
               </a:rPr>
-              <a:t>Choose by validation macro F1, using accuracy to break ties</a:t>
+              <a:t>Choose settings using the 12,000 validation images</a:t>
             </a:r>
           </a:p>
         </p:txBody>
@@ -16870,7 +14782,7 @@
           <p:cNvPr id="6" name="">
             <a:extLst xmlns:a="http://schemas.openxmlformats.org/drawingml/2006/main">
               <a:ext uri="{FF2B5EF4-FFF2-40B4-BE49-F238E27FC236}">
-                <a16:creationId xmlns:a16="http://schemas.microsoft.com/office/drawing/2014/main" id="{D2DFD852-067F-48BC-B477-8EF52213FCE2}"/>
+                <a16:creationId xmlns:a16="http://schemas.microsoft.com/office/drawing/2014/main" id="{0A1B0092-1294-4F83-AFF6-6AE8CD8AAFC7}"/>
               </a:ext>
             </a:extLst>
           </p:cNvPr>
@@ -17016,7 +14928,7 @@
                 <a:ea typeface="Helvetica Neue"/>
                 <a:cs typeface="Helvetica Neue"/>
               </a:rPr>
-              <a:t>RBF SVM runs on pixels, coarse HOG and fine HOG</a:t>
+              <a:t>Save the chosen models and their checksums</a:t>
             </a:r>
           </a:p>
         </p:txBody>
@@ -17026,7 +14938,7 @@
           <p:cNvPr id="7" name="">
             <a:extLst xmlns:a="http://schemas.openxmlformats.org/drawingml/2006/main">
               <a:ext uri="{FF2B5EF4-FFF2-40B4-BE49-F238E27FC236}">
-                <a16:creationId xmlns:a16="http://schemas.microsoft.com/office/drawing/2014/main" id="{740154DE-41CE-427E-84C1-66BB6C5C7B8B}"/>
+                <a16:creationId xmlns:a16="http://schemas.microsoft.com/office/drawing/2014/main" id="{354D53EA-DBE5-4FB9-8098-08C29F9010ED}"/>
               </a:ext>
             </a:extLst>
           </p:cNvPr>
@@ -17172,7 +15084,7 @@
                 <a:ea typeface="Helvetica Neue"/>
                 <a:cs typeface="Helvetica Neue"/>
               </a:rPr>
-              <a:t>Save model choices and hashes before test evaluation</a:t>
+              <a:t>Evaluate once on the official 10,000 test images</a:t>
             </a:r>
           </a:p>
         </p:txBody>
@@ -17180,7 +15092,7 @@
     </p:spTree>
     <p:extLst>
       <p:ext uri="{BB962C8B-B14F-4D97-AF65-F5344CB8AC3E}">
-        <p14:creationId xmlns:p14="http://schemas.microsoft.com/office/powerpoint/2010/main" val="1379847238"/>
+        <p14:creationId xmlns:p14="http://schemas.microsoft.com/office/powerpoint/2010/main" val="470345767"/>
       </p:ext>
     </p:extLst>
   </p:cSld>
@@ -17211,7 +15123,7 @@
           <p:cNvPr id="5" name="">
             <a:extLst xmlns:a="http://schemas.openxmlformats.org/drawingml/2006/main">
               <a:ext uri="{FF2B5EF4-FFF2-40B4-BE49-F238E27FC236}">
-                <a16:creationId xmlns:a16="http://schemas.microsoft.com/office/drawing/2014/main" id="{5DCCC113-F271-4BD5-84E1-EAC28CB827D1}"/>
+                <a16:creationId xmlns:a16="http://schemas.microsoft.com/office/drawing/2014/main" id="{6A5945F6-4656-4CEB-8197-778847247B99}"/>
               </a:ext>
             </a:extLst>
           </p:cNvPr>
@@ -17367,7 +15279,7 @@
           <p:cNvPr id="2" name="">
             <a:extLst xmlns:a="http://schemas.openxmlformats.org/drawingml/2006/main">
               <a:ext uri="{FF2B5EF4-FFF2-40B4-BE49-F238E27FC236}">
-                <a16:creationId xmlns:a16="http://schemas.microsoft.com/office/drawing/2014/main" id="{9C4846A7-28F3-441B-B5AE-3496B272E0CF}"/>
+                <a16:creationId xmlns:a16="http://schemas.microsoft.com/office/drawing/2014/main" id="{EFFEF223-4A5C-49D7-9BFF-9E6E2621DA66}"/>
               </a:ext>
             </a:extLst>
           </p:cNvPr>
@@ -17523,7 +15435,7 @@
           <p:cNvPr id="3" name="">
             <a:extLst xmlns:a="http://schemas.openxmlformats.org/drawingml/2006/main">
               <a:ext uri="{FF2B5EF4-FFF2-40B4-BE49-F238E27FC236}">
-                <a16:creationId xmlns:a16="http://schemas.microsoft.com/office/drawing/2014/main" id="{78324756-B46B-4CD6-B269-EBE288731C8F}"/>
+                <a16:creationId xmlns:a16="http://schemas.microsoft.com/office/drawing/2014/main" id="{6CBF856E-224F-49D7-97E1-F53CB566EC35}"/>
               </a:ext>
             </a:extLst>
           </p:cNvPr>
@@ -17679,7 +15591,7 @@
           <p:cNvPr id="4" name="">
             <a:extLst xmlns:a="http://schemas.openxmlformats.org/drawingml/2006/main">
               <a:ext uri="{FF2B5EF4-FFF2-40B4-BE49-F238E27FC236}">
-                <a16:creationId xmlns:a16="http://schemas.microsoft.com/office/drawing/2014/main" id="{5683ACF2-6FF9-43F8-8EAE-EF2FD368CF04}"/>
+                <a16:creationId xmlns:a16="http://schemas.microsoft.com/office/drawing/2014/main" id="{C3683CE6-04F5-4E6E-9EF9-D47A755F23D0}"/>
               </a:ext>
             </a:extLst>
           </p:cNvPr>
@@ -18372,7 +16284,7 @@
     </p:spTree>
     <p:extLst>
       <p:ext uri="{BB962C8B-B14F-4D97-AF65-F5344CB8AC3E}">
-        <p14:creationId xmlns:p14="http://schemas.microsoft.com/office/powerpoint/2010/main" val="1311718774"/>
+        <p14:creationId xmlns:p14="http://schemas.microsoft.com/office/powerpoint/2010/main" val="1660353046"/>
       </p:ext>
     </p:extLst>
   </p:cSld>
@@ -18400,10 +16312,10 @@
       </p:grpSpPr>
       <p:sp>
         <p:nvSpPr>
-          <p:cNvPr id="9" name="">
+          <p:cNvPr id="8" name="">
             <a:extLst xmlns:a="http://schemas.openxmlformats.org/drawingml/2006/main">
               <a:ext uri="{FF2B5EF4-FFF2-40B4-BE49-F238E27FC236}">
-                <a16:creationId xmlns:a16="http://schemas.microsoft.com/office/drawing/2014/main" id="{1A7608EC-5B8E-4C4C-906D-E786AEBB780B}"/>
+                <a16:creationId xmlns:a16="http://schemas.microsoft.com/office/drawing/2014/main" id="{47ECFEE7-97C7-451F-B533-6C393A652498}"/>
               </a:ext>
             </a:extLst>
           </p:cNvPr>
@@ -18549,7 +16461,7 @@
                 <a:ea typeface="Helvetica Neue"/>
                 <a:cs typeface="Helvetica Neue"/>
               </a:rPr>
-              <a:t>Selected model and test performance</a:t>
+              <a:t>Selected model: Pixels + Random Forest</a:t>
             </a:r>
           </a:p>
         </p:txBody>
@@ -18559,7 +16471,7 @@
           <p:cNvPr id="2" name="">
             <a:extLst xmlns:a="http://schemas.openxmlformats.org/drawingml/2006/main">
               <a:ext uri="{FF2B5EF4-FFF2-40B4-BE49-F238E27FC236}">
-                <a16:creationId xmlns:a16="http://schemas.microsoft.com/office/drawing/2014/main" id="{001A0B40-F375-40A3-8AEB-6DC844A4DC6B}"/>
+                <a16:creationId xmlns:a16="http://schemas.microsoft.com/office/drawing/2014/main" id="{607FED1F-D8D5-4025-A3E6-98C0E4258CD9}"/>
               </a:ext>
             </a:extLst>
           </p:cNvPr>
@@ -18715,7 +16627,7 @@
           <p:cNvPr id="3" name="">
             <a:extLst xmlns:a="http://schemas.openxmlformats.org/drawingml/2006/main">
               <a:ext uri="{FF2B5EF4-FFF2-40B4-BE49-F238E27FC236}">
-                <a16:creationId xmlns:a16="http://schemas.microsoft.com/office/drawing/2014/main" id="{B72D4387-E3BB-4094-8205-B34ED531D9D5}"/>
+                <a16:creationId xmlns:a16="http://schemas.microsoft.com/office/drawing/2014/main" id="{5E38C751-E1DE-43F1-89D2-E8027175D4F2}"/>
               </a:ext>
             </a:extLst>
           </p:cNvPr>
@@ -18866,12 +16778,40 @@
           </a:p>
         </p:txBody>
       </p:sp>
-      <p:sp>
-        <p:nvSpPr>
+      <p:pic>
+        <p:nvPicPr>
           <p:cNvPr id="4" name="">
             <a:extLst xmlns:a="http://schemas.openxmlformats.org/drawingml/2006/main">
               <a:ext uri="{FF2B5EF4-FFF2-40B4-BE49-F238E27FC236}">
-                <a16:creationId xmlns:a16="http://schemas.microsoft.com/office/drawing/2014/main" id="{526BDE83-AD71-44D0-AACD-8A94077E9C9A}"/>
+                <a16:creationId xmlns:a16="http://schemas.microsoft.com/office/drawing/2014/main" id="{36A3F537-2A81-4EA5-A743-BC424EFC5FFB}"/>
+              </a:ext>
+            </a:extLst>
+          </p:cNvPr>
+          <p:cNvPicPr>
+            <a:picLocks xmlns:a="http://schemas.openxmlformats.org/drawingml/2006/main" noChangeAspect="1"/>
+          </p:cNvPicPr>
+          <p:nvPr/>
+        </p:nvPicPr>
+        <p:blipFill>
+          <a:blip xmlns:r="http://schemas.openxmlformats.org/officeDocument/2006/relationships" xmlns:a="http://schemas.openxmlformats.org/drawingml/2006/main" r:embed="R3e1ca2b326bf481e"/>
+          <a:stretch xmlns:a="http://schemas.openxmlformats.org/drawingml/2006/main"/>
+        </p:blipFill>
+        <p:spPr>
+          <a:xfrm xmlns:a="http://schemas.openxmlformats.org/drawingml/2006/main">
+            <a:off x="1537891" y="1381125"/>
+            <a:ext cx="5115719" cy="4619625"/>
+          </a:xfrm>
+          <a:prstGeom xmlns:a="http://schemas.openxmlformats.org/drawingml/2006/main" prst="rect">
+            <a:avLst/>
+          </a:prstGeom>
+        </p:spPr>
+      </p:pic>
+      <p:sp>
+        <p:nvSpPr>
+          <p:cNvPr id="5" name="">
+            <a:extLst xmlns:a="http://schemas.openxmlformats.org/drawingml/2006/main">
+              <a:ext uri="{FF2B5EF4-FFF2-40B4-BE49-F238E27FC236}">
+                <a16:creationId xmlns:a16="http://schemas.microsoft.com/office/drawing/2014/main" id="{F4BA9ED0-0370-4F7F-B961-60A8FDD2A040}"/>
               </a:ext>
             </a:extLst>
           </p:cNvPr>
@@ -18882,8 +16822,8 @@
         </p:nvSpPr>
         <p:spPr>
           <a:xfrm xmlns:a="http://schemas.openxmlformats.org/drawingml/2006/main">
-            <a:off x="714375" y="1428750"/>
-            <a:ext cx="10668000" cy="714375"/>
+            <a:off x="7858125" y="2095500"/>
+            <a:ext cx="3619500" cy="809625"/>
           </a:xfrm>
           <a:prstGeom xmlns:a="http://schemas.openxmlformats.org/drawingml/2006/main" prst="rect">
             <a:avLst/>
@@ -19017,17 +16957,17 @@
                 <a:ea typeface="Helvetica Neue"/>
                 <a:cs typeface="Helvetica Neue"/>
               </a:rPr>
-              <a:t>Fine HOG + RBF SVM</a:t>
+              <a:t>87.61% accuracy</a:t>
             </a:r>
           </a:p>
         </p:txBody>
       </p:sp>
       <p:sp>
         <p:nvSpPr>
-          <p:cNvPr id="5" name="">
+          <p:cNvPr id="6" name="">
             <a:extLst xmlns:a="http://schemas.openxmlformats.org/drawingml/2006/main">
               <a:ext uri="{FF2B5EF4-FFF2-40B4-BE49-F238E27FC236}">
-                <a16:creationId xmlns:a16="http://schemas.microsoft.com/office/drawing/2014/main" id="{8E0FD384-DB83-48ED-81E4-926A77028B7A}"/>
+                <a16:creationId xmlns:a16="http://schemas.microsoft.com/office/drawing/2014/main" id="{B7215643-0533-478D-9C6B-CD3E873DFEF7}"/>
               </a:ext>
             </a:extLst>
           </p:cNvPr>
@@ -19038,8 +16978,8 @@
         </p:nvSpPr>
         <p:spPr>
           <a:xfrm xmlns:a="http://schemas.openxmlformats.org/drawingml/2006/main">
-            <a:off x="714375" y="2381250"/>
-            <a:ext cx="10668000" cy="857250"/>
+            <a:off x="7858125" y="3238500"/>
+            <a:ext cx="3619500" cy="619125"/>
           </a:xfrm>
           <a:prstGeom xmlns:a="http://schemas.openxmlformats.org/drawingml/2006/main" prst="rect">
             <a:avLst/>
@@ -19053,9 +16993,9 @@
           <a:bodyPr xmlns:a="http://schemas.openxmlformats.org/drawingml/2006/main"/>
           <a:lstStyle xmlns:a="http://schemas.openxmlformats.org/drawingml/2006/main">
             <a:defPPr>
-              <a:defRPr sz="4650" b="1">
-                <a:solidFill>
-                  <a:srgbClr val="102B3B"/>
+              <a:defRPr sz="2400" b="0">
+                <a:solidFill>
+                  <a:srgbClr val="20333F"/>
                 </a:solidFill>
                 <a:latin typeface="Helvetica Neue"/>
                 <a:ea typeface="Helvetica Neue"/>
@@ -19063,9 +17003,9 @@
               </a:defRPr>
             </a:defPPr>
             <a:lvl1pPr>
-              <a:defRPr sz="4650" b="1">
-                <a:solidFill>
-                  <a:srgbClr val="102B3B"/>
+              <a:defRPr sz="2400" b="0">
+                <a:solidFill>
+                  <a:srgbClr val="20333F"/>
                 </a:solidFill>
                 <a:latin typeface="Helvetica Neue"/>
                 <a:ea typeface="Helvetica Neue"/>
@@ -19073,9 +17013,9 @@
               </a:defRPr>
             </a:lvl1pPr>
             <a:lvl2pPr>
-              <a:defRPr sz="4650" b="1">
-                <a:solidFill>
-                  <a:srgbClr val="102B3B"/>
+              <a:defRPr sz="2400" b="0">
+                <a:solidFill>
+                  <a:srgbClr val="20333F"/>
                 </a:solidFill>
                 <a:latin typeface="Helvetica Neue"/>
                 <a:ea typeface="Helvetica Neue"/>
@@ -19083,9 +17023,9 @@
               </a:defRPr>
             </a:lvl2pPr>
             <a:lvl3pPr>
-              <a:defRPr sz="4650" b="1">
-                <a:solidFill>
-                  <a:srgbClr val="102B3B"/>
+              <a:defRPr sz="2400" b="0">
+                <a:solidFill>
+                  <a:srgbClr val="20333F"/>
                 </a:solidFill>
                 <a:latin typeface="Helvetica Neue"/>
                 <a:ea typeface="Helvetica Neue"/>
@@ -19093,9 +17033,9 @@
               </a:defRPr>
             </a:lvl3pPr>
             <a:lvl4pPr>
-              <a:defRPr sz="4650" b="1">
-                <a:solidFill>
-                  <a:srgbClr val="102B3B"/>
+              <a:defRPr sz="2400" b="0">
+                <a:solidFill>
+                  <a:srgbClr val="20333F"/>
                 </a:solidFill>
                 <a:latin typeface="Helvetica Neue"/>
                 <a:ea typeface="Helvetica Neue"/>
@@ -19103,9 +17043,9 @@
               </a:defRPr>
             </a:lvl4pPr>
             <a:lvl5pPr>
-              <a:defRPr sz="4650" b="1">
-                <a:solidFill>
-                  <a:srgbClr val="102B3B"/>
+              <a:defRPr sz="2400" b="0">
+                <a:solidFill>
+                  <a:srgbClr val="20333F"/>
                 </a:solidFill>
                 <a:latin typeface="Helvetica Neue"/>
                 <a:ea typeface="Helvetica Neue"/>
@@ -19113,9 +17053,9 @@
               </a:defRPr>
             </a:lvl5pPr>
             <a:lvl6pPr>
-              <a:defRPr sz="4650" b="1">
-                <a:solidFill>
-                  <a:srgbClr val="102B3B"/>
+              <a:defRPr sz="2400" b="0">
+                <a:solidFill>
+                  <a:srgbClr val="20333F"/>
                 </a:solidFill>
                 <a:latin typeface="Helvetica Neue"/>
                 <a:ea typeface="Helvetica Neue"/>
@@ -19123,9 +17063,9 @@
               </a:defRPr>
             </a:lvl6pPr>
             <a:lvl7pPr>
-              <a:defRPr sz="4650" b="1">
-                <a:solidFill>
-                  <a:srgbClr val="102B3B"/>
+              <a:defRPr sz="2400" b="0">
+                <a:solidFill>
+                  <a:srgbClr val="20333F"/>
                 </a:solidFill>
                 <a:latin typeface="Helvetica Neue"/>
                 <a:ea typeface="Helvetica Neue"/>
@@ -19133,9 +17073,9 @@
               </a:defRPr>
             </a:lvl7pPr>
             <a:lvl8pPr>
-              <a:defRPr sz="4650" b="1">
-                <a:solidFill>
-                  <a:srgbClr val="102B3B"/>
+              <a:defRPr sz="2400" b="0">
+                <a:solidFill>
+                  <a:srgbClr val="20333F"/>
                 </a:solidFill>
                 <a:latin typeface="Helvetica Neue"/>
                 <a:ea typeface="Helvetica Neue"/>
@@ -19143,9 +17083,9 @@
               </a:defRPr>
             </a:lvl8pPr>
             <a:lvl9pPr>
-              <a:defRPr sz="4650" b="1">
-                <a:solidFill>
-                  <a:srgbClr val="102B3B"/>
+              <a:defRPr sz="2400" b="0">
+                <a:solidFill>
+                  <a:srgbClr val="20333F"/>
                 </a:solidFill>
                 <a:latin typeface="Helvetica Neue"/>
                 <a:ea typeface="Helvetica Neue"/>
@@ -19155,9 +17095,9 @@
           </a:lstStyle>
           <a:p xmlns:a="http://schemas.openxmlformats.org/drawingml/2006/main">
             <a:pPr>
-              <a:defRPr sz="4650" b="1">
-                <a:solidFill>
-                  <a:srgbClr val="102B3B"/>
+              <a:defRPr sz="2400" b="0">
+                <a:solidFill>
+                  <a:srgbClr val="20333F"/>
                 </a:solidFill>
                 <a:latin typeface="Helvetica Neue"/>
                 <a:ea typeface="Helvetica Neue"/>
@@ -19165,25 +17105,25 @@
               </a:defRPr>
             </a:pPr>
             <a:r>
-              <a:rPr sz="4650" b="1">
-                <a:solidFill>
-                  <a:srgbClr val="102B3B"/>
+              <a:rPr sz="2400" b="0">
+                <a:solidFill>
+                  <a:srgbClr val="20333F"/>
                 </a:solidFill>
                 <a:latin typeface="Helvetica Neue"/>
                 <a:ea typeface="Helvetica Neue"/>
                 <a:cs typeface="Helvetica Neue"/>
               </a:rPr>
-              <a:t>90.87% test accuracy</a:t>
+              <a:t>0.8747 macro F1</a:t>
             </a:r>
           </a:p>
         </p:txBody>
       </p:sp>
       <p:sp>
         <p:nvSpPr>
-          <p:cNvPr id="6" name="">
+          <p:cNvPr id="7" name="">
             <a:extLst xmlns:a="http://schemas.openxmlformats.org/drawingml/2006/main">
               <a:ext uri="{FF2B5EF4-FFF2-40B4-BE49-F238E27FC236}">
-                <a16:creationId xmlns:a16="http://schemas.microsoft.com/office/drawing/2014/main" id="{E6C5426D-1C8D-4116-AB76-7A0275B85A6E}"/>
+                <a16:creationId xmlns:a16="http://schemas.microsoft.com/office/drawing/2014/main" id="{3D63AB9B-9723-4626-9AF7-9654588010E3}"/>
               </a:ext>
             </a:extLst>
           </p:cNvPr>
@@ -19194,8 +17134,8 @@
         </p:nvSpPr>
         <p:spPr>
           <a:xfrm xmlns:a="http://schemas.openxmlformats.org/drawingml/2006/main">
-            <a:off x="714375" y="3476625"/>
-            <a:ext cx="10668000" cy="619125"/>
+            <a:off x="7858125" y="4429125"/>
+            <a:ext cx="3619500" cy="809625"/>
           </a:xfrm>
           <a:prstGeom xmlns:a="http://schemas.openxmlformats.org/drawingml/2006/main" prst="rect">
             <a:avLst/>
@@ -19209,7 +17149,7 @@
           <a:bodyPr xmlns:a="http://schemas.openxmlformats.org/drawingml/2006/main"/>
           <a:lstStyle xmlns:a="http://schemas.openxmlformats.org/drawingml/2006/main">
             <a:defPPr>
-              <a:defRPr sz="2775" b="0">
+              <a:defRPr sz="1950" b="0">
                 <a:solidFill>
                   <a:srgbClr val="20333F"/>
                 </a:solidFill>
@@ -19219,7 +17159,7 @@
               </a:defRPr>
             </a:defPPr>
             <a:lvl1pPr>
-              <a:defRPr sz="2775" b="0">
+              <a:defRPr sz="1950" b="0">
                 <a:solidFill>
                   <a:srgbClr val="20333F"/>
                 </a:solidFill>
@@ -19229,7 +17169,7 @@
               </a:defRPr>
             </a:lvl1pPr>
             <a:lvl2pPr>
-              <a:defRPr sz="2775" b="0">
+              <a:defRPr sz="1950" b="0">
                 <a:solidFill>
                   <a:srgbClr val="20333F"/>
                 </a:solidFill>
@@ -19239,7 +17179,7 @@
               </a:defRPr>
             </a:lvl2pPr>
             <a:lvl3pPr>
-              <a:defRPr sz="2775" b="0">
+              <a:defRPr sz="1950" b="0">
                 <a:solidFill>
                   <a:srgbClr val="20333F"/>
                 </a:solidFill>
@@ -19249,7 +17189,7 @@
               </a:defRPr>
             </a:lvl3pPr>
             <a:lvl4pPr>
-              <a:defRPr sz="2775" b="0">
+              <a:defRPr sz="1950" b="0">
                 <a:solidFill>
                   <a:srgbClr val="20333F"/>
                 </a:solidFill>
@@ -19259,7 +17199,7 @@
               </a:defRPr>
             </a:lvl4pPr>
             <a:lvl5pPr>
-              <a:defRPr sz="2775" b="0">
+              <a:defRPr sz="1950" b="0">
                 <a:solidFill>
                   <a:srgbClr val="20333F"/>
                 </a:solidFill>
@@ -19269,7 +17209,7 @@
               </a:defRPr>
             </a:lvl5pPr>
             <a:lvl6pPr>
-              <a:defRPr sz="2775" b="0">
+              <a:defRPr sz="1950" b="0">
                 <a:solidFill>
                   <a:srgbClr val="20333F"/>
                 </a:solidFill>
@@ -19279,7 +17219,7 @@
               </a:defRPr>
             </a:lvl6pPr>
             <a:lvl7pPr>
-              <a:defRPr sz="2775" b="0">
+              <a:defRPr sz="1950" b="0">
                 <a:solidFill>
                   <a:srgbClr val="20333F"/>
                 </a:solidFill>
@@ -19289,7 +17229,7 @@
               </a:defRPr>
             </a:lvl7pPr>
             <a:lvl8pPr>
-              <a:defRPr sz="2775" b="0">
+              <a:defRPr sz="1950" b="0">
                 <a:solidFill>
                   <a:srgbClr val="20333F"/>
                 </a:solidFill>
@@ -19299,7 +17239,7 @@
               </a:defRPr>
             </a:lvl8pPr>
             <a:lvl9pPr>
-              <a:defRPr sz="2775" b="0">
+              <a:defRPr sz="1950" b="0">
                 <a:solidFill>
                   <a:srgbClr val="20333F"/>
                 </a:solidFill>
@@ -19311,7 +17251,7 @@
           </a:lstStyle>
           <a:p xmlns:a="http://schemas.openxmlformats.org/drawingml/2006/main">
             <a:pPr>
-              <a:defRPr sz="2775" b="0">
+              <a:defRPr sz="1950" b="0">
                 <a:solidFill>
                   <a:srgbClr val="20333F"/>
                 </a:solidFill>
@@ -19321,7 +17261,7 @@
               </a:defRPr>
             </a:pPr>
             <a:r>
-              <a:rPr sz="2775" b="0">
+              <a:rPr sz="1950" b="0">
                 <a:solidFill>
                   <a:srgbClr val="20333F"/>
                 </a:solidFill>
@@ -19329,319 +17269,7 @@
                 <a:ea typeface="Helvetica Neue"/>
                 <a:cs typeface="Helvetica Neue"/>
               </a:rPr>
-              <a:t>0.9084 macro F1</a:t>
-            </a:r>
-          </a:p>
-        </p:txBody>
-      </p:sp>
-      <p:sp>
-        <p:nvSpPr>
-          <p:cNvPr id="7" name="">
-            <a:extLst xmlns:a="http://schemas.openxmlformats.org/drawingml/2006/main">
-              <a:ext uri="{FF2B5EF4-FFF2-40B4-BE49-F238E27FC236}">
-                <a16:creationId xmlns:a16="http://schemas.microsoft.com/office/drawing/2014/main" id="{AB2CB973-7751-4FBF-9222-4D230B2A082E}"/>
-              </a:ext>
-            </a:extLst>
-          </p:cNvPr>
-          <p:cNvSpPr>
-            <a:spLocks xmlns:a="http://schemas.openxmlformats.org/drawingml/2006/main" noGrp="1"/>
-          </p:cNvSpPr>
-          <p:nvPr/>
-        </p:nvSpPr>
-        <p:spPr>
-          <a:xfrm xmlns:a="http://schemas.openxmlformats.org/drawingml/2006/main">
-            <a:off x="714375" y="4572000"/>
-            <a:ext cx="10668000" cy="571500"/>
-          </a:xfrm>
-          <a:prstGeom xmlns:a="http://schemas.openxmlformats.org/drawingml/2006/main" prst="rect">
-            <a:avLst/>
-          </a:prstGeom>
-          <a:noFill xmlns:a="http://schemas.openxmlformats.org/drawingml/2006/main"/>
-          <a:ln xmlns:a="http://schemas.openxmlformats.org/drawingml/2006/main" w="0">
-            <a:noFill/>
-          </a:ln>
-        </p:spPr>
-        <p:txBody>
-          <a:bodyPr xmlns:a="http://schemas.openxmlformats.org/drawingml/2006/main"/>
-          <a:lstStyle xmlns:a="http://schemas.openxmlformats.org/drawingml/2006/main">
-            <a:defPPr>
-              <a:defRPr sz="2250" b="0">
-                <a:solidFill>
-                  <a:srgbClr val="20333F"/>
-                </a:solidFill>
-                <a:latin typeface="Helvetica Neue"/>
-                <a:ea typeface="Helvetica Neue"/>
-                <a:cs typeface="Helvetica Neue"/>
-              </a:defRPr>
-            </a:defPPr>
-            <a:lvl1pPr>
-              <a:defRPr sz="2250" b="0">
-                <a:solidFill>
-                  <a:srgbClr val="20333F"/>
-                </a:solidFill>
-                <a:latin typeface="Helvetica Neue"/>
-                <a:ea typeface="Helvetica Neue"/>
-                <a:cs typeface="Helvetica Neue"/>
-              </a:defRPr>
-            </a:lvl1pPr>
-            <a:lvl2pPr>
-              <a:defRPr sz="2250" b="0">
-                <a:solidFill>
-                  <a:srgbClr val="20333F"/>
-                </a:solidFill>
-                <a:latin typeface="Helvetica Neue"/>
-                <a:ea typeface="Helvetica Neue"/>
-                <a:cs typeface="Helvetica Neue"/>
-              </a:defRPr>
-            </a:lvl2pPr>
-            <a:lvl3pPr>
-              <a:defRPr sz="2250" b="0">
-                <a:solidFill>
-                  <a:srgbClr val="20333F"/>
-                </a:solidFill>
-                <a:latin typeface="Helvetica Neue"/>
-                <a:ea typeface="Helvetica Neue"/>
-                <a:cs typeface="Helvetica Neue"/>
-              </a:defRPr>
-            </a:lvl3pPr>
-            <a:lvl4pPr>
-              <a:defRPr sz="2250" b="0">
-                <a:solidFill>
-                  <a:srgbClr val="20333F"/>
-                </a:solidFill>
-                <a:latin typeface="Helvetica Neue"/>
-                <a:ea typeface="Helvetica Neue"/>
-                <a:cs typeface="Helvetica Neue"/>
-              </a:defRPr>
-            </a:lvl4pPr>
-            <a:lvl5pPr>
-              <a:defRPr sz="2250" b="0">
-                <a:solidFill>
-                  <a:srgbClr val="20333F"/>
-                </a:solidFill>
-                <a:latin typeface="Helvetica Neue"/>
-                <a:ea typeface="Helvetica Neue"/>
-                <a:cs typeface="Helvetica Neue"/>
-              </a:defRPr>
-            </a:lvl5pPr>
-            <a:lvl6pPr>
-              <a:defRPr sz="2250" b="0">
-                <a:solidFill>
-                  <a:srgbClr val="20333F"/>
-                </a:solidFill>
-                <a:latin typeface="Helvetica Neue"/>
-                <a:ea typeface="Helvetica Neue"/>
-                <a:cs typeface="Helvetica Neue"/>
-              </a:defRPr>
-            </a:lvl6pPr>
-            <a:lvl7pPr>
-              <a:defRPr sz="2250" b="0">
-                <a:solidFill>
-                  <a:srgbClr val="20333F"/>
-                </a:solidFill>
-                <a:latin typeface="Helvetica Neue"/>
-                <a:ea typeface="Helvetica Neue"/>
-                <a:cs typeface="Helvetica Neue"/>
-              </a:defRPr>
-            </a:lvl7pPr>
-            <a:lvl8pPr>
-              <a:defRPr sz="2250" b="0">
-                <a:solidFill>
-                  <a:srgbClr val="20333F"/>
-                </a:solidFill>
-                <a:latin typeface="Helvetica Neue"/>
-                <a:ea typeface="Helvetica Neue"/>
-                <a:cs typeface="Helvetica Neue"/>
-              </a:defRPr>
-            </a:lvl8pPr>
-            <a:lvl9pPr>
-              <a:defRPr sz="2250" b="0">
-                <a:solidFill>
-                  <a:srgbClr val="20333F"/>
-                </a:solidFill>
-                <a:latin typeface="Helvetica Neue"/>
-                <a:ea typeface="Helvetica Neue"/>
-                <a:cs typeface="Helvetica Neue"/>
-              </a:defRPr>
-            </a:lvl9pPr>
-          </a:lstStyle>
-          <a:p xmlns:a="http://schemas.openxmlformats.org/drawingml/2006/main">
-            <a:pPr>
-              <a:defRPr sz="2250" b="0">
-                <a:solidFill>
-                  <a:srgbClr val="20333F"/>
-                </a:solidFill>
-                <a:latin typeface="Helvetica Neue"/>
-                <a:ea typeface="Helvetica Neue"/>
-                <a:cs typeface="Helvetica Neue"/>
-              </a:defRPr>
-            </a:pPr>
-            <a:r>
-              <a:rPr sz="2250" b="0">
-                <a:solidFill>
-                  <a:srgbClr val="20333F"/>
-                </a:solidFill>
-                <a:latin typeface="Helvetica Neue"/>
-                <a:ea typeface="Helvetica Neue"/>
-                <a:cs typeface="Helvetica Neue"/>
-              </a:rPr>
-              <a:t>All methods used the same 48,000 training images</a:t>
-            </a:r>
-          </a:p>
-        </p:txBody>
-      </p:sp>
-      <p:sp>
-        <p:nvSpPr>
-          <p:cNvPr id="8" name="">
-            <a:extLst xmlns:a="http://schemas.openxmlformats.org/drawingml/2006/main">
-              <a:ext uri="{FF2B5EF4-FFF2-40B4-BE49-F238E27FC236}">
-                <a16:creationId xmlns:a16="http://schemas.microsoft.com/office/drawing/2014/main" id="{CEEAFA04-B947-475D-9270-48B70120705F}"/>
-              </a:ext>
-            </a:extLst>
-          </p:cNvPr>
-          <p:cNvSpPr>
-            <a:spLocks xmlns:a="http://schemas.openxmlformats.org/drawingml/2006/main" noGrp="1"/>
-          </p:cNvSpPr>
-          <p:nvPr/>
-        </p:nvSpPr>
-        <p:spPr>
-          <a:xfrm xmlns:a="http://schemas.openxmlformats.org/drawingml/2006/main">
-            <a:off x="714375" y="5381625"/>
-            <a:ext cx="10668000" cy="523875"/>
-          </a:xfrm>
-          <a:prstGeom xmlns:a="http://schemas.openxmlformats.org/drawingml/2006/main" prst="rect">
-            <a:avLst/>
-          </a:prstGeom>
-          <a:noFill xmlns:a="http://schemas.openxmlformats.org/drawingml/2006/main"/>
-          <a:ln xmlns:a="http://schemas.openxmlformats.org/drawingml/2006/main" w="0">
-            <a:noFill/>
-          </a:ln>
-        </p:spPr>
-        <p:txBody>
-          <a:bodyPr xmlns:a="http://schemas.openxmlformats.org/drawingml/2006/main"/>
-          <a:lstStyle xmlns:a="http://schemas.openxmlformats.org/drawingml/2006/main">
-            <a:defPPr>
-              <a:defRPr sz="1875" b="0">
-                <a:solidFill>
-                  <a:srgbClr val="607582"/>
-                </a:solidFill>
-                <a:latin typeface="Helvetica Neue"/>
-                <a:ea typeface="Helvetica Neue"/>
-                <a:cs typeface="Helvetica Neue"/>
-              </a:defRPr>
-            </a:defPPr>
-            <a:lvl1pPr>
-              <a:defRPr sz="1875" b="0">
-                <a:solidFill>
-                  <a:srgbClr val="607582"/>
-                </a:solidFill>
-                <a:latin typeface="Helvetica Neue"/>
-                <a:ea typeface="Helvetica Neue"/>
-                <a:cs typeface="Helvetica Neue"/>
-              </a:defRPr>
-            </a:lvl1pPr>
-            <a:lvl2pPr>
-              <a:defRPr sz="1875" b="0">
-                <a:solidFill>
-                  <a:srgbClr val="607582"/>
-                </a:solidFill>
-                <a:latin typeface="Helvetica Neue"/>
-                <a:ea typeface="Helvetica Neue"/>
-                <a:cs typeface="Helvetica Neue"/>
-              </a:defRPr>
-            </a:lvl2pPr>
-            <a:lvl3pPr>
-              <a:defRPr sz="1875" b="0">
-                <a:solidFill>
-                  <a:srgbClr val="607582"/>
-                </a:solidFill>
-                <a:latin typeface="Helvetica Neue"/>
-                <a:ea typeface="Helvetica Neue"/>
-                <a:cs typeface="Helvetica Neue"/>
-              </a:defRPr>
-            </a:lvl3pPr>
-            <a:lvl4pPr>
-              <a:defRPr sz="1875" b="0">
-                <a:solidFill>
-                  <a:srgbClr val="607582"/>
-                </a:solidFill>
-                <a:latin typeface="Helvetica Neue"/>
-                <a:ea typeface="Helvetica Neue"/>
-                <a:cs typeface="Helvetica Neue"/>
-              </a:defRPr>
-            </a:lvl4pPr>
-            <a:lvl5pPr>
-              <a:defRPr sz="1875" b="0">
-                <a:solidFill>
-                  <a:srgbClr val="607582"/>
-                </a:solidFill>
-                <a:latin typeface="Helvetica Neue"/>
-                <a:ea typeface="Helvetica Neue"/>
-                <a:cs typeface="Helvetica Neue"/>
-              </a:defRPr>
-            </a:lvl5pPr>
-            <a:lvl6pPr>
-              <a:defRPr sz="1875" b="0">
-                <a:solidFill>
-                  <a:srgbClr val="607582"/>
-                </a:solidFill>
-                <a:latin typeface="Helvetica Neue"/>
-                <a:ea typeface="Helvetica Neue"/>
-                <a:cs typeface="Helvetica Neue"/>
-              </a:defRPr>
-            </a:lvl6pPr>
-            <a:lvl7pPr>
-              <a:defRPr sz="1875" b="0">
-                <a:solidFill>
-                  <a:srgbClr val="607582"/>
-                </a:solidFill>
-                <a:latin typeface="Helvetica Neue"/>
-                <a:ea typeface="Helvetica Neue"/>
-                <a:cs typeface="Helvetica Neue"/>
-              </a:defRPr>
-            </a:lvl7pPr>
-            <a:lvl8pPr>
-              <a:defRPr sz="1875" b="0">
-                <a:solidFill>
-                  <a:srgbClr val="607582"/>
-                </a:solidFill>
-                <a:latin typeface="Helvetica Neue"/>
-                <a:ea typeface="Helvetica Neue"/>
-                <a:cs typeface="Helvetica Neue"/>
-              </a:defRPr>
-            </a:lvl8pPr>
-            <a:lvl9pPr>
-              <a:defRPr sz="1875" b="0">
-                <a:solidFill>
-                  <a:srgbClr val="607582"/>
-                </a:solidFill>
-                <a:latin typeface="Helvetica Neue"/>
-                <a:ea typeface="Helvetica Neue"/>
-                <a:cs typeface="Helvetica Neue"/>
-              </a:defRPr>
-            </a:lvl9pPr>
-          </a:lstStyle>
-          <a:p xmlns:a="http://schemas.openxmlformats.org/drawingml/2006/main">
-            <a:pPr>
-              <a:defRPr sz="1875" b="0">
-                <a:solidFill>
-                  <a:srgbClr val="607582"/>
-                </a:solidFill>
-                <a:latin typeface="Helvetica Neue"/>
-                <a:ea typeface="Helvetica Neue"/>
-                <a:cs typeface="Helvetica Neue"/>
-              </a:defRPr>
-            </a:pPr>
-            <a:r>
-              <a:rPr sz="1875" b="0">
-                <a:solidFill>
-                  <a:srgbClr val="607582"/>
-                </a:solidFill>
-                <a:latin typeface="Helvetica Neue"/>
-                <a:ea typeface="Helvetica Neue"/>
-                <a:cs typeface="Helvetica Neue"/>
-              </a:rPr>
-              <a:t>The reference used 12,000 images. Training size and settings both changed</a:t>
+              <a:t>Chosen using validation data</a:t>
             </a:r>
           </a:p>
         </p:txBody>
@@ -19649,7 +17277,7 @@
     </p:spTree>
     <p:extLst>
       <p:ext uri="{BB962C8B-B14F-4D97-AF65-F5344CB8AC3E}">
-        <p14:creationId xmlns:p14="http://schemas.microsoft.com/office/powerpoint/2010/main" val="882768720"/>
+        <p14:creationId xmlns:p14="http://schemas.microsoft.com/office/powerpoint/2010/main" val="295278558"/>
       </p:ext>
     </p:extLst>
   </p:cSld>

</xml_diff>